<commit_message>
tiny updates and move to page adhustments
</commit_message>
<xml_diff>
--- a/Week04_IntegerArithmetic/Ch05_Integer Arithmetic_V4.pptx
+++ b/Week04_IntegerArithmetic/Ch05_Integer Arithmetic_V4.pptx
@@ -38,19 +38,19 @@
     <p:sldId id="378" r:id="rId26"/>
     <p:sldId id="358" r:id="rId27"/>
     <p:sldId id="362" r:id="rId28"/>
-    <p:sldId id="363" r:id="rId29"/>
-    <p:sldId id="364" r:id="rId30"/>
-    <p:sldId id="365" r:id="rId31"/>
-    <p:sldId id="379" r:id="rId32"/>
-    <p:sldId id="380" r:id="rId33"/>
-    <p:sldId id="368" r:id="rId34"/>
-    <p:sldId id="369" r:id="rId35"/>
-    <p:sldId id="370" r:id="rId36"/>
-    <p:sldId id="371" r:id="rId37"/>
-    <p:sldId id="372" r:id="rId38"/>
-    <p:sldId id="373" r:id="rId39"/>
-    <p:sldId id="336" r:id="rId40"/>
-    <p:sldId id="509" r:id="rId41"/>
+    <p:sldId id="509" r:id="rId29"/>
+    <p:sldId id="363" r:id="rId30"/>
+    <p:sldId id="364" r:id="rId31"/>
+    <p:sldId id="365" r:id="rId32"/>
+    <p:sldId id="379" r:id="rId33"/>
+    <p:sldId id="380" r:id="rId34"/>
+    <p:sldId id="368" r:id="rId35"/>
+    <p:sldId id="369" r:id="rId36"/>
+    <p:sldId id="370" r:id="rId37"/>
+    <p:sldId id="371" r:id="rId38"/>
+    <p:sldId id="372" r:id="rId39"/>
+    <p:sldId id="373" r:id="rId40"/>
+    <p:sldId id="336" r:id="rId41"/>
   </p:sldIdLst>
   <p:sldSz cx="12192000" cy="6858000"/>
   <p:notesSz cx="7010400" cy="9296400"/>
@@ -30714,8 +30714,8 @@
           </a:p>
         </p:txBody>
       </p:sp>
-      <mc:AlternateContent xmlns:mc="http://schemas.openxmlformats.org/markup-compatibility/2006">
-        <mc:Choice xmlns:a14="http://schemas.microsoft.com/office/drawing/2010/main" Requires="a14">
+      <mc:AlternateContent xmlns:mc="http://schemas.openxmlformats.org/markup-compatibility/2006" xmlns:a14="http://schemas.microsoft.com/office/drawing/2010/main">
+        <mc:Choice Requires="a14">
           <p:graphicFrame>
             <p:nvGraphicFramePr>
               <p:cNvPr id="3" name="Table 2"/>
@@ -31927,7 +31927,7 @@
             </a:graphic>
           </p:graphicFrame>
         </mc:Choice>
-        <mc:Fallback>
+        <mc:Fallback xmlns="">
           <p:graphicFrame>
             <p:nvGraphicFramePr>
               <p:cNvPr id="3" name="Table 2"/>
@@ -32619,6 +32619,70 @@
   <p:cSld>
     <p:spTree>
       <p:nvGrpSpPr>
+        <p:cNvPr id="1" name="">
+          <a:extLst>
+            <a:ext uri="{FF2B5EF4-FFF2-40B4-BE49-F238E27FC236}">
+              <a16:creationId xmlns:a16="http://schemas.microsoft.com/office/drawing/2014/main" id="{84DA25F2-3AE0-BDCF-0880-EDD5EEF55E54}"/>
+            </a:ext>
+          </a:extLst>
+        </p:cNvPr>
+        <p:cNvGrpSpPr/>
+        <p:nvPr/>
+      </p:nvGrpSpPr>
+      <p:grpSpPr>
+        <a:xfrm>
+          <a:off x="0" y="0"/>
+          <a:ext cx="0" cy="0"/>
+          <a:chOff x="0" y="0"/>
+          <a:chExt cx="0" cy="0"/>
+        </a:xfrm>
+      </p:grpSpPr>
+      <p:sp>
+        <p:nvSpPr>
+          <p:cNvPr id="2" name="Title 1">
+            <a:extLst>
+              <a:ext uri="{FF2B5EF4-FFF2-40B4-BE49-F238E27FC236}">
+                <a16:creationId xmlns:a16="http://schemas.microsoft.com/office/drawing/2014/main" id="{6EAE57A2-3A61-C5F8-EEFD-EA2961784338}"/>
+              </a:ext>
+            </a:extLst>
+          </p:cNvPr>
+          <p:cNvSpPr>
+            <a:spLocks noGrp="1"/>
+          </p:cNvSpPr>
+          <p:nvPr>
+            <p:ph type="ctrTitle"/>
+          </p:nvPr>
+        </p:nvSpPr>
+        <p:spPr/>
+        <p:txBody>
+          <a:bodyPr/>
+          <a:lstStyle/>
+          <a:p>
+            <a:r>
+              <a:rPr lang="en-US" dirty="0"/>
+              <a:t>… to here …</a:t>
+            </a:r>
+          </a:p>
+        </p:txBody>
+      </p:sp>
+    </p:spTree>
+    <p:extLst>
+      <p:ext uri="{BB962C8B-B14F-4D97-AF65-F5344CB8AC3E}">
+        <p14:creationId xmlns:p14="http://schemas.microsoft.com/office/powerpoint/2010/main" val="2815624037"/>
+      </p:ext>
+    </p:extLst>
+  </p:cSld>
+  <p:clrMapOvr>
+    <a:masterClrMapping/>
+  </p:clrMapOvr>
+</p:sld>
+</file>
+
+<file path=ppt/slides/slide27.xml><?xml version="1.0" encoding="utf-8"?>
+<p:sld xmlns:a="http://schemas.openxmlformats.org/drawingml/2006/main" xmlns:r="http://schemas.openxmlformats.org/officeDocument/2006/relationships" xmlns:p="http://schemas.openxmlformats.org/presentationml/2006/main">
+  <p:cSld>
+    <p:spTree>
+      <p:nvGrpSpPr>
         <p:cNvPr id="1" name=""/>
         <p:cNvGrpSpPr/>
         <p:nvPr/>
@@ -32707,7 +32771,7 @@
 </p:sld>
 </file>
 
-<file path=ppt/slides/slide27.xml><?xml version="1.0" encoding="utf-8"?>
+<file path=ppt/slides/slide28.xml><?xml version="1.0" encoding="utf-8"?>
 <p:sld xmlns:a="http://schemas.openxmlformats.org/drawingml/2006/main" xmlns:r="http://schemas.openxmlformats.org/officeDocument/2006/relationships" xmlns:p="http://schemas.openxmlformats.org/presentationml/2006/main">
   <p:cSld>
     <p:spTree>
@@ -33241,7 +33305,7 @@
 </p:sld>
 </file>
 
-<file path=ppt/slides/slide28.xml><?xml version="1.0" encoding="utf-8"?>
+<file path=ppt/slides/slide29.xml><?xml version="1.0" encoding="utf-8"?>
 <p:sld xmlns:a="http://schemas.openxmlformats.org/drawingml/2006/main" xmlns:r="http://schemas.openxmlformats.org/officeDocument/2006/relationships" xmlns:p="http://schemas.openxmlformats.org/presentationml/2006/main">
   <p:cSld>
     <p:spTree>
@@ -35329,7 +35393,564 @@
 </p:sld>
 </file>
 
-<file path=ppt/slides/slide29.xml><?xml version="1.0" encoding="utf-8"?>
+<file path=ppt/slides/slide3.xml><?xml version="1.0" encoding="utf-8"?>
+<p:sld xmlns:a="http://schemas.openxmlformats.org/drawingml/2006/main" xmlns:r="http://schemas.openxmlformats.org/officeDocument/2006/relationships" xmlns:p="http://schemas.openxmlformats.org/presentationml/2006/main">
+  <p:cSld>
+    <p:spTree>
+      <p:nvGrpSpPr>
+        <p:cNvPr id="1" name=""/>
+        <p:cNvGrpSpPr/>
+        <p:nvPr/>
+      </p:nvGrpSpPr>
+      <p:grpSpPr>
+        <a:xfrm>
+          <a:off x="0" y="0"/>
+          <a:ext cx="0" cy="0"/>
+          <a:chOff x="0" y="0"/>
+          <a:chExt cx="0" cy="0"/>
+        </a:xfrm>
+      </p:grpSpPr>
+      <p:sp>
+        <p:nvSpPr>
+          <p:cNvPr id="2" name="Title 1"/>
+          <p:cNvSpPr>
+            <a:spLocks noGrp="1"/>
+          </p:cNvSpPr>
+          <p:nvPr>
+            <p:ph type="title"/>
+          </p:nvPr>
+        </p:nvSpPr>
+        <p:spPr>
+          <a:xfrm>
+            <a:off x="940527" y="726230"/>
+            <a:ext cx="7136673" cy="666899"/>
+          </a:xfrm>
+        </p:spPr>
+        <p:txBody>
+          <a:bodyPr/>
+          <a:lstStyle/>
+          <a:p>
+            <a:r>
+              <a:rPr lang="en-US" dirty="0"/>
+              <a:t>ADDITION AND SUBTRACTION</a:t>
+            </a:r>
+          </a:p>
+        </p:txBody>
+      </p:sp>
+      <p:sp>
+        <p:nvSpPr>
+          <p:cNvPr id="5" name="TextBox 4"/>
+          <p:cNvSpPr txBox="1"/>
+          <p:nvPr/>
+        </p:nvSpPr>
+        <p:spPr>
+          <a:xfrm>
+            <a:off x="5390583" y="2101586"/>
+            <a:ext cx="1283576" cy="2246769"/>
+          </a:xfrm>
+          <a:prstGeom prst="rect">
+            <a:avLst/>
+          </a:prstGeom>
+          <a:noFill/>
+        </p:spPr>
+        <p:txBody>
+          <a:bodyPr wrap="square" rtlCol="0">
+            <a:spAutoFit/>
+          </a:bodyPr>
+          <a:lstStyle/>
+          <a:p>
+            <a:pPr algn="ctr">
+              <a:tabLst>
+                <a:tab pos="3086100" algn="l"/>
+                <a:tab pos="5715000" algn="l"/>
+              </a:tabLst>
+            </a:pPr>
+            <a:r>
+              <a:rPr lang="en-US" sz="2800" i="1" dirty="0"/>
+              <a:t>Binary</a:t>
+            </a:r>
+          </a:p>
+          <a:p>
+            <a:pPr>
+              <a:tabLst>
+                <a:tab pos="3086100" algn="l"/>
+                <a:tab pos="5715000" algn="l"/>
+              </a:tabLst>
+            </a:pPr>
+            <a:endParaRPr lang="en-US" sz="2800" i="1" dirty="0"/>
+          </a:p>
+          <a:p>
+            <a:pPr>
+              <a:tabLst>
+                <a:tab pos="571500" algn="r"/>
+                <a:tab pos="3886200" algn="r"/>
+                <a:tab pos="6686550" algn="r"/>
+              </a:tabLst>
+            </a:pPr>
+            <a:r>
+              <a:rPr lang="en-US" sz="2800" dirty="0"/>
+              <a:t>  	0011</a:t>
+            </a:r>
+          </a:p>
+          <a:p>
+            <a:pPr>
+              <a:tabLst>
+                <a:tab pos="571500" algn="r"/>
+                <a:tab pos="3886200" algn="r"/>
+                <a:tab pos="6686550" algn="r"/>
+              </a:tabLst>
+            </a:pPr>
+            <a:r>
+              <a:rPr lang="en-US" sz="2800" dirty="0"/>
+              <a:t>+</a:t>
+            </a:r>
+            <a:r>
+              <a:rPr lang="en-US" sz="2800" u="sng" dirty="0"/>
+              <a:t>1010</a:t>
+            </a:r>
+          </a:p>
+          <a:p>
+            <a:pPr>
+              <a:tabLst>
+                <a:tab pos="857250" algn="r"/>
+                <a:tab pos="4000500" algn="r"/>
+                <a:tab pos="6858000" algn="r"/>
+              </a:tabLst>
+            </a:pPr>
+            <a:r>
+              <a:rPr lang="en-US" sz="2800" dirty="0"/>
+              <a:t>	  1101</a:t>
+            </a:r>
+            <a:r>
+              <a:rPr lang="en-US" sz="2800" baseline="-25000" dirty="0"/>
+              <a:t>2</a:t>
+            </a:r>
+            <a:endParaRPr lang="en-US" sz="2800" dirty="0"/>
+          </a:p>
+        </p:txBody>
+      </p:sp>
+      <p:grpSp>
+        <p:nvGrpSpPr>
+          <p:cNvPr id="12" name="Group 11"/>
+          <p:cNvGrpSpPr/>
+          <p:nvPr/>
+        </p:nvGrpSpPr>
+        <p:grpSpPr>
+          <a:xfrm>
+            <a:off x="4438569" y="5026231"/>
+            <a:ext cx="3794760" cy="1015663"/>
+            <a:chOff x="1620391" y="4175686"/>
+            <a:chExt cx="3794760" cy="1015663"/>
+          </a:xfrm>
+          <a:solidFill>
+            <a:schemeClr val="accent4">
+              <a:lumMod val="20000"/>
+              <a:lumOff val="80000"/>
+            </a:schemeClr>
+          </a:solidFill>
+        </p:grpSpPr>
+        <p:sp>
+          <p:nvSpPr>
+            <p:cNvPr id="10" name="TextBox 9"/>
+            <p:cNvSpPr txBox="1"/>
+            <p:nvPr/>
+          </p:nvSpPr>
+          <p:spPr>
+            <a:xfrm>
+              <a:off x="1620391" y="4175686"/>
+              <a:ext cx="3794760" cy="1015663"/>
+            </a:xfrm>
+            <a:prstGeom prst="rect">
+              <a:avLst/>
+            </a:prstGeom>
+            <a:grpFill/>
+            <a:ln/>
+          </p:spPr>
+          <p:style>
+            <a:lnRef idx="1">
+              <a:schemeClr val="accent2"/>
+            </a:lnRef>
+            <a:fillRef idx="2">
+              <a:schemeClr val="accent2"/>
+            </a:fillRef>
+            <a:effectRef idx="1">
+              <a:schemeClr val="accent2"/>
+            </a:effectRef>
+            <a:fontRef idx="minor">
+              <a:schemeClr val="dk1"/>
+            </a:fontRef>
+          </p:style>
+          <p:txBody>
+            <a:bodyPr wrap="square" tIns="91440" bIns="91440" rtlCol="0">
+              <a:spAutoFit/>
+            </a:bodyPr>
+            <a:lstStyle/>
+            <a:p>
+              <a:pPr marL="1027113" lvl="1"/>
+              <a:r>
+                <a:rPr lang="en-US" dirty="0"/>
+                <a:t>A single ADD (or SUB) instruction works for both </a:t>
+              </a:r>
+              <a:r>
+                <a:rPr lang="en-US" b="1" dirty="0">
+                  <a:solidFill>
+                    <a:srgbClr val="92D050"/>
+                  </a:solidFill>
+                </a:rPr>
+                <a:t>unsigned</a:t>
+              </a:r>
+              <a:r>
+                <a:rPr lang="en-US" dirty="0"/>
+                <a:t> and </a:t>
+              </a:r>
+              <a:r>
+                <a:rPr lang="en-US" b="1" dirty="0">
+                  <a:solidFill>
+                    <a:srgbClr val="FF0000"/>
+                  </a:solidFill>
+                </a:rPr>
+                <a:t>2’s comp</a:t>
+              </a:r>
+              <a:r>
+                <a:rPr lang="en-US" dirty="0"/>
+                <a:t>.</a:t>
+              </a:r>
+            </a:p>
+          </p:txBody>
+        </p:sp>
+        <p:pic>
+          <p:nvPicPr>
+            <p:cNvPr id="11" name="Picture 10" descr="http://www.aamu.edu/campuslife/living-on-campus/residentialLife/SiteAssets/pages/default/Warning_sign.png"/>
+            <p:cNvPicPr>
+              <a:picLocks noChangeAspect="1" noChangeArrowheads="1"/>
+            </p:cNvPicPr>
+            <p:nvPr/>
+          </p:nvPicPr>
+          <p:blipFill>
+            <a:blip r:embed="rId2" cstate="print">
+              <a:extLst>
+                <a:ext uri="{28A0092B-C50C-407E-A947-70E740481C1C}">
+                  <a14:useLocalDpi xmlns:a14="http://schemas.microsoft.com/office/drawing/2010/main" val="0"/>
+                </a:ext>
+              </a:extLst>
+            </a:blip>
+            <a:srcRect/>
+            <a:stretch>
+              <a:fillRect/>
+            </a:stretch>
+          </p:blipFill>
+          <p:spPr bwMode="auto">
+            <a:xfrm flipH="1">
+              <a:off x="1620391" y="4264417"/>
+              <a:ext cx="971826" cy="838200"/>
+            </a:xfrm>
+            <a:prstGeom prst="rect">
+              <a:avLst/>
+            </a:prstGeom>
+            <a:grpFill/>
+          </p:spPr>
+        </p:pic>
+      </p:grpSp>
+      <p:sp>
+        <p:nvSpPr>
+          <p:cNvPr id="22" name="TextBox 21"/>
+          <p:cNvSpPr txBox="1"/>
+          <p:nvPr/>
+        </p:nvSpPr>
+        <p:spPr>
+          <a:xfrm>
+            <a:off x="2057400" y="2101585"/>
+            <a:ext cx="1905000" cy="2246769"/>
+          </a:xfrm>
+          <a:prstGeom prst="rect">
+            <a:avLst/>
+          </a:prstGeom>
+          <a:noFill/>
+        </p:spPr>
+        <p:txBody>
+          <a:bodyPr wrap="square" rtlCol="0">
+            <a:spAutoFit/>
+          </a:bodyPr>
+          <a:lstStyle/>
+          <a:p>
+            <a:r>
+              <a:rPr lang="en-US" sz="2800" b="1" dirty="0">
+                <a:solidFill>
+                  <a:srgbClr val="92D050"/>
+                </a:solidFill>
+              </a:rPr>
+              <a:t>Unsigned</a:t>
+            </a:r>
+          </a:p>
+          <a:p>
+            <a:r>
+              <a:rPr lang="en-US" sz="2800" i="1" dirty="0"/>
+              <a:t> </a:t>
+            </a:r>
+          </a:p>
+          <a:p>
+            <a:r>
+              <a:rPr lang="en-US" sz="2800" dirty="0">
+                <a:latin typeface="Consolas" panose="020B0609020204030204" pitchFamily="49" charset="0"/>
+              </a:rPr>
+              <a:t>   3</a:t>
+            </a:r>
+          </a:p>
+          <a:p>
+            <a:r>
+              <a:rPr lang="en-US" sz="2800" dirty="0">
+                <a:latin typeface="Consolas" panose="020B0609020204030204" pitchFamily="49" charset="0"/>
+              </a:rPr>
+              <a:t> </a:t>
+            </a:r>
+            <a:r>
+              <a:rPr lang="en-US" sz="2800" u="sng" dirty="0">
+                <a:latin typeface="Consolas" panose="020B0609020204030204" pitchFamily="49" charset="0"/>
+              </a:rPr>
+              <a:t>+10</a:t>
+            </a:r>
+          </a:p>
+          <a:p>
+            <a:r>
+              <a:rPr lang="en-US" sz="2800" dirty="0">
+                <a:latin typeface="Consolas" panose="020B0609020204030204" pitchFamily="49" charset="0"/>
+              </a:rPr>
+              <a:t>  13</a:t>
+            </a:r>
+            <a:r>
+              <a:rPr lang="en-US" sz="2800" baseline="-25000" dirty="0">
+                <a:latin typeface="Consolas" panose="020B0609020204030204" pitchFamily="49" charset="0"/>
+              </a:rPr>
+              <a:t>10</a:t>
+            </a:r>
+          </a:p>
+        </p:txBody>
+      </p:sp>
+      <p:sp>
+        <p:nvSpPr>
+          <p:cNvPr id="23" name="TextBox 22"/>
+          <p:cNvSpPr txBox="1"/>
+          <p:nvPr/>
+        </p:nvSpPr>
+        <p:spPr>
+          <a:xfrm>
+            <a:off x="7821856" y="2108310"/>
+            <a:ext cx="3166986" cy="2246769"/>
+          </a:xfrm>
+          <a:prstGeom prst="rect">
+            <a:avLst/>
+          </a:prstGeom>
+          <a:noFill/>
+        </p:spPr>
+        <p:txBody>
+          <a:bodyPr wrap="square" rtlCol="0">
+            <a:spAutoFit/>
+          </a:bodyPr>
+          <a:lstStyle/>
+          <a:p>
+            <a:r>
+              <a:rPr lang="en-US" sz="2800" i="1" dirty="0"/>
+              <a:t>  </a:t>
+            </a:r>
+            <a:r>
+              <a:rPr lang="en-US" sz="2800" b="1" dirty="0">
+                <a:solidFill>
+                  <a:srgbClr val="FF0000"/>
+                </a:solidFill>
+              </a:rPr>
+              <a:t>2’s Complement </a:t>
+            </a:r>
+          </a:p>
+          <a:p>
+            <a:r>
+              <a:rPr lang="en-US" sz="2800" i="1" dirty="0"/>
+              <a:t> </a:t>
+            </a:r>
+          </a:p>
+          <a:p>
+            <a:r>
+              <a:rPr lang="en-US" sz="2800" dirty="0">
+                <a:latin typeface="Consolas" panose="020B0609020204030204" pitchFamily="49" charset="0"/>
+              </a:rPr>
+              <a:t>   (+3)</a:t>
+            </a:r>
+          </a:p>
+          <a:p>
+            <a:r>
+              <a:rPr lang="en-US" sz="2800" dirty="0">
+                <a:latin typeface="Consolas" panose="020B0609020204030204" pitchFamily="49" charset="0"/>
+              </a:rPr>
+              <a:t>  </a:t>
+            </a:r>
+            <a:r>
+              <a:rPr lang="en-US" sz="2800" u="sng" dirty="0">
+                <a:latin typeface="Consolas" panose="020B0609020204030204" pitchFamily="49" charset="0"/>
+              </a:rPr>
+              <a:t>+(-6)</a:t>
+            </a:r>
+          </a:p>
+          <a:p>
+            <a:r>
+              <a:rPr lang="en-US" sz="2800" dirty="0">
+                <a:latin typeface="Consolas" panose="020B0609020204030204" pitchFamily="49" charset="0"/>
+              </a:rPr>
+              <a:t>    -3</a:t>
+            </a:r>
+            <a:r>
+              <a:rPr lang="en-US" sz="2800" baseline="-25000" dirty="0">
+                <a:latin typeface="Consolas" panose="020B0609020204030204" pitchFamily="49" charset="0"/>
+              </a:rPr>
+              <a:t>10</a:t>
+            </a:r>
+          </a:p>
+        </p:txBody>
+      </p:sp>
+      <p:cxnSp>
+        <p:nvCxnSpPr>
+          <p:cNvPr id="34" name="Straight Arrow Connector 33"/>
+          <p:cNvCxnSpPr/>
+          <p:nvPr/>
+        </p:nvCxnSpPr>
+        <p:spPr>
+          <a:xfrm>
+            <a:off x="6915150" y="3503268"/>
+            <a:ext cx="906706" cy="0"/>
+          </a:xfrm>
+          <a:prstGeom prst="straightConnector1">
+            <a:avLst/>
+          </a:prstGeom>
+          <a:ln w="76200">
+            <a:solidFill>
+              <a:srgbClr val="FF0000"/>
+            </a:solidFill>
+            <a:tailEnd type="triangle"/>
+          </a:ln>
+        </p:spPr>
+        <p:style>
+          <a:lnRef idx="1">
+            <a:schemeClr val="accent1"/>
+          </a:lnRef>
+          <a:fillRef idx="0">
+            <a:schemeClr val="accent1"/>
+          </a:fillRef>
+          <a:effectRef idx="0">
+            <a:schemeClr val="accent1"/>
+          </a:effectRef>
+          <a:fontRef idx="minor">
+            <a:schemeClr val="tx1"/>
+          </a:fontRef>
+        </p:style>
+      </p:cxnSp>
+      <p:cxnSp>
+        <p:nvCxnSpPr>
+          <p:cNvPr id="35" name="Straight Arrow Connector 34"/>
+          <p:cNvCxnSpPr/>
+          <p:nvPr/>
+        </p:nvCxnSpPr>
+        <p:spPr>
+          <a:xfrm flipH="1" flipV="1">
+            <a:off x="3967547" y="3457930"/>
+            <a:ext cx="942045" cy="11332"/>
+          </a:xfrm>
+          <a:prstGeom prst="straightConnector1">
+            <a:avLst/>
+          </a:prstGeom>
+          <a:ln w="76200">
+            <a:solidFill>
+              <a:srgbClr val="FF0000"/>
+            </a:solidFill>
+            <a:tailEnd type="triangle"/>
+          </a:ln>
+        </p:spPr>
+        <p:style>
+          <a:lnRef idx="1">
+            <a:schemeClr val="accent1"/>
+          </a:lnRef>
+          <a:fillRef idx="0">
+            <a:schemeClr val="accent1"/>
+          </a:fillRef>
+          <a:effectRef idx="0">
+            <a:schemeClr val="accent1"/>
+          </a:effectRef>
+          <a:fontRef idx="minor">
+            <a:schemeClr val="tx1"/>
+          </a:fontRef>
+        </p:style>
+      </p:cxnSp>
+      <p:pic>
+        <p:nvPicPr>
+          <p:cNvPr id="13" name="Picture 12"/>
+          <p:cNvPicPr>
+            <a:picLocks noChangeAspect="1"/>
+          </p:cNvPicPr>
+          <p:nvPr/>
+        </p:nvPicPr>
+        <p:blipFill>
+          <a:blip r:embed="rId3" cstate="print">
+            <a:extLst>
+              <a:ext uri="{28A0092B-C50C-407E-A947-70E740481C1C}">
+                <a14:useLocalDpi xmlns:a14="http://schemas.microsoft.com/office/drawing/2010/main" val="0"/>
+              </a:ext>
+            </a:extLst>
+          </a:blip>
+          <a:stretch>
+            <a:fillRect/>
+          </a:stretch>
+        </p:blipFill>
+        <p:spPr>
+          <a:xfrm>
+            <a:off x="3413280" y="3765302"/>
+            <a:ext cx="533399" cy="523398"/>
+          </a:xfrm>
+          <a:prstGeom prst="rect">
+            <a:avLst/>
+          </a:prstGeom>
+        </p:spPr>
+      </p:pic>
+      <p:pic>
+        <p:nvPicPr>
+          <p:cNvPr id="14" name="Picture 13"/>
+          <p:cNvPicPr>
+            <a:picLocks noChangeAspect="1"/>
+          </p:cNvPicPr>
+          <p:nvPr/>
+        </p:nvPicPr>
+        <p:blipFill>
+          <a:blip r:embed="rId3" cstate="print">
+            <a:extLst>
+              <a:ext uri="{28A0092B-C50C-407E-A947-70E740481C1C}">
+                <a14:useLocalDpi xmlns:a14="http://schemas.microsoft.com/office/drawing/2010/main" val="0"/>
+              </a:ext>
+            </a:extLst>
+          </a:blip>
+          <a:stretch>
+            <a:fillRect/>
+          </a:stretch>
+        </p:blipFill>
+        <p:spPr>
+          <a:xfrm>
+            <a:off x="9533148" y="3766324"/>
+            <a:ext cx="533399" cy="523398"/>
+          </a:xfrm>
+          <a:prstGeom prst="rect">
+            <a:avLst/>
+          </a:prstGeom>
+        </p:spPr>
+      </p:pic>
+    </p:spTree>
+    <p:extLst>
+      <p:ext uri="{BB962C8B-B14F-4D97-AF65-F5344CB8AC3E}">
+        <p14:creationId xmlns:p14="http://schemas.microsoft.com/office/powerpoint/2010/main" val="1403904733"/>
+      </p:ext>
+    </p:extLst>
+  </p:cSld>
+  <p:clrMapOvr>
+    <a:masterClrMapping/>
+  </p:clrMapOvr>
+</p:sld>
+</file>
+
+<file path=ppt/slides/slide30.xml><?xml version="1.0" encoding="utf-8"?>
 <p:sld xmlns:a="http://schemas.openxmlformats.org/drawingml/2006/main" xmlns:r="http://schemas.openxmlformats.org/officeDocument/2006/relationships" xmlns:p="http://schemas.openxmlformats.org/presentationml/2006/main">
   <p:cSld>
     <p:spTree>
@@ -36261,564 +36882,7 @@
 </p:sld>
 </file>
 
-<file path=ppt/slides/slide3.xml><?xml version="1.0" encoding="utf-8"?>
-<p:sld xmlns:a="http://schemas.openxmlformats.org/drawingml/2006/main" xmlns:r="http://schemas.openxmlformats.org/officeDocument/2006/relationships" xmlns:p="http://schemas.openxmlformats.org/presentationml/2006/main">
-  <p:cSld>
-    <p:spTree>
-      <p:nvGrpSpPr>
-        <p:cNvPr id="1" name=""/>
-        <p:cNvGrpSpPr/>
-        <p:nvPr/>
-      </p:nvGrpSpPr>
-      <p:grpSpPr>
-        <a:xfrm>
-          <a:off x="0" y="0"/>
-          <a:ext cx="0" cy="0"/>
-          <a:chOff x="0" y="0"/>
-          <a:chExt cx="0" cy="0"/>
-        </a:xfrm>
-      </p:grpSpPr>
-      <p:sp>
-        <p:nvSpPr>
-          <p:cNvPr id="2" name="Title 1"/>
-          <p:cNvSpPr>
-            <a:spLocks noGrp="1"/>
-          </p:cNvSpPr>
-          <p:nvPr>
-            <p:ph type="title"/>
-          </p:nvPr>
-        </p:nvSpPr>
-        <p:spPr>
-          <a:xfrm>
-            <a:off x="940527" y="726230"/>
-            <a:ext cx="7136673" cy="666899"/>
-          </a:xfrm>
-        </p:spPr>
-        <p:txBody>
-          <a:bodyPr/>
-          <a:lstStyle/>
-          <a:p>
-            <a:r>
-              <a:rPr lang="en-US" dirty="0"/>
-              <a:t>ADDITION AND SUBTRACTION</a:t>
-            </a:r>
-          </a:p>
-        </p:txBody>
-      </p:sp>
-      <p:sp>
-        <p:nvSpPr>
-          <p:cNvPr id="5" name="TextBox 4"/>
-          <p:cNvSpPr txBox="1"/>
-          <p:nvPr/>
-        </p:nvSpPr>
-        <p:spPr>
-          <a:xfrm>
-            <a:off x="5390583" y="2101586"/>
-            <a:ext cx="1283576" cy="2246769"/>
-          </a:xfrm>
-          <a:prstGeom prst="rect">
-            <a:avLst/>
-          </a:prstGeom>
-          <a:noFill/>
-        </p:spPr>
-        <p:txBody>
-          <a:bodyPr wrap="square" rtlCol="0">
-            <a:spAutoFit/>
-          </a:bodyPr>
-          <a:lstStyle/>
-          <a:p>
-            <a:pPr algn="ctr">
-              <a:tabLst>
-                <a:tab pos="3086100" algn="l"/>
-                <a:tab pos="5715000" algn="l"/>
-              </a:tabLst>
-            </a:pPr>
-            <a:r>
-              <a:rPr lang="en-US" sz="2800" i="1" dirty="0"/>
-              <a:t>Binary</a:t>
-            </a:r>
-          </a:p>
-          <a:p>
-            <a:pPr>
-              <a:tabLst>
-                <a:tab pos="3086100" algn="l"/>
-                <a:tab pos="5715000" algn="l"/>
-              </a:tabLst>
-            </a:pPr>
-            <a:endParaRPr lang="en-US" sz="2800" i="1" dirty="0"/>
-          </a:p>
-          <a:p>
-            <a:pPr>
-              <a:tabLst>
-                <a:tab pos="571500" algn="r"/>
-                <a:tab pos="3886200" algn="r"/>
-                <a:tab pos="6686550" algn="r"/>
-              </a:tabLst>
-            </a:pPr>
-            <a:r>
-              <a:rPr lang="en-US" sz="2800" dirty="0"/>
-              <a:t>  	0011</a:t>
-            </a:r>
-          </a:p>
-          <a:p>
-            <a:pPr>
-              <a:tabLst>
-                <a:tab pos="571500" algn="r"/>
-                <a:tab pos="3886200" algn="r"/>
-                <a:tab pos="6686550" algn="r"/>
-              </a:tabLst>
-            </a:pPr>
-            <a:r>
-              <a:rPr lang="en-US" sz="2800" dirty="0"/>
-              <a:t>+</a:t>
-            </a:r>
-            <a:r>
-              <a:rPr lang="en-US" sz="2800" u="sng" dirty="0"/>
-              <a:t>1010</a:t>
-            </a:r>
-          </a:p>
-          <a:p>
-            <a:pPr>
-              <a:tabLst>
-                <a:tab pos="857250" algn="r"/>
-                <a:tab pos="4000500" algn="r"/>
-                <a:tab pos="6858000" algn="r"/>
-              </a:tabLst>
-            </a:pPr>
-            <a:r>
-              <a:rPr lang="en-US" sz="2800" dirty="0"/>
-              <a:t>	  1101</a:t>
-            </a:r>
-            <a:r>
-              <a:rPr lang="en-US" sz="2800" baseline="-25000" dirty="0"/>
-              <a:t>2</a:t>
-            </a:r>
-            <a:endParaRPr lang="en-US" sz="2800" dirty="0"/>
-          </a:p>
-        </p:txBody>
-      </p:sp>
-      <p:grpSp>
-        <p:nvGrpSpPr>
-          <p:cNvPr id="12" name="Group 11"/>
-          <p:cNvGrpSpPr/>
-          <p:nvPr/>
-        </p:nvGrpSpPr>
-        <p:grpSpPr>
-          <a:xfrm>
-            <a:off x="4438569" y="5026231"/>
-            <a:ext cx="3794760" cy="1015663"/>
-            <a:chOff x="1620391" y="4175686"/>
-            <a:chExt cx="3794760" cy="1015663"/>
-          </a:xfrm>
-          <a:solidFill>
-            <a:schemeClr val="accent4">
-              <a:lumMod val="20000"/>
-              <a:lumOff val="80000"/>
-            </a:schemeClr>
-          </a:solidFill>
-        </p:grpSpPr>
-        <p:sp>
-          <p:nvSpPr>
-            <p:cNvPr id="10" name="TextBox 9"/>
-            <p:cNvSpPr txBox="1"/>
-            <p:nvPr/>
-          </p:nvSpPr>
-          <p:spPr>
-            <a:xfrm>
-              <a:off x="1620391" y="4175686"/>
-              <a:ext cx="3794760" cy="1015663"/>
-            </a:xfrm>
-            <a:prstGeom prst="rect">
-              <a:avLst/>
-            </a:prstGeom>
-            <a:grpFill/>
-            <a:ln/>
-          </p:spPr>
-          <p:style>
-            <a:lnRef idx="1">
-              <a:schemeClr val="accent2"/>
-            </a:lnRef>
-            <a:fillRef idx="2">
-              <a:schemeClr val="accent2"/>
-            </a:fillRef>
-            <a:effectRef idx="1">
-              <a:schemeClr val="accent2"/>
-            </a:effectRef>
-            <a:fontRef idx="minor">
-              <a:schemeClr val="dk1"/>
-            </a:fontRef>
-          </p:style>
-          <p:txBody>
-            <a:bodyPr wrap="square" tIns="91440" bIns="91440" rtlCol="0">
-              <a:spAutoFit/>
-            </a:bodyPr>
-            <a:lstStyle/>
-            <a:p>
-              <a:pPr marL="1027113" lvl="1"/>
-              <a:r>
-                <a:rPr lang="en-US" dirty="0"/>
-                <a:t>A single ADD (or SUB) instruction works for both </a:t>
-              </a:r>
-              <a:r>
-                <a:rPr lang="en-US" b="1" dirty="0">
-                  <a:solidFill>
-                    <a:srgbClr val="92D050"/>
-                  </a:solidFill>
-                </a:rPr>
-                <a:t>unsigned</a:t>
-              </a:r>
-              <a:r>
-                <a:rPr lang="en-US" dirty="0"/>
-                <a:t> and </a:t>
-              </a:r>
-              <a:r>
-                <a:rPr lang="en-US" b="1" dirty="0">
-                  <a:solidFill>
-                    <a:srgbClr val="FF0000"/>
-                  </a:solidFill>
-                </a:rPr>
-                <a:t>2’s comp</a:t>
-              </a:r>
-              <a:r>
-                <a:rPr lang="en-US" dirty="0"/>
-                <a:t>.</a:t>
-              </a:r>
-            </a:p>
-          </p:txBody>
-        </p:sp>
-        <p:pic>
-          <p:nvPicPr>
-            <p:cNvPr id="11" name="Picture 10" descr="http://www.aamu.edu/campuslife/living-on-campus/residentialLife/SiteAssets/pages/default/Warning_sign.png"/>
-            <p:cNvPicPr>
-              <a:picLocks noChangeAspect="1" noChangeArrowheads="1"/>
-            </p:cNvPicPr>
-            <p:nvPr/>
-          </p:nvPicPr>
-          <p:blipFill>
-            <a:blip r:embed="rId2" cstate="print">
-              <a:extLst>
-                <a:ext uri="{28A0092B-C50C-407E-A947-70E740481C1C}">
-                  <a14:useLocalDpi xmlns:a14="http://schemas.microsoft.com/office/drawing/2010/main" val="0"/>
-                </a:ext>
-              </a:extLst>
-            </a:blip>
-            <a:srcRect/>
-            <a:stretch>
-              <a:fillRect/>
-            </a:stretch>
-          </p:blipFill>
-          <p:spPr bwMode="auto">
-            <a:xfrm flipH="1">
-              <a:off x="1620391" y="4264417"/>
-              <a:ext cx="971826" cy="838200"/>
-            </a:xfrm>
-            <a:prstGeom prst="rect">
-              <a:avLst/>
-            </a:prstGeom>
-            <a:grpFill/>
-          </p:spPr>
-        </p:pic>
-      </p:grpSp>
-      <p:sp>
-        <p:nvSpPr>
-          <p:cNvPr id="22" name="TextBox 21"/>
-          <p:cNvSpPr txBox="1"/>
-          <p:nvPr/>
-        </p:nvSpPr>
-        <p:spPr>
-          <a:xfrm>
-            <a:off x="2057400" y="2101585"/>
-            <a:ext cx="1905000" cy="2246769"/>
-          </a:xfrm>
-          <a:prstGeom prst="rect">
-            <a:avLst/>
-          </a:prstGeom>
-          <a:noFill/>
-        </p:spPr>
-        <p:txBody>
-          <a:bodyPr wrap="square" rtlCol="0">
-            <a:spAutoFit/>
-          </a:bodyPr>
-          <a:lstStyle/>
-          <a:p>
-            <a:r>
-              <a:rPr lang="en-US" sz="2800" b="1" dirty="0">
-                <a:solidFill>
-                  <a:srgbClr val="92D050"/>
-                </a:solidFill>
-              </a:rPr>
-              <a:t>Unsigned</a:t>
-            </a:r>
-          </a:p>
-          <a:p>
-            <a:r>
-              <a:rPr lang="en-US" sz="2800" i="1" dirty="0"/>
-              <a:t> </a:t>
-            </a:r>
-          </a:p>
-          <a:p>
-            <a:r>
-              <a:rPr lang="en-US" sz="2800" dirty="0">
-                <a:latin typeface="Consolas" panose="020B0609020204030204" pitchFamily="49" charset="0"/>
-              </a:rPr>
-              <a:t>   3</a:t>
-            </a:r>
-          </a:p>
-          <a:p>
-            <a:r>
-              <a:rPr lang="en-US" sz="2800" dirty="0">
-                <a:latin typeface="Consolas" panose="020B0609020204030204" pitchFamily="49" charset="0"/>
-              </a:rPr>
-              <a:t> </a:t>
-            </a:r>
-            <a:r>
-              <a:rPr lang="en-US" sz="2800" u="sng" dirty="0">
-                <a:latin typeface="Consolas" panose="020B0609020204030204" pitchFamily="49" charset="0"/>
-              </a:rPr>
-              <a:t>+10</a:t>
-            </a:r>
-          </a:p>
-          <a:p>
-            <a:r>
-              <a:rPr lang="en-US" sz="2800" dirty="0">
-                <a:latin typeface="Consolas" panose="020B0609020204030204" pitchFamily="49" charset="0"/>
-              </a:rPr>
-              <a:t>  13</a:t>
-            </a:r>
-            <a:r>
-              <a:rPr lang="en-US" sz="2800" baseline="-25000" dirty="0">
-                <a:latin typeface="Consolas" panose="020B0609020204030204" pitchFamily="49" charset="0"/>
-              </a:rPr>
-              <a:t>10</a:t>
-            </a:r>
-          </a:p>
-        </p:txBody>
-      </p:sp>
-      <p:sp>
-        <p:nvSpPr>
-          <p:cNvPr id="23" name="TextBox 22"/>
-          <p:cNvSpPr txBox="1"/>
-          <p:nvPr/>
-        </p:nvSpPr>
-        <p:spPr>
-          <a:xfrm>
-            <a:off x="7821856" y="2108310"/>
-            <a:ext cx="3166986" cy="2246769"/>
-          </a:xfrm>
-          <a:prstGeom prst="rect">
-            <a:avLst/>
-          </a:prstGeom>
-          <a:noFill/>
-        </p:spPr>
-        <p:txBody>
-          <a:bodyPr wrap="square" rtlCol="0">
-            <a:spAutoFit/>
-          </a:bodyPr>
-          <a:lstStyle/>
-          <a:p>
-            <a:r>
-              <a:rPr lang="en-US" sz="2800" i="1" dirty="0"/>
-              <a:t>  </a:t>
-            </a:r>
-            <a:r>
-              <a:rPr lang="en-US" sz="2800" b="1" dirty="0">
-                <a:solidFill>
-                  <a:srgbClr val="FF0000"/>
-                </a:solidFill>
-              </a:rPr>
-              <a:t>2’s Complement </a:t>
-            </a:r>
-          </a:p>
-          <a:p>
-            <a:r>
-              <a:rPr lang="en-US" sz="2800" i="1" dirty="0"/>
-              <a:t> </a:t>
-            </a:r>
-          </a:p>
-          <a:p>
-            <a:r>
-              <a:rPr lang="en-US" sz="2800" dirty="0">
-                <a:latin typeface="Consolas" panose="020B0609020204030204" pitchFamily="49" charset="0"/>
-              </a:rPr>
-              <a:t>   (+3)</a:t>
-            </a:r>
-          </a:p>
-          <a:p>
-            <a:r>
-              <a:rPr lang="en-US" sz="2800" dirty="0">
-                <a:latin typeface="Consolas" panose="020B0609020204030204" pitchFamily="49" charset="0"/>
-              </a:rPr>
-              <a:t>  </a:t>
-            </a:r>
-            <a:r>
-              <a:rPr lang="en-US" sz="2800" u="sng" dirty="0">
-                <a:latin typeface="Consolas" panose="020B0609020204030204" pitchFamily="49" charset="0"/>
-              </a:rPr>
-              <a:t>+(-6)</a:t>
-            </a:r>
-          </a:p>
-          <a:p>
-            <a:r>
-              <a:rPr lang="en-US" sz="2800" dirty="0">
-                <a:latin typeface="Consolas" panose="020B0609020204030204" pitchFamily="49" charset="0"/>
-              </a:rPr>
-              <a:t>    -3</a:t>
-            </a:r>
-            <a:r>
-              <a:rPr lang="en-US" sz="2800" baseline="-25000" dirty="0">
-                <a:latin typeface="Consolas" panose="020B0609020204030204" pitchFamily="49" charset="0"/>
-              </a:rPr>
-              <a:t>10</a:t>
-            </a:r>
-          </a:p>
-        </p:txBody>
-      </p:sp>
-      <p:cxnSp>
-        <p:nvCxnSpPr>
-          <p:cNvPr id="34" name="Straight Arrow Connector 33"/>
-          <p:cNvCxnSpPr/>
-          <p:nvPr/>
-        </p:nvCxnSpPr>
-        <p:spPr>
-          <a:xfrm>
-            <a:off x="6915150" y="3503268"/>
-            <a:ext cx="906706" cy="0"/>
-          </a:xfrm>
-          <a:prstGeom prst="straightConnector1">
-            <a:avLst/>
-          </a:prstGeom>
-          <a:ln w="76200">
-            <a:solidFill>
-              <a:srgbClr val="FF0000"/>
-            </a:solidFill>
-            <a:tailEnd type="triangle"/>
-          </a:ln>
-        </p:spPr>
-        <p:style>
-          <a:lnRef idx="1">
-            <a:schemeClr val="accent1"/>
-          </a:lnRef>
-          <a:fillRef idx="0">
-            <a:schemeClr val="accent1"/>
-          </a:fillRef>
-          <a:effectRef idx="0">
-            <a:schemeClr val="accent1"/>
-          </a:effectRef>
-          <a:fontRef idx="minor">
-            <a:schemeClr val="tx1"/>
-          </a:fontRef>
-        </p:style>
-      </p:cxnSp>
-      <p:cxnSp>
-        <p:nvCxnSpPr>
-          <p:cNvPr id="35" name="Straight Arrow Connector 34"/>
-          <p:cNvCxnSpPr/>
-          <p:nvPr/>
-        </p:nvCxnSpPr>
-        <p:spPr>
-          <a:xfrm flipH="1" flipV="1">
-            <a:off x="3967547" y="3457930"/>
-            <a:ext cx="942045" cy="11332"/>
-          </a:xfrm>
-          <a:prstGeom prst="straightConnector1">
-            <a:avLst/>
-          </a:prstGeom>
-          <a:ln w="76200">
-            <a:solidFill>
-              <a:srgbClr val="FF0000"/>
-            </a:solidFill>
-            <a:tailEnd type="triangle"/>
-          </a:ln>
-        </p:spPr>
-        <p:style>
-          <a:lnRef idx="1">
-            <a:schemeClr val="accent1"/>
-          </a:lnRef>
-          <a:fillRef idx="0">
-            <a:schemeClr val="accent1"/>
-          </a:fillRef>
-          <a:effectRef idx="0">
-            <a:schemeClr val="accent1"/>
-          </a:effectRef>
-          <a:fontRef idx="minor">
-            <a:schemeClr val="tx1"/>
-          </a:fontRef>
-        </p:style>
-      </p:cxnSp>
-      <p:pic>
-        <p:nvPicPr>
-          <p:cNvPr id="13" name="Picture 12"/>
-          <p:cNvPicPr>
-            <a:picLocks noChangeAspect="1"/>
-          </p:cNvPicPr>
-          <p:nvPr/>
-        </p:nvPicPr>
-        <p:blipFill>
-          <a:blip r:embed="rId3" cstate="print">
-            <a:extLst>
-              <a:ext uri="{28A0092B-C50C-407E-A947-70E740481C1C}">
-                <a14:useLocalDpi xmlns:a14="http://schemas.microsoft.com/office/drawing/2010/main" val="0"/>
-              </a:ext>
-            </a:extLst>
-          </a:blip>
-          <a:stretch>
-            <a:fillRect/>
-          </a:stretch>
-        </p:blipFill>
-        <p:spPr>
-          <a:xfrm>
-            <a:off x="3413280" y="3765302"/>
-            <a:ext cx="533399" cy="523398"/>
-          </a:xfrm>
-          <a:prstGeom prst="rect">
-            <a:avLst/>
-          </a:prstGeom>
-        </p:spPr>
-      </p:pic>
-      <p:pic>
-        <p:nvPicPr>
-          <p:cNvPr id="14" name="Picture 13"/>
-          <p:cNvPicPr>
-            <a:picLocks noChangeAspect="1"/>
-          </p:cNvPicPr>
-          <p:nvPr/>
-        </p:nvPicPr>
-        <p:blipFill>
-          <a:blip r:embed="rId3" cstate="print">
-            <a:extLst>
-              <a:ext uri="{28A0092B-C50C-407E-A947-70E740481C1C}">
-                <a14:useLocalDpi xmlns:a14="http://schemas.microsoft.com/office/drawing/2010/main" val="0"/>
-              </a:ext>
-            </a:extLst>
-          </a:blip>
-          <a:stretch>
-            <a:fillRect/>
-          </a:stretch>
-        </p:blipFill>
-        <p:spPr>
-          <a:xfrm>
-            <a:off x="9533148" y="3766324"/>
-            <a:ext cx="533399" cy="523398"/>
-          </a:xfrm>
-          <a:prstGeom prst="rect">
-            <a:avLst/>
-          </a:prstGeom>
-        </p:spPr>
-      </p:pic>
-    </p:spTree>
-    <p:extLst>
-      <p:ext uri="{BB962C8B-B14F-4D97-AF65-F5344CB8AC3E}">
-        <p14:creationId xmlns:p14="http://schemas.microsoft.com/office/powerpoint/2010/main" val="1403904733"/>
-      </p:ext>
-    </p:extLst>
-  </p:cSld>
-  <p:clrMapOvr>
-    <a:masterClrMapping/>
-  </p:clrMapOvr>
-</p:sld>
-</file>
-
-<file path=ppt/slides/slide30.xml><?xml version="1.0" encoding="utf-8"?>
+<file path=ppt/slides/slide31.xml><?xml version="1.0" encoding="utf-8"?>
 <p:sld xmlns:a="http://schemas.openxmlformats.org/drawingml/2006/main" xmlns:r="http://schemas.openxmlformats.org/officeDocument/2006/relationships" xmlns:p="http://schemas.openxmlformats.org/presentationml/2006/main">
   <p:cSld>
     <p:spTree>
@@ -41861,7 +41925,7 @@
 </p:sld>
 </file>
 
-<file path=ppt/slides/slide31.xml><?xml version="1.0" encoding="utf-8"?>
+<file path=ppt/slides/slide32.xml><?xml version="1.0" encoding="utf-8"?>
 <p:sld xmlns:a="http://schemas.openxmlformats.org/drawingml/2006/main" xmlns:r="http://schemas.openxmlformats.org/officeDocument/2006/relationships" xmlns:p="http://schemas.openxmlformats.org/presentationml/2006/main">
   <p:cSld>
     <p:spTree>
@@ -41938,444 +42002,6 @@
     <p:extLst>
       <p:ext uri="{BB962C8B-B14F-4D97-AF65-F5344CB8AC3E}">
         <p14:creationId xmlns:p14="http://schemas.microsoft.com/office/powerpoint/2010/main" val="338773540"/>
-      </p:ext>
-    </p:extLst>
-  </p:cSld>
-  <p:clrMapOvr>
-    <a:masterClrMapping/>
-  </p:clrMapOvr>
-</p:sld>
-</file>
-
-<file path=ppt/slides/slide32.xml><?xml version="1.0" encoding="utf-8"?>
-<p:sld xmlns:a="http://schemas.openxmlformats.org/drawingml/2006/main" xmlns:r="http://schemas.openxmlformats.org/officeDocument/2006/relationships" xmlns:p="http://schemas.openxmlformats.org/presentationml/2006/main">
-  <p:cSld>
-    <p:spTree>
-      <p:nvGrpSpPr>
-        <p:cNvPr id="1" name=""/>
-        <p:cNvGrpSpPr/>
-        <p:nvPr/>
-      </p:nvGrpSpPr>
-      <p:grpSpPr>
-        <a:xfrm>
-          <a:off x="0" y="0"/>
-          <a:ext cx="0" cy="0"/>
-          <a:chOff x="0" y="0"/>
-          <a:chExt cx="0" cy="0"/>
-        </a:xfrm>
-      </p:grpSpPr>
-      <p:sp>
-        <p:nvSpPr>
-          <p:cNvPr id="2" name="Title 1"/>
-          <p:cNvSpPr>
-            <a:spLocks noGrp="1"/>
-          </p:cNvSpPr>
-          <p:nvPr>
-            <p:ph type="title"/>
-          </p:nvPr>
-        </p:nvSpPr>
-        <p:spPr>
-          <a:xfrm>
-            <a:off x="936516" y="749193"/>
-            <a:ext cx="4112737" cy="654492"/>
-          </a:xfrm>
-        </p:spPr>
-        <p:txBody>
-          <a:bodyPr/>
-          <a:lstStyle/>
-          <a:p>
-            <a:r>
-              <a:rPr lang="en-US" dirty="0"/>
-              <a:t>Integer Addition</a:t>
-            </a:r>
-          </a:p>
-        </p:txBody>
-      </p:sp>
-      <p:sp>
-        <p:nvSpPr>
-          <p:cNvPr id="5" name="Content Placeholder 4"/>
-          <p:cNvSpPr>
-            <a:spLocks noGrp="1"/>
-          </p:cNvSpPr>
-          <p:nvPr>
-            <p:ph idx="1"/>
-          </p:nvPr>
-        </p:nvSpPr>
-        <p:spPr>
-          <a:xfrm>
-            <a:off x="936516" y="1643270"/>
-            <a:ext cx="10433326" cy="4974098"/>
-          </a:xfrm>
-        </p:spPr>
-        <p:txBody>
-          <a:bodyPr>
-            <a:normAutofit/>
-          </a:bodyPr>
-          <a:lstStyle/>
-          <a:p>
-            <a:r>
-              <a:rPr lang="en-US" dirty="0">
-                <a:solidFill>
-                  <a:schemeClr val="tx1"/>
-                </a:solidFill>
-              </a:rPr>
-              <a:t>Instructions: </a:t>
-            </a:r>
-            <a:r>
-              <a:rPr lang="en-US" dirty="0">
-                <a:solidFill>
-                  <a:srgbClr val="0070C0"/>
-                </a:solidFill>
-              </a:rPr>
-              <a:t>ADD{</a:t>
-            </a:r>
-            <a:r>
-              <a:rPr lang="en-US" b="1" dirty="0">
-                <a:solidFill>
-                  <a:srgbClr val="FF0000"/>
-                </a:solidFill>
-              </a:rPr>
-              <a:t>S</a:t>
-            </a:r>
-            <a:r>
-              <a:rPr lang="en-US" dirty="0">
-                <a:solidFill>
-                  <a:srgbClr val="0070C0"/>
-                </a:solidFill>
-              </a:rPr>
-              <a:t>}</a:t>
-            </a:r>
-            <a:r>
-              <a:rPr lang="en-US" dirty="0">
-                <a:solidFill>
-                  <a:schemeClr val="tx1"/>
-                </a:solidFill>
-              </a:rPr>
-              <a:t>,</a:t>
-            </a:r>
-            <a:r>
-              <a:rPr lang="en-US" dirty="0">
-                <a:solidFill>
-                  <a:srgbClr val="0070C0"/>
-                </a:solidFill>
-              </a:rPr>
-              <a:t> ADC{</a:t>
-            </a:r>
-            <a:r>
-              <a:rPr lang="en-US" b="1" dirty="0">
-                <a:solidFill>
-                  <a:srgbClr val="FF0000"/>
-                </a:solidFill>
-              </a:rPr>
-              <a:t>S</a:t>
-            </a:r>
-            <a:r>
-              <a:rPr lang="en-US" dirty="0">
-                <a:solidFill>
-                  <a:srgbClr val="0070C0"/>
-                </a:solidFill>
-              </a:rPr>
-              <a:t>}</a:t>
-            </a:r>
-          </a:p>
-          <a:p>
-            <a:r>
-              <a:rPr lang="en-US" dirty="0">
-                <a:solidFill>
-                  <a:schemeClr val="tx1"/>
-                </a:solidFill>
-              </a:rPr>
-              <a:t>Format Examples:</a:t>
-            </a:r>
-          </a:p>
-          <a:p>
-            <a:pPr lvl="1"/>
-            <a:r>
-              <a:rPr lang="en-US" dirty="0">
-                <a:solidFill>
-                  <a:schemeClr val="tx1"/>
-                </a:solidFill>
-              </a:rPr>
-              <a:t>ADD	R0,R1,</a:t>
-            </a:r>
-            <a:r>
-              <a:rPr lang="en-US" b="1" dirty="0">
-                <a:solidFill>
-                  <a:srgbClr val="0000FF"/>
-                </a:solidFill>
-              </a:rPr>
-              <a:t>#5</a:t>
-            </a:r>
-            <a:r>
-              <a:rPr lang="en-US" dirty="0">
-                <a:solidFill>
-                  <a:schemeClr val="tx1"/>
-                </a:solidFill>
-              </a:rPr>
-              <a:t>			// R0 </a:t>
-            </a:r>
-            <a:r>
-              <a:rPr lang="en-US" dirty="0">
-                <a:solidFill>
-                  <a:schemeClr val="tx1"/>
-                </a:solidFill>
-                <a:sym typeface="Wingdings" panose="05000000000000000000" pitchFamily="2" charset="2"/>
-              </a:rPr>
-              <a:t>= R1 + 5</a:t>
-            </a:r>
-            <a:endParaRPr lang="en-US" dirty="0">
-              <a:solidFill>
-                <a:schemeClr val="tx1"/>
-              </a:solidFill>
-            </a:endParaRPr>
-          </a:p>
-          <a:p>
-            <a:pPr lvl="1"/>
-            <a:r>
-              <a:rPr lang="en-US" dirty="0">
-                <a:solidFill>
-                  <a:schemeClr val="tx1"/>
-                </a:solidFill>
-              </a:rPr>
-              <a:t>ADD	R0,R1,R2		// R0 </a:t>
-            </a:r>
-            <a:r>
-              <a:rPr lang="en-US" dirty="0">
-                <a:solidFill>
-                  <a:schemeClr val="tx1"/>
-                </a:solidFill>
-                <a:sym typeface="Wingdings" panose="05000000000000000000" pitchFamily="2" charset="2"/>
-              </a:rPr>
-              <a:t>= R1 + R2</a:t>
-            </a:r>
-            <a:endParaRPr lang="en-US" dirty="0">
-              <a:solidFill>
-                <a:schemeClr val="tx1"/>
-              </a:solidFill>
-            </a:endParaRPr>
-          </a:p>
-          <a:p>
-            <a:pPr lvl="1"/>
-            <a:r>
-              <a:rPr lang="en-US" dirty="0">
-                <a:solidFill>
-                  <a:schemeClr val="tx1"/>
-                </a:solidFill>
-              </a:rPr>
-              <a:t>ADD	R0,R1,</a:t>
-            </a:r>
-            <a:r>
-              <a:rPr lang="en-US" b="1" dirty="0">
-                <a:solidFill>
-                  <a:srgbClr val="0000FF"/>
-                </a:solidFill>
-              </a:rPr>
-              <a:t>R2,LSL #2</a:t>
-            </a:r>
-            <a:r>
-              <a:rPr lang="en-US" dirty="0">
-                <a:solidFill>
-                  <a:schemeClr val="tx1"/>
-                </a:solidFill>
-              </a:rPr>
-              <a:t>		// R0 </a:t>
-            </a:r>
-            <a:r>
-              <a:rPr lang="en-US" dirty="0">
-                <a:solidFill>
-                  <a:schemeClr val="tx1"/>
-                </a:solidFill>
-                <a:sym typeface="Wingdings" panose="05000000000000000000" pitchFamily="2" charset="2"/>
-              </a:rPr>
-              <a:t>= R1 + </a:t>
-            </a:r>
-            <a:r>
-              <a:rPr lang="en-US" b="1" dirty="0">
-                <a:solidFill>
-                  <a:srgbClr val="0000FF"/>
-                </a:solidFill>
-                <a:sym typeface="Wingdings" panose="05000000000000000000" pitchFamily="2" charset="2"/>
-              </a:rPr>
-              <a:t>(R2 &lt;&lt; 2)</a:t>
-            </a:r>
-            <a:endParaRPr lang="en-US" b="1" dirty="0">
-              <a:solidFill>
-                <a:srgbClr val="0000FF"/>
-              </a:solidFill>
-            </a:endParaRPr>
-          </a:p>
-          <a:p>
-            <a:r>
-              <a:rPr lang="en-US" dirty="0">
-                <a:solidFill>
-                  <a:schemeClr val="tx1"/>
-                </a:solidFill>
-              </a:rPr>
-              <a:t>Flags: </a:t>
-            </a:r>
-            <a:r>
-              <a:rPr lang="en-US" dirty="0">
-                <a:solidFill>
-                  <a:srgbClr val="0070C0"/>
-                </a:solidFill>
-              </a:rPr>
-              <a:t>Append “S” to capture result characteristics in NCVZ</a:t>
-            </a:r>
-          </a:p>
-          <a:p>
-            <a:endParaRPr lang="en-US" dirty="0"/>
-          </a:p>
-          <a:p>
-            <a:r>
-              <a:rPr lang="en-US" dirty="0">
-                <a:solidFill>
-                  <a:schemeClr val="tx1"/>
-                </a:solidFill>
-              </a:rPr>
-              <a:t>Overflow:</a:t>
-            </a:r>
-          </a:p>
-          <a:p>
-            <a:pPr lvl="1"/>
-            <a:r>
-              <a:rPr lang="en-US" b="1" dirty="0">
-                <a:solidFill>
-                  <a:srgbClr val="92D050"/>
-                </a:solidFill>
-              </a:rPr>
-              <a:t>Unsigned</a:t>
-            </a:r>
-            <a:r>
-              <a:rPr lang="en-US" dirty="0">
-                <a:solidFill>
-                  <a:srgbClr val="0070C0"/>
-                </a:solidFill>
-              </a:rPr>
-              <a:t>: Carry Flag (C) = 1</a:t>
-            </a:r>
-          </a:p>
-          <a:p>
-            <a:pPr lvl="1"/>
-            <a:r>
-              <a:rPr lang="en-US" dirty="0">
-                <a:solidFill>
-                  <a:srgbClr val="0070C0"/>
-                </a:solidFill>
-              </a:rPr>
-              <a:t>     </a:t>
-            </a:r>
-            <a:r>
-              <a:rPr lang="en-US" b="1" dirty="0">
-                <a:solidFill>
-                  <a:srgbClr val="FF0000"/>
-                </a:solidFill>
-              </a:rPr>
-              <a:t>Signed</a:t>
-            </a:r>
-            <a:r>
-              <a:rPr lang="en-US" dirty="0">
-                <a:solidFill>
-                  <a:srgbClr val="0070C0"/>
-                </a:solidFill>
-              </a:rPr>
-              <a:t>: Overflow Flag (V) = 1 (Set when C</a:t>
-            </a:r>
-            <a:r>
-              <a:rPr lang="en-US" baseline="-25000" dirty="0">
-                <a:solidFill>
-                  <a:srgbClr val="0070C0"/>
-                </a:solidFill>
-              </a:rPr>
-              <a:t>N</a:t>
-            </a:r>
-            <a:r>
-              <a:rPr lang="en-US" dirty="0">
-                <a:solidFill>
-                  <a:srgbClr val="0070C0"/>
-                </a:solidFill>
-              </a:rPr>
-              <a:t>≠C</a:t>
-            </a:r>
-            <a:r>
-              <a:rPr lang="en-US" baseline="-25000" dirty="0">
-                <a:solidFill>
-                  <a:srgbClr val="0070C0"/>
-                </a:solidFill>
-              </a:rPr>
-              <a:t>N-1</a:t>
-            </a:r>
-            <a:r>
-              <a:rPr lang="en-US" dirty="0">
-                <a:solidFill>
-                  <a:srgbClr val="0070C0"/>
-                </a:solidFill>
-              </a:rPr>
-              <a:t>)</a:t>
-            </a:r>
-          </a:p>
-          <a:p>
-            <a:endParaRPr lang="en-US" dirty="0"/>
-          </a:p>
-          <a:p>
-            <a:r>
-              <a:rPr lang="en-US" dirty="0">
-                <a:solidFill>
-                  <a:schemeClr val="tx1"/>
-                </a:solidFill>
-              </a:rPr>
-              <a:t>Multiple precision addition: </a:t>
-            </a:r>
-            <a:r>
-              <a:rPr lang="en-US" dirty="0">
-                <a:solidFill>
-                  <a:srgbClr val="0070C0"/>
-                </a:solidFill>
-              </a:rPr>
-              <a:t>ADD</a:t>
-            </a:r>
-            <a:r>
-              <a:rPr lang="en-US" b="1" dirty="0">
-                <a:solidFill>
-                  <a:srgbClr val="FF0000"/>
-                </a:solidFill>
-              </a:rPr>
-              <a:t>S</a:t>
-            </a:r>
-            <a:r>
-              <a:rPr lang="en-US" dirty="0">
-                <a:solidFill>
-                  <a:srgbClr val="0070C0"/>
-                </a:solidFill>
-              </a:rPr>
-              <a:t> </a:t>
-            </a:r>
-            <a:r>
-              <a:rPr lang="en-US" dirty="0">
-                <a:solidFill>
-                  <a:srgbClr val="0070C0"/>
-                </a:solidFill>
-                <a:sym typeface="Wingdings" panose="05000000000000000000" pitchFamily="2" charset="2"/>
-              </a:rPr>
-              <a:t> ADC</a:t>
-            </a:r>
-            <a:endParaRPr lang="en-US" dirty="0">
-              <a:solidFill>
-                <a:srgbClr val="0070C0"/>
-              </a:solidFill>
-            </a:endParaRPr>
-          </a:p>
-          <a:p>
-            <a:endParaRPr lang="en-US" dirty="0"/>
-          </a:p>
-          <a:p>
-            <a:endParaRPr lang="en-US" dirty="0"/>
-          </a:p>
-        </p:txBody>
-      </p:sp>
-    </p:spTree>
-    <p:extLst>
-      <p:ext uri="{BB962C8B-B14F-4D97-AF65-F5344CB8AC3E}">
-        <p14:creationId xmlns:p14="http://schemas.microsoft.com/office/powerpoint/2010/main" val="385189333"/>
       </p:ext>
     </p:extLst>
   </p:cSld>
@@ -42414,8 +42040,8 @@
         </p:nvSpPr>
         <p:spPr>
           <a:xfrm>
-            <a:off x="936516" y="749192"/>
-            <a:ext cx="4606031" cy="662513"/>
+            <a:off x="936516" y="749193"/>
+            <a:ext cx="4112737" cy="654492"/>
           </a:xfrm>
         </p:spPr>
         <p:txBody>
@@ -42424,467 +42050,396 @@
           <a:p>
             <a:r>
               <a:rPr lang="en-US" dirty="0"/>
-              <a:t>Integer Subtraction</a:t>
+              <a:t>Integer Addition</a:t>
             </a:r>
           </a:p>
         </p:txBody>
       </p:sp>
       <p:sp>
         <p:nvSpPr>
-          <p:cNvPr id="6" name="Content Placeholder 4"/>
-          <p:cNvSpPr txBox="1">
-            <a:spLocks/>
+          <p:cNvPr id="5" name="Content Placeholder 4"/>
+          <p:cNvSpPr>
+            <a:spLocks noGrp="1"/>
           </p:cNvSpPr>
-          <p:nvPr/>
+          <p:nvPr>
+            <p:ph idx="1"/>
+          </p:nvPr>
         </p:nvSpPr>
         <p:spPr>
           <a:xfrm>
-            <a:off x="936515" y="1708172"/>
-            <a:ext cx="10425305" cy="4953311"/>
+            <a:off x="936516" y="1643270"/>
+            <a:ext cx="10433326" cy="4974098"/>
           </a:xfrm>
-          <a:prstGeom prst="rect">
-            <a:avLst/>
-          </a:prstGeom>
         </p:spPr>
         <p:txBody>
-          <a:bodyPr vert="horz" lIns="68580" tIns="34290" rIns="68580" bIns="34290" rtlCol="0">
+          <a:bodyPr>
             <a:normAutofit/>
           </a:bodyPr>
-          <a:lstStyle>
-            <a:lvl1pPr marL="228600" indent="-228600" algn="l" defTabSz="914400" rtl="0" eaLnBrk="1" latinLnBrk="0" hangingPunct="1">
-              <a:lnSpc>
-                <a:spcPct val="90000"/>
-              </a:lnSpc>
-              <a:spcBef>
-                <a:spcPts val="1000"/>
-              </a:spcBef>
-              <a:buFont typeface="Arial" panose="020B0604020202020204" pitchFamily="34" charset="0"/>
-              <a:buChar char="•"/>
-              <a:defRPr sz="2800" kern="1200">
+          <a:lstStyle/>
+          <a:p>
+            <a:r>
+              <a:rPr lang="en-US" dirty="0">
                 <a:solidFill>
                   <a:schemeClr val="tx1"/>
                 </a:solidFill>
-                <a:latin typeface="+mn-lt"/>
-                <a:ea typeface="+mn-ea"/>
-                <a:cs typeface="+mn-cs"/>
-              </a:defRPr>
-            </a:lvl1pPr>
-            <a:lvl2pPr marL="685800" indent="-228600" algn="l" defTabSz="914400" rtl="0" eaLnBrk="1" latinLnBrk="0" hangingPunct="1">
-              <a:lnSpc>
-                <a:spcPct val="90000"/>
-              </a:lnSpc>
-              <a:spcBef>
-                <a:spcPts val="500"/>
-              </a:spcBef>
-              <a:buFont typeface="Arial" panose="020B0604020202020204" pitchFamily="34" charset="0"/>
-              <a:buChar char="•"/>
-              <a:defRPr sz="2400" kern="1200">
+              </a:rPr>
+              <a:t>Instructions: </a:t>
+            </a:r>
+            <a:r>
+              <a:rPr lang="en-US" dirty="0">
+                <a:solidFill>
+                  <a:srgbClr val="0070C0"/>
+                </a:solidFill>
+              </a:rPr>
+              <a:t>ADD{</a:t>
+            </a:r>
+            <a:r>
+              <a:rPr lang="en-US" b="1" dirty="0">
+                <a:solidFill>
+                  <a:srgbClr val="FF0000"/>
+                </a:solidFill>
+              </a:rPr>
+              <a:t>S</a:t>
+            </a:r>
+            <a:r>
+              <a:rPr lang="en-US" dirty="0">
+                <a:solidFill>
+                  <a:srgbClr val="0070C0"/>
+                </a:solidFill>
+              </a:rPr>
+              <a:t>}</a:t>
+            </a:r>
+            <a:r>
+              <a:rPr lang="en-US" dirty="0">
                 <a:solidFill>
                   <a:schemeClr val="tx1"/>
                 </a:solidFill>
-                <a:latin typeface="+mn-lt"/>
-                <a:ea typeface="+mn-ea"/>
-                <a:cs typeface="+mn-cs"/>
-              </a:defRPr>
-            </a:lvl2pPr>
-            <a:lvl3pPr marL="1143000" indent="-228600" algn="l" defTabSz="914400" rtl="0" eaLnBrk="1" latinLnBrk="0" hangingPunct="1">
-              <a:lnSpc>
-                <a:spcPct val="90000"/>
-              </a:lnSpc>
-              <a:spcBef>
-                <a:spcPts val="500"/>
-              </a:spcBef>
-              <a:buFont typeface="Arial" panose="020B0604020202020204" pitchFamily="34" charset="0"/>
-              <a:buChar char="•"/>
-              <a:defRPr sz="2000" kern="1200">
+              </a:rPr>
+              <a:t>,</a:t>
+            </a:r>
+            <a:r>
+              <a:rPr lang="en-US" dirty="0">
+                <a:solidFill>
+                  <a:srgbClr val="0070C0"/>
+                </a:solidFill>
+              </a:rPr>
+              <a:t> ADC{</a:t>
+            </a:r>
+            <a:r>
+              <a:rPr lang="en-US" b="1" dirty="0">
+                <a:solidFill>
+                  <a:srgbClr val="FF0000"/>
+                </a:solidFill>
+              </a:rPr>
+              <a:t>S</a:t>
+            </a:r>
+            <a:r>
+              <a:rPr lang="en-US" dirty="0">
+                <a:solidFill>
+                  <a:srgbClr val="0070C0"/>
+                </a:solidFill>
+              </a:rPr>
+              <a:t>}</a:t>
+            </a:r>
+          </a:p>
+          <a:p>
+            <a:r>
+              <a:rPr lang="en-US" dirty="0">
                 <a:solidFill>
                   <a:schemeClr val="tx1"/>
                 </a:solidFill>
-                <a:latin typeface="+mn-lt"/>
-                <a:ea typeface="+mn-ea"/>
-                <a:cs typeface="+mn-cs"/>
-              </a:defRPr>
-            </a:lvl3pPr>
-            <a:lvl4pPr marL="1600200" indent="-228600" algn="l" defTabSz="914400" rtl="0" eaLnBrk="1" latinLnBrk="0" hangingPunct="1">
-              <a:lnSpc>
-                <a:spcPct val="90000"/>
-              </a:lnSpc>
-              <a:spcBef>
-                <a:spcPts val="500"/>
-              </a:spcBef>
-              <a:buFont typeface="Arial" panose="020B0604020202020204" pitchFamily="34" charset="0"/>
-              <a:buChar char="•"/>
-              <a:defRPr sz="1800" kern="1200">
+              </a:rPr>
+              <a:t>Format Examples:</a:t>
+            </a:r>
+          </a:p>
+          <a:p>
+            <a:pPr lvl="1"/>
+            <a:r>
+              <a:rPr lang="en-US" dirty="0">
                 <a:solidFill>
                   <a:schemeClr val="tx1"/>
                 </a:solidFill>
-                <a:latin typeface="+mn-lt"/>
-                <a:ea typeface="+mn-ea"/>
-                <a:cs typeface="+mn-cs"/>
-              </a:defRPr>
-            </a:lvl4pPr>
-            <a:lvl5pPr marL="2057400" indent="-228600" algn="l" defTabSz="914400" rtl="0" eaLnBrk="1" latinLnBrk="0" hangingPunct="1">
-              <a:lnSpc>
-                <a:spcPct val="90000"/>
-              </a:lnSpc>
-              <a:spcBef>
-                <a:spcPts val="500"/>
-              </a:spcBef>
-              <a:buFont typeface="Arial" panose="020B0604020202020204" pitchFamily="34" charset="0"/>
-              <a:buChar char="•"/>
-              <a:defRPr sz="1800" kern="1200">
+              </a:rPr>
+              <a:t>ADD	R0,R1,</a:t>
+            </a:r>
+            <a:r>
+              <a:rPr lang="en-US" b="1" dirty="0">
+                <a:solidFill>
+                  <a:srgbClr val="0000FF"/>
+                </a:solidFill>
+              </a:rPr>
+              <a:t>#5</a:t>
+            </a:r>
+            <a:r>
+              <a:rPr lang="en-US" dirty="0">
                 <a:solidFill>
                   <a:schemeClr val="tx1"/>
                 </a:solidFill>
-                <a:latin typeface="+mn-lt"/>
-                <a:ea typeface="+mn-ea"/>
-                <a:cs typeface="+mn-cs"/>
-              </a:defRPr>
-            </a:lvl5pPr>
-            <a:lvl6pPr marL="2514600" indent="-228600" algn="l" defTabSz="914400" rtl="0" eaLnBrk="1" latinLnBrk="0" hangingPunct="1">
-              <a:lnSpc>
-                <a:spcPct val="90000"/>
-              </a:lnSpc>
-              <a:spcBef>
-                <a:spcPts val="500"/>
-              </a:spcBef>
-              <a:buFont typeface="Arial" panose="020B0604020202020204" pitchFamily="34" charset="0"/>
-              <a:buChar char="•"/>
-              <a:defRPr sz="1800" kern="1200">
+              </a:rPr>
+              <a:t>			// R0 </a:t>
+            </a:r>
+            <a:r>
+              <a:rPr lang="en-US" dirty="0">
                 <a:solidFill>
                   <a:schemeClr val="tx1"/>
                 </a:solidFill>
-                <a:latin typeface="+mn-lt"/>
-                <a:ea typeface="+mn-ea"/>
-                <a:cs typeface="+mn-cs"/>
-              </a:defRPr>
-            </a:lvl6pPr>
-            <a:lvl7pPr marL="2971800" indent="-228600" algn="l" defTabSz="914400" rtl="0" eaLnBrk="1" latinLnBrk="0" hangingPunct="1">
-              <a:lnSpc>
-                <a:spcPct val="90000"/>
-              </a:lnSpc>
-              <a:spcBef>
-                <a:spcPts val="500"/>
-              </a:spcBef>
-              <a:buFont typeface="Arial" panose="020B0604020202020204" pitchFamily="34" charset="0"/>
-              <a:buChar char="•"/>
-              <a:defRPr sz="1800" kern="1200">
+                <a:sym typeface="Wingdings" panose="05000000000000000000" pitchFamily="2" charset="2"/>
+              </a:rPr>
+              <a:t>= R1 + 5</a:t>
+            </a:r>
+            <a:endParaRPr lang="en-US" dirty="0">
+              <a:solidFill>
+                <a:schemeClr val="tx1"/>
+              </a:solidFill>
+            </a:endParaRPr>
+          </a:p>
+          <a:p>
+            <a:pPr lvl="1"/>
+            <a:r>
+              <a:rPr lang="en-US" dirty="0">
                 <a:solidFill>
                   <a:schemeClr val="tx1"/>
                 </a:solidFill>
-                <a:latin typeface="+mn-lt"/>
-                <a:ea typeface="+mn-ea"/>
-                <a:cs typeface="+mn-cs"/>
-              </a:defRPr>
-            </a:lvl7pPr>
-            <a:lvl8pPr marL="3429000" indent="-228600" algn="l" defTabSz="914400" rtl="0" eaLnBrk="1" latinLnBrk="0" hangingPunct="1">
-              <a:lnSpc>
-                <a:spcPct val="90000"/>
-              </a:lnSpc>
-              <a:spcBef>
-                <a:spcPts val="500"/>
-              </a:spcBef>
-              <a:buFont typeface="Arial" panose="020B0604020202020204" pitchFamily="34" charset="0"/>
-              <a:buChar char="•"/>
-              <a:defRPr sz="1800" kern="1200">
+              </a:rPr>
+              <a:t>ADD	R0,R1,R2		// R0 </a:t>
+            </a:r>
+            <a:r>
+              <a:rPr lang="en-US" dirty="0">
                 <a:solidFill>
                   <a:schemeClr val="tx1"/>
                 </a:solidFill>
-                <a:latin typeface="+mn-lt"/>
-                <a:ea typeface="+mn-ea"/>
-                <a:cs typeface="+mn-cs"/>
-              </a:defRPr>
-            </a:lvl8pPr>
-            <a:lvl9pPr marL="3886200" indent="-228600" algn="l" defTabSz="914400" rtl="0" eaLnBrk="1" latinLnBrk="0" hangingPunct="1">
-              <a:lnSpc>
-                <a:spcPct val="90000"/>
-              </a:lnSpc>
-              <a:spcBef>
-                <a:spcPts val="500"/>
-              </a:spcBef>
-              <a:buFont typeface="Arial" panose="020B0604020202020204" pitchFamily="34" charset="0"/>
-              <a:buChar char="•"/>
-              <a:defRPr sz="1800" kern="1200">
+                <a:sym typeface="Wingdings" panose="05000000000000000000" pitchFamily="2" charset="2"/>
+              </a:rPr>
+              <a:t>= R1 + R2</a:t>
+            </a:r>
+            <a:endParaRPr lang="en-US" dirty="0">
+              <a:solidFill>
+                <a:schemeClr val="tx1"/>
+              </a:solidFill>
+            </a:endParaRPr>
+          </a:p>
+          <a:p>
+            <a:pPr lvl="1"/>
+            <a:r>
+              <a:rPr lang="en-US" dirty="0">
                 <a:solidFill>
                   <a:schemeClr val="tx1"/>
                 </a:solidFill>
-                <a:latin typeface="+mn-lt"/>
-                <a:ea typeface="+mn-ea"/>
-                <a:cs typeface="+mn-cs"/>
-              </a:defRPr>
-            </a:lvl9pPr>
-          </a:lstStyle>
-          <a:p>
-            <a:r>
-              <a:rPr lang="en-US" sz="2100" dirty="0"/>
-              <a:t>Instructions: </a:t>
-            </a:r>
-            <a:r>
-              <a:rPr lang="en-US" sz="2100" dirty="0">
+              </a:rPr>
+              <a:t>ADD	R0,R1,</a:t>
+            </a:r>
+            <a:r>
+              <a:rPr lang="en-US" b="1" dirty="0">
+                <a:solidFill>
+                  <a:srgbClr val="0000FF"/>
+                </a:solidFill>
+              </a:rPr>
+              <a:t>R2,LSL #2</a:t>
+            </a:r>
+            <a:r>
+              <a:rPr lang="en-US" dirty="0">
+                <a:solidFill>
+                  <a:schemeClr val="tx1"/>
+                </a:solidFill>
+              </a:rPr>
+              <a:t>		// R0 </a:t>
+            </a:r>
+            <a:r>
+              <a:rPr lang="en-US" dirty="0">
+                <a:solidFill>
+                  <a:schemeClr val="tx1"/>
+                </a:solidFill>
+                <a:sym typeface="Wingdings" panose="05000000000000000000" pitchFamily="2" charset="2"/>
+              </a:rPr>
+              <a:t>= R1 + </a:t>
+            </a:r>
+            <a:r>
+              <a:rPr lang="en-US" b="1" dirty="0">
+                <a:solidFill>
+                  <a:srgbClr val="0000FF"/>
+                </a:solidFill>
+                <a:sym typeface="Wingdings" panose="05000000000000000000" pitchFamily="2" charset="2"/>
+              </a:rPr>
+              <a:t>(R2 &lt;&lt; 2)</a:t>
+            </a:r>
+            <a:endParaRPr lang="en-US" b="1" dirty="0">
+              <a:solidFill>
+                <a:srgbClr val="0000FF"/>
+              </a:solidFill>
+            </a:endParaRPr>
+          </a:p>
+          <a:p>
+            <a:r>
+              <a:rPr lang="en-US" dirty="0">
+                <a:solidFill>
+                  <a:schemeClr val="tx1"/>
+                </a:solidFill>
+              </a:rPr>
+              <a:t>Flags: </a:t>
+            </a:r>
+            <a:r>
+              <a:rPr lang="en-US" dirty="0">
                 <a:solidFill>
                   <a:srgbClr val="0070C0"/>
                 </a:solidFill>
               </a:rPr>
-              <a:t>SUB{S}, SBC{S}, RSB{S}</a:t>
-            </a:r>
-          </a:p>
-          <a:p>
-            <a:r>
-              <a:rPr lang="en-US" sz="2100" dirty="0"/>
-              <a:t>Format Examples:</a:t>
+              <a:t>Append “S” to capture result characteristics in NCVZ</a:t>
+            </a:r>
+          </a:p>
+          <a:p>
+            <a:endParaRPr lang="en-US" dirty="0"/>
+          </a:p>
+          <a:p>
+            <a:r>
+              <a:rPr lang="en-US" dirty="0">
+                <a:solidFill>
+                  <a:schemeClr val="tx1"/>
+                </a:solidFill>
+              </a:rPr>
+              <a:t>Overflow:</a:t>
             </a:r>
           </a:p>
           <a:p>
             <a:pPr lvl="1"/>
             <a:r>
-              <a:rPr lang="en-US" sz="1800" dirty="0"/>
-              <a:t>SUB	R0,R1,</a:t>
-            </a:r>
-            <a:r>
-              <a:rPr lang="en-US" sz="1800" b="1" dirty="0">
-                <a:solidFill>
-                  <a:srgbClr val="0000FF"/>
-                </a:solidFill>
-              </a:rPr>
-              <a:t>#5</a:t>
-            </a:r>
-            <a:r>
-              <a:rPr lang="en-US" sz="1800" dirty="0"/>
-              <a:t>		// R0 </a:t>
-            </a:r>
-            <a:r>
-              <a:rPr lang="en-US" sz="1800" dirty="0">
+              <a:rPr lang="en-US" b="1" dirty="0">
+                <a:solidFill>
+                  <a:srgbClr val="92D050"/>
+                </a:solidFill>
+              </a:rPr>
+              <a:t>Unsigned</a:t>
+            </a:r>
+            <a:r>
+              <a:rPr lang="en-US" dirty="0">
+                <a:solidFill>
+                  <a:srgbClr val="0070C0"/>
+                </a:solidFill>
+              </a:rPr>
+              <a:t>: Carry Flag (C) = 1</a:t>
+            </a:r>
+          </a:p>
+          <a:p>
+            <a:pPr lvl="1"/>
+            <a:r>
+              <a:rPr lang="en-US" dirty="0">
+                <a:solidFill>
+                  <a:srgbClr val="0070C0"/>
+                </a:solidFill>
+              </a:rPr>
+              <a:t>     </a:t>
+            </a:r>
+            <a:r>
+              <a:rPr lang="en-US" b="1" dirty="0">
+                <a:solidFill>
+                  <a:srgbClr val="FF0000"/>
+                </a:solidFill>
+              </a:rPr>
+              <a:t>Signed</a:t>
+            </a:r>
+            <a:r>
+              <a:rPr lang="en-US" dirty="0">
+                <a:solidFill>
+                  <a:srgbClr val="0070C0"/>
+                </a:solidFill>
+              </a:rPr>
+              <a:t>: Overflow Flag (V) = 1 (Set when C</a:t>
+            </a:r>
+            <a:r>
+              <a:rPr lang="en-US" baseline="-25000" dirty="0">
+                <a:solidFill>
+                  <a:srgbClr val="0070C0"/>
+                </a:solidFill>
+              </a:rPr>
+              <a:t>N</a:t>
+            </a:r>
+            <a:r>
+              <a:rPr lang="en-US" dirty="0">
+                <a:solidFill>
+                  <a:srgbClr val="0070C0"/>
+                </a:solidFill>
+              </a:rPr>
+              <a:t>≠C</a:t>
+            </a:r>
+            <a:r>
+              <a:rPr lang="en-US" baseline="-25000" dirty="0">
+                <a:solidFill>
+                  <a:srgbClr val="0070C0"/>
+                </a:solidFill>
+              </a:rPr>
+              <a:t>N-1</a:t>
+            </a:r>
+            <a:r>
+              <a:rPr lang="en-US" dirty="0">
+                <a:solidFill>
+                  <a:srgbClr val="0070C0"/>
+                </a:solidFill>
+              </a:rPr>
+              <a:t>)</a:t>
+            </a:r>
+          </a:p>
+          <a:p>
+            <a:endParaRPr lang="en-US" dirty="0"/>
+          </a:p>
+          <a:p>
+            <a:r>
+              <a:rPr lang="en-US" dirty="0">
+                <a:solidFill>
+                  <a:schemeClr val="tx1"/>
+                </a:solidFill>
+              </a:rPr>
+              <a:t>Multiple precision addition: </a:t>
+            </a:r>
+            <a:r>
+              <a:rPr lang="en-US" dirty="0">
+                <a:solidFill>
+                  <a:srgbClr val="0070C0"/>
+                </a:solidFill>
+              </a:rPr>
+              <a:t>ADD</a:t>
+            </a:r>
+            <a:r>
+              <a:rPr lang="en-US" b="1" dirty="0">
+                <a:solidFill>
+                  <a:srgbClr val="FF0000"/>
+                </a:solidFill>
+              </a:rPr>
+              <a:t>S</a:t>
+            </a:r>
+            <a:r>
+              <a:rPr lang="en-US" dirty="0">
+                <a:solidFill>
+                  <a:srgbClr val="0070C0"/>
+                </a:solidFill>
+              </a:rPr>
+              <a:t> </a:t>
+            </a:r>
+            <a:r>
+              <a:rPr lang="en-US" dirty="0">
+                <a:solidFill>
+                  <a:srgbClr val="0070C0"/>
+                </a:solidFill>
                 <a:sym typeface="Wingdings" panose="05000000000000000000" pitchFamily="2" charset="2"/>
               </a:rPr>
-              <a:t>= R1 - 5</a:t>
-            </a:r>
-            <a:endParaRPr lang="en-US" sz="1800" dirty="0"/>
-          </a:p>
-          <a:p>
-            <a:pPr lvl="1"/>
-            <a:r>
-              <a:rPr lang="en-US" sz="1800" dirty="0"/>
-              <a:t>SUB	R0,R1,R2		// R0 </a:t>
-            </a:r>
-            <a:r>
-              <a:rPr lang="en-US" sz="1800" dirty="0">
-                <a:sym typeface="Wingdings" panose="05000000000000000000" pitchFamily="2" charset="2"/>
-              </a:rPr>
-              <a:t>= R1 - R2</a:t>
-            </a:r>
-            <a:endParaRPr lang="en-US" sz="1800" dirty="0"/>
-          </a:p>
-          <a:p>
-            <a:pPr lvl="1"/>
-            <a:r>
-              <a:rPr lang="en-US" sz="1800" dirty="0"/>
-              <a:t>SUB	R0,R1,</a:t>
-            </a:r>
-            <a:r>
-              <a:rPr lang="en-US" sz="1800" b="1" dirty="0">
-                <a:solidFill>
-                  <a:srgbClr val="0000FF"/>
-                </a:solidFill>
-              </a:rPr>
-              <a:t>R2,LSL #2</a:t>
-            </a:r>
-            <a:r>
-              <a:rPr lang="en-US" sz="1800" dirty="0"/>
-              <a:t>		// R0 </a:t>
-            </a:r>
-            <a:r>
-              <a:rPr lang="en-US" sz="1800" dirty="0">
-                <a:sym typeface="Wingdings" panose="05000000000000000000" pitchFamily="2" charset="2"/>
-              </a:rPr>
-              <a:t>= R1 - </a:t>
-            </a:r>
-            <a:r>
-              <a:rPr lang="en-US" sz="1800" b="1" dirty="0">
-                <a:solidFill>
-                  <a:srgbClr val="0000FF"/>
-                </a:solidFill>
-                <a:sym typeface="Wingdings" panose="05000000000000000000" pitchFamily="2" charset="2"/>
-              </a:rPr>
-              <a:t>(R2 &lt;&lt; 2)</a:t>
-            </a:r>
-            <a:r>
-              <a:rPr lang="en-US" sz="1800" dirty="0">
-                <a:solidFill>
-                  <a:srgbClr val="0070C0"/>
-                </a:solidFill>
-                <a:sym typeface="Wingdings" panose="05000000000000000000" pitchFamily="2" charset="2"/>
-              </a:rPr>
-              <a:t>	</a:t>
-            </a:r>
-            <a:endParaRPr lang="en-US" sz="1800" dirty="0">
+              <a:t> ADC</a:t>
+            </a:r>
+            <a:endParaRPr lang="en-US" dirty="0">
               <a:solidFill>
                 <a:srgbClr val="0070C0"/>
               </a:solidFill>
             </a:endParaRPr>
           </a:p>
           <a:p>
-            <a:endParaRPr lang="en-US" sz="2100" dirty="0"/>
-          </a:p>
-          <a:p>
-            <a:r>
-              <a:rPr lang="en-US" sz="2100" dirty="0"/>
-              <a:t>Flags: </a:t>
-            </a:r>
-            <a:r>
-              <a:rPr lang="en-US" sz="2100" dirty="0">
-                <a:solidFill>
-                  <a:srgbClr val="0070C0"/>
-                </a:solidFill>
-              </a:rPr>
-              <a:t>Append “S” to capture result characteristics in NCVZ</a:t>
-            </a:r>
-          </a:p>
-          <a:p>
-            <a:endParaRPr lang="en-US" sz="2100" dirty="0"/>
-          </a:p>
-          <a:p>
-            <a:r>
-              <a:rPr lang="en-US" sz="2100" dirty="0"/>
-              <a:t>Overflow:</a:t>
-            </a:r>
-          </a:p>
-          <a:p>
-            <a:pPr lvl="1"/>
-            <a:r>
-              <a:rPr lang="en-US" sz="1800" b="1" dirty="0">
-                <a:solidFill>
-                  <a:srgbClr val="92D050"/>
-                </a:solidFill>
-              </a:rPr>
-              <a:t>Unsigned</a:t>
-            </a:r>
-            <a:r>
-              <a:rPr lang="en-US" sz="1800" dirty="0">
-                <a:solidFill>
-                  <a:srgbClr val="0070C0"/>
-                </a:solidFill>
-              </a:rPr>
-              <a:t>: Carry Flag       (C) = 0</a:t>
-            </a:r>
-          </a:p>
-          <a:p>
-            <a:pPr lvl="1"/>
-            <a:r>
-              <a:rPr lang="en-US" sz="1800" dirty="0">
-                <a:solidFill>
-                  <a:srgbClr val="0070C0"/>
-                </a:solidFill>
-              </a:rPr>
-              <a:t>     </a:t>
-            </a:r>
-            <a:r>
-              <a:rPr lang="en-US" sz="1800" b="1" dirty="0">
-                <a:solidFill>
-                  <a:srgbClr val="FF0000"/>
-                </a:solidFill>
-              </a:rPr>
-              <a:t>Signed</a:t>
-            </a:r>
-            <a:r>
-              <a:rPr lang="en-US" sz="1800" dirty="0">
-                <a:solidFill>
-                  <a:srgbClr val="0070C0"/>
-                </a:solidFill>
-              </a:rPr>
-              <a:t>: Overflow Flag (V) = 1 (Set when C</a:t>
-            </a:r>
-            <a:r>
-              <a:rPr lang="en-US" sz="1800" baseline="-25000" dirty="0">
-                <a:solidFill>
-                  <a:srgbClr val="0070C0"/>
-                </a:solidFill>
-              </a:rPr>
-              <a:t>N</a:t>
-            </a:r>
-            <a:r>
-              <a:rPr lang="en-US" sz="1800" dirty="0">
-                <a:solidFill>
-                  <a:srgbClr val="0070C0"/>
-                </a:solidFill>
-              </a:rPr>
-              <a:t>≠C</a:t>
-            </a:r>
-            <a:r>
-              <a:rPr lang="en-US" sz="1800" baseline="-25000" dirty="0">
-                <a:solidFill>
-                  <a:srgbClr val="0070C0"/>
-                </a:solidFill>
-              </a:rPr>
-              <a:t>N-1</a:t>
-            </a:r>
-            <a:r>
-              <a:rPr lang="en-US" sz="1800" dirty="0">
-                <a:solidFill>
-                  <a:srgbClr val="0070C0"/>
-                </a:solidFill>
-              </a:rPr>
-              <a:t>)</a:t>
-            </a:r>
-          </a:p>
-          <a:p>
-            <a:endParaRPr lang="en-US" sz="2100" dirty="0"/>
-          </a:p>
-          <a:p>
-            <a:r>
-              <a:rPr lang="en-US" sz="2100" dirty="0"/>
-              <a:t>Multiple precision subtraction: </a:t>
-            </a:r>
-            <a:r>
-              <a:rPr lang="en-US" sz="2100" dirty="0">
-                <a:solidFill>
-                  <a:srgbClr val="0070C0"/>
-                </a:solidFill>
-              </a:rPr>
-              <a:t>SUB</a:t>
-            </a:r>
-            <a:r>
-              <a:rPr lang="en-US" sz="2100" b="1" dirty="0">
-                <a:solidFill>
-                  <a:srgbClr val="FF0000"/>
-                </a:solidFill>
-              </a:rPr>
-              <a:t>S</a:t>
-            </a:r>
-            <a:r>
-              <a:rPr lang="en-US" sz="2100" dirty="0">
-                <a:solidFill>
-                  <a:srgbClr val="0070C0"/>
-                </a:solidFill>
-              </a:rPr>
-              <a:t> </a:t>
-            </a:r>
-            <a:r>
-              <a:rPr lang="en-US" sz="2100" dirty="0">
-                <a:solidFill>
-                  <a:srgbClr val="0070C0"/>
-                </a:solidFill>
-                <a:sym typeface="Wingdings" panose="05000000000000000000" pitchFamily="2" charset="2"/>
-              </a:rPr>
-              <a:t> SBC</a:t>
-            </a:r>
-            <a:endParaRPr lang="en-US" sz="2100" dirty="0">
-              <a:solidFill>
-                <a:srgbClr val="0070C0"/>
-              </a:solidFill>
-            </a:endParaRPr>
-          </a:p>
-          <a:p>
-            <a:endParaRPr lang="en-US" sz="2100" dirty="0"/>
-          </a:p>
-          <a:p>
-            <a:endParaRPr lang="en-US" sz="2100" dirty="0"/>
+            <a:endParaRPr lang="en-US" dirty="0"/>
+          </a:p>
+          <a:p>
+            <a:endParaRPr lang="en-US" dirty="0"/>
           </a:p>
         </p:txBody>
       </p:sp>
     </p:spTree>
     <p:extLst>
       <p:ext uri="{BB962C8B-B14F-4D97-AF65-F5344CB8AC3E}">
-        <p14:creationId xmlns:p14="http://schemas.microsoft.com/office/powerpoint/2010/main" val="2046813644"/>
+        <p14:creationId xmlns:p14="http://schemas.microsoft.com/office/powerpoint/2010/main" val="385189333"/>
       </p:ext>
     </p:extLst>
   </p:cSld>
@@ -42923,355 +42478,477 @@
         </p:nvSpPr>
         <p:spPr>
           <a:xfrm>
-            <a:off x="936516" y="745181"/>
-            <a:ext cx="9466789" cy="686577"/>
+            <a:off x="936516" y="749192"/>
+            <a:ext cx="4606031" cy="662513"/>
           </a:xfrm>
         </p:spPr>
         <p:txBody>
-          <a:bodyPr>
-            <a:normAutofit/>
-          </a:bodyPr>
+          <a:bodyPr/>
           <a:lstStyle/>
           <a:p>
             <a:r>
               <a:rPr lang="en-US" dirty="0"/>
-              <a:t>Single-Length 32x32 Integer Multiplication</a:t>
+              <a:t>Integer Subtraction</a:t>
             </a:r>
           </a:p>
         </p:txBody>
       </p:sp>
       <p:sp>
         <p:nvSpPr>
-          <p:cNvPr id="3" name="Content Placeholder 2"/>
-          <p:cNvSpPr>
-            <a:spLocks noGrp="1"/>
+          <p:cNvPr id="6" name="Content Placeholder 4"/>
+          <p:cNvSpPr txBox="1">
+            <a:spLocks/>
           </p:cNvSpPr>
-          <p:nvPr>
-            <p:ph idx="1"/>
-          </p:nvPr>
+          <p:nvPr/>
         </p:nvSpPr>
         <p:spPr>
           <a:xfrm>
-            <a:off x="936515" y="1807701"/>
-            <a:ext cx="10441347" cy="4841752"/>
+            <a:off x="936515" y="1708172"/>
+            <a:ext cx="10425305" cy="4953311"/>
           </a:xfrm>
+          <a:prstGeom prst="rect">
+            <a:avLst/>
+          </a:prstGeom>
         </p:spPr>
         <p:txBody>
-          <a:bodyPr>
-            <a:normAutofit lnSpcReduction="10000"/>
+          <a:bodyPr vert="horz" lIns="68580" tIns="34290" rIns="68580" bIns="34290" rtlCol="0">
+            <a:normAutofit/>
           </a:bodyPr>
-          <a:lstStyle/>
-          <a:p>
-            <a:r>
-              <a:rPr lang="en-US" dirty="0">
+          <a:lstStyle>
+            <a:lvl1pPr marL="228600" indent="-228600" algn="l" defTabSz="914400" rtl="0" eaLnBrk="1" latinLnBrk="0" hangingPunct="1">
+              <a:lnSpc>
+                <a:spcPct val="90000"/>
+              </a:lnSpc>
+              <a:spcBef>
+                <a:spcPts val="1000"/>
+              </a:spcBef>
+              <a:buFont typeface="Arial" panose="020B0604020202020204" pitchFamily="34" charset="0"/>
+              <a:buChar char="•"/>
+              <a:defRPr sz="2800" kern="1200">
                 <a:solidFill>
                   <a:schemeClr val="tx1"/>
                 </a:solidFill>
-              </a:rPr>
-              <a:t>Instructions:</a:t>
-            </a:r>
-            <a:r>
-              <a:rPr lang="en-US" dirty="0"/>
+                <a:latin typeface="+mn-lt"/>
+                <a:ea typeface="+mn-ea"/>
+                <a:cs typeface="+mn-cs"/>
+              </a:defRPr>
+            </a:lvl1pPr>
+            <a:lvl2pPr marL="685800" indent="-228600" algn="l" defTabSz="914400" rtl="0" eaLnBrk="1" latinLnBrk="0" hangingPunct="1">
+              <a:lnSpc>
+                <a:spcPct val="90000"/>
+              </a:lnSpc>
+              <a:spcBef>
+                <a:spcPts val="500"/>
+              </a:spcBef>
+              <a:buFont typeface="Arial" panose="020B0604020202020204" pitchFamily="34" charset="0"/>
+              <a:buChar char="•"/>
+              <a:defRPr sz="2400" kern="1200">
+                <a:solidFill>
+                  <a:schemeClr val="tx1"/>
+                </a:solidFill>
+                <a:latin typeface="+mn-lt"/>
+                <a:ea typeface="+mn-ea"/>
+                <a:cs typeface="+mn-cs"/>
+              </a:defRPr>
+            </a:lvl2pPr>
+            <a:lvl3pPr marL="1143000" indent="-228600" algn="l" defTabSz="914400" rtl="0" eaLnBrk="1" latinLnBrk="0" hangingPunct="1">
+              <a:lnSpc>
+                <a:spcPct val="90000"/>
+              </a:lnSpc>
+              <a:spcBef>
+                <a:spcPts val="500"/>
+              </a:spcBef>
+              <a:buFont typeface="Arial" panose="020B0604020202020204" pitchFamily="34" charset="0"/>
+              <a:buChar char="•"/>
+              <a:defRPr sz="2000" kern="1200">
+                <a:solidFill>
+                  <a:schemeClr val="tx1"/>
+                </a:solidFill>
+                <a:latin typeface="+mn-lt"/>
+                <a:ea typeface="+mn-ea"/>
+                <a:cs typeface="+mn-cs"/>
+              </a:defRPr>
+            </a:lvl3pPr>
+            <a:lvl4pPr marL="1600200" indent="-228600" algn="l" defTabSz="914400" rtl="0" eaLnBrk="1" latinLnBrk="0" hangingPunct="1">
+              <a:lnSpc>
+                <a:spcPct val="90000"/>
+              </a:lnSpc>
+              <a:spcBef>
+                <a:spcPts val="500"/>
+              </a:spcBef>
+              <a:buFont typeface="Arial" panose="020B0604020202020204" pitchFamily="34" charset="0"/>
+              <a:buChar char="•"/>
+              <a:defRPr sz="1800" kern="1200">
+                <a:solidFill>
+                  <a:schemeClr val="tx1"/>
+                </a:solidFill>
+                <a:latin typeface="+mn-lt"/>
+                <a:ea typeface="+mn-ea"/>
+                <a:cs typeface="+mn-cs"/>
+              </a:defRPr>
+            </a:lvl4pPr>
+            <a:lvl5pPr marL="2057400" indent="-228600" algn="l" defTabSz="914400" rtl="0" eaLnBrk="1" latinLnBrk="0" hangingPunct="1">
+              <a:lnSpc>
+                <a:spcPct val="90000"/>
+              </a:lnSpc>
+              <a:spcBef>
+                <a:spcPts val="500"/>
+              </a:spcBef>
+              <a:buFont typeface="Arial" panose="020B0604020202020204" pitchFamily="34" charset="0"/>
+              <a:buChar char="•"/>
+              <a:defRPr sz="1800" kern="1200">
+                <a:solidFill>
+                  <a:schemeClr val="tx1"/>
+                </a:solidFill>
+                <a:latin typeface="+mn-lt"/>
+                <a:ea typeface="+mn-ea"/>
+                <a:cs typeface="+mn-cs"/>
+              </a:defRPr>
+            </a:lvl5pPr>
+            <a:lvl6pPr marL="2514600" indent="-228600" algn="l" defTabSz="914400" rtl="0" eaLnBrk="1" latinLnBrk="0" hangingPunct="1">
+              <a:lnSpc>
+                <a:spcPct val="90000"/>
+              </a:lnSpc>
+              <a:spcBef>
+                <a:spcPts val="500"/>
+              </a:spcBef>
+              <a:buFont typeface="Arial" panose="020B0604020202020204" pitchFamily="34" charset="0"/>
+              <a:buChar char="•"/>
+              <a:defRPr sz="1800" kern="1200">
+                <a:solidFill>
+                  <a:schemeClr val="tx1"/>
+                </a:solidFill>
+                <a:latin typeface="+mn-lt"/>
+                <a:ea typeface="+mn-ea"/>
+                <a:cs typeface="+mn-cs"/>
+              </a:defRPr>
+            </a:lvl6pPr>
+            <a:lvl7pPr marL="2971800" indent="-228600" algn="l" defTabSz="914400" rtl="0" eaLnBrk="1" latinLnBrk="0" hangingPunct="1">
+              <a:lnSpc>
+                <a:spcPct val="90000"/>
+              </a:lnSpc>
+              <a:spcBef>
+                <a:spcPts val="500"/>
+              </a:spcBef>
+              <a:buFont typeface="Arial" panose="020B0604020202020204" pitchFamily="34" charset="0"/>
+              <a:buChar char="•"/>
+              <a:defRPr sz="1800" kern="1200">
+                <a:solidFill>
+                  <a:schemeClr val="tx1"/>
+                </a:solidFill>
+                <a:latin typeface="+mn-lt"/>
+                <a:ea typeface="+mn-ea"/>
+                <a:cs typeface="+mn-cs"/>
+              </a:defRPr>
+            </a:lvl7pPr>
+            <a:lvl8pPr marL="3429000" indent="-228600" algn="l" defTabSz="914400" rtl="0" eaLnBrk="1" latinLnBrk="0" hangingPunct="1">
+              <a:lnSpc>
+                <a:spcPct val="90000"/>
+              </a:lnSpc>
+              <a:spcBef>
+                <a:spcPts val="500"/>
+              </a:spcBef>
+              <a:buFont typeface="Arial" panose="020B0604020202020204" pitchFamily="34" charset="0"/>
+              <a:buChar char="•"/>
+              <a:defRPr sz="1800" kern="1200">
+                <a:solidFill>
+                  <a:schemeClr val="tx1"/>
+                </a:solidFill>
+                <a:latin typeface="+mn-lt"/>
+                <a:ea typeface="+mn-ea"/>
+                <a:cs typeface="+mn-cs"/>
+              </a:defRPr>
+            </a:lvl8pPr>
+            <a:lvl9pPr marL="3886200" indent="-228600" algn="l" defTabSz="914400" rtl="0" eaLnBrk="1" latinLnBrk="0" hangingPunct="1">
+              <a:lnSpc>
+                <a:spcPct val="90000"/>
+              </a:lnSpc>
+              <a:spcBef>
+                <a:spcPts val="500"/>
+              </a:spcBef>
+              <a:buFont typeface="Arial" panose="020B0604020202020204" pitchFamily="34" charset="0"/>
+              <a:buChar char="•"/>
+              <a:defRPr sz="1800" kern="1200">
+                <a:solidFill>
+                  <a:schemeClr val="tx1"/>
+                </a:solidFill>
+                <a:latin typeface="+mn-lt"/>
+                <a:ea typeface="+mn-ea"/>
+                <a:cs typeface="+mn-cs"/>
+              </a:defRPr>
+            </a:lvl9pPr>
+          </a:lstStyle>
+          <a:p>
+            <a:r>
+              <a:rPr lang="en-US" sz="2100" dirty="0"/>
+              <a:t>Instructions: </a:t>
+            </a:r>
+            <a:r>
+              <a:rPr lang="en-US" sz="2100" dirty="0">
+                <a:solidFill>
+                  <a:srgbClr val="0070C0"/>
+                </a:solidFill>
+              </a:rPr>
+              <a:t>SUB{S}, SBC{S}, RSB{S}</a:t>
+            </a:r>
+          </a:p>
+          <a:p>
+            <a:r>
+              <a:rPr lang="en-US" sz="2100" dirty="0"/>
+              <a:t>Format Examples:</a:t>
+            </a:r>
+          </a:p>
+          <a:p>
+            <a:pPr lvl="1"/>
+            <a:r>
+              <a:rPr lang="en-US" sz="1800" dirty="0"/>
+              <a:t>SUB	R0,R1,</a:t>
+            </a:r>
+            <a:r>
+              <a:rPr lang="en-US" sz="1800" b="1" dirty="0">
+                <a:solidFill>
+                  <a:srgbClr val="0000FF"/>
+                </a:solidFill>
+              </a:rPr>
+              <a:t>#5</a:t>
+            </a:r>
+            <a:r>
+              <a:rPr lang="en-US" sz="1800" dirty="0"/>
+              <a:t>		// R0 </a:t>
+            </a:r>
+            <a:r>
+              <a:rPr lang="en-US" sz="1800" dirty="0">
+                <a:sym typeface="Wingdings" panose="05000000000000000000" pitchFamily="2" charset="2"/>
+              </a:rPr>
+              <a:t>= R1 - 5</a:t>
+            </a:r>
+            <a:endParaRPr lang="en-US" sz="1800" dirty="0"/>
+          </a:p>
+          <a:p>
+            <a:pPr lvl="1"/>
+            <a:r>
+              <a:rPr lang="en-US" sz="1800" dirty="0"/>
+              <a:t>SUB	R0,R1,R2		// R0 </a:t>
+            </a:r>
+            <a:r>
+              <a:rPr lang="en-US" sz="1800" dirty="0">
+                <a:sym typeface="Wingdings" panose="05000000000000000000" pitchFamily="2" charset="2"/>
+              </a:rPr>
+              <a:t>= R1 - R2</a:t>
+            </a:r>
+            <a:endParaRPr lang="en-US" sz="1800" dirty="0"/>
+          </a:p>
+          <a:p>
+            <a:pPr lvl="1"/>
+            <a:r>
+              <a:rPr lang="en-US" sz="1800" dirty="0"/>
+              <a:t>SUB	R0,R1,</a:t>
+            </a:r>
+            <a:r>
+              <a:rPr lang="en-US" sz="1800" b="1" dirty="0">
+                <a:solidFill>
+                  <a:srgbClr val="0000FF"/>
+                </a:solidFill>
+              </a:rPr>
+              <a:t>R2,LSL #2</a:t>
+            </a:r>
+            <a:r>
+              <a:rPr lang="en-US" sz="1800" dirty="0"/>
+              <a:t>		// R0 </a:t>
+            </a:r>
+            <a:r>
+              <a:rPr lang="en-US" sz="1800" dirty="0">
+                <a:sym typeface="Wingdings" panose="05000000000000000000" pitchFamily="2" charset="2"/>
+              </a:rPr>
+              <a:t>= R1 - </a:t>
+            </a:r>
+            <a:r>
+              <a:rPr lang="en-US" sz="1800" b="1" dirty="0">
+                <a:solidFill>
+                  <a:srgbClr val="0000FF"/>
+                </a:solidFill>
+                <a:sym typeface="Wingdings" panose="05000000000000000000" pitchFamily="2" charset="2"/>
+              </a:rPr>
+              <a:t>(R2 &lt;&lt; 2)</a:t>
+            </a:r>
+            <a:r>
+              <a:rPr lang="en-US" sz="1800" dirty="0">
+                <a:solidFill>
+                  <a:srgbClr val="0070C0"/>
+                </a:solidFill>
+                <a:sym typeface="Wingdings" panose="05000000000000000000" pitchFamily="2" charset="2"/>
+              </a:rPr>
+              <a:t>	</a:t>
+            </a:r>
+            <a:endParaRPr lang="en-US" sz="1800" dirty="0">
+              <a:solidFill>
+                <a:srgbClr val="0070C0"/>
+              </a:solidFill>
+            </a:endParaRPr>
+          </a:p>
+          <a:p>
+            <a:endParaRPr lang="en-US" sz="2100" dirty="0"/>
+          </a:p>
+          <a:p>
+            <a:r>
+              <a:rPr lang="en-US" sz="2100" dirty="0"/>
+              <a:t>Flags: </a:t>
+            </a:r>
+            <a:r>
+              <a:rPr lang="en-US" sz="2100" dirty="0">
+                <a:solidFill>
+                  <a:srgbClr val="0070C0"/>
+                </a:solidFill>
+              </a:rPr>
+              <a:t>Append “S” to capture result characteristics in NCVZ</a:t>
+            </a:r>
+          </a:p>
+          <a:p>
+            <a:endParaRPr lang="en-US" sz="2100" dirty="0"/>
+          </a:p>
+          <a:p>
+            <a:r>
+              <a:rPr lang="en-US" sz="2100" dirty="0"/>
+              <a:t>Overflow:</a:t>
+            </a:r>
+          </a:p>
+          <a:p>
+            <a:pPr lvl="1"/>
+            <a:r>
+              <a:rPr lang="en-US" sz="1800" b="1" dirty="0">
+                <a:solidFill>
+                  <a:srgbClr val="92D050"/>
+                </a:solidFill>
+              </a:rPr>
+              <a:t>Unsigned</a:t>
+            </a:r>
+            <a:r>
+              <a:rPr lang="en-US" sz="1800" dirty="0">
+                <a:solidFill>
+                  <a:srgbClr val="0070C0"/>
+                </a:solidFill>
+              </a:rPr>
+              <a:t>: Carry Flag       (C) = 0</a:t>
+            </a:r>
+          </a:p>
+          <a:p>
+            <a:pPr lvl="1"/>
+            <a:r>
+              <a:rPr lang="en-US" sz="1800" dirty="0">
+                <a:solidFill>
+                  <a:srgbClr val="0070C0"/>
+                </a:solidFill>
+              </a:rPr>
+              <a:t>     </a:t>
+            </a:r>
+            <a:r>
+              <a:rPr lang="en-US" sz="1800" b="1" dirty="0">
+                <a:solidFill>
+                  <a:srgbClr val="FF0000"/>
+                </a:solidFill>
+              </a:rPr>
+              <a:t>Signed</a:t>
+            </a:r>
+            <a:r>
+              <a:rPr lang="en-US" sz="1800" dirty="0">
+                <a:solidFill>
+                  <a:srgbClr val="0070C0"/>
+                </a:solidFill>
+              </a:rPr>
+              <a:t>: Overflow Flag (V) = 1 (Set when C</a:t>
+            </a:r>
+            <a:r>
+              <a:rPr lang="en-US" sz="1800" baseline="-25000" dirty="0">
+                <a:solidFill>
+                  <a:srgbClr val="0070C0"/>
+                </a:solidFill>
+              </a:rPr>
+              <a:t>N</a:t>
+            </a:r>
+            <a:r>
+              <a:rPr lang="en-US" sz="1800" dirty="0">
+                <a:solidFill>
+                  <a:srgbClr val="0070C0"/>
+                </a:solidFill>
+              </a:rPr>
+              <a:t>≠C</a:t>
+            </a:r>
+            <a:r>
+              <a:rPr lang="en-US" sz="1800" baseline="-25000" dirty="0">
+                <a:solidFill>
+                  <a:srgbClr val="0070C0"/>
+                </a:solidFill>
+              </a:rPr>
+              <a:t>N-1</a:t>
+            </a:r>
+            <a:r>
+              <a:rPr lang="en-US" sz="1800" dirty="0">
+                <a:solidFill>
+                  <a:srgbClr val="0070C0"/>
+                </a:solidFill>
+              </a:rPr>
+              <a:t>)</a:t>
+            </a:r>
+          </a:p>
+          <a:p>
+            <a:endParaRPr lang="en-US" sz="2100" dirty="0"/>
+          </a:p>
+          <a:p>
+            <a:r>
+              <a:rPr lang="en-US" sz="2100" dirty="0"/>
+              <a:t>Multiple precision subtraction: </a:t>
+            </a:r>
+            <a:r>
+              <a:rPr lang="en-US" sz="2100" dirty="0">
+                <a:solidFill>
+                  <a:srgbClr val="0070C0"/>
+                </a:solidFill>
+              </a:rPr>
+              <a:t>SUB</a:t>
+            </a:r>
+            <a:r>
+              <a:rPr lang="en-US" sz="2100" b="1" dirty="0">
+                <a:solidFill>
+                  <a:srgbClr val="FF0000"/>
+                </a:solidFill>
+              </a:rPr>
+              <a:t>S</a:t>
+            </a:r>
+            <a:r>
+              <a:rPr lang="en-US" sz="2100" dirty="0">
+                <a:solidFill>
+                  <a:srgbClr val="0070C0"/>
+                </a:solidFill>
+              </a:rPr>
               <a:t> </a:t>
             </a:r>
             <a:r>
-              <a:rPr lang="en-US" dirty="0">
+              <a:rPr lang="en-US" sz="2100" dirty="0">
                 <a:solidFill>
                   <a:srgbClr val="0070C0"/>
                 </a:solidFill>
-              </a:rPr>
-              <a:t>MUL{</a:t>
-            </a:r>
-            <a:r>
-              <a:rPr lang="en-US" b="1" dirty="0">
-                <a:solidFill>
-                  <a:srgbClr val="FF0000"/>
-                </a:solidFill>
-              </a:rPr>
-              <a:t>S</a:t>
-            </a:r>
-            <a:r>
-              <a:rPr lang="en-US" dirty="0">
-                <a:solidFill>
-                  <a:srgbClr val="0070C0"/>
-                </a:solidFill>
-              </a:rPr>
-              <a:t>}, MLA, MLS</a:t>
-            </a:r>
-          </a:p>
-          <a:p>
-            <a:endParaRPr lang="en-US" dirty="0"/>
-          </a:p>
-          <a:p>
-            <a:r>
-              <a:rPr lang="en-US" b="1" dirty="0">
-                <a:solidFill>
-                  <a:srgbClr val="FF0000"/>
-                </a:solidFill>
-              </a:rPr>
-              <a:t>Signed</a:t>
-            </a:r>
-            <a:r>
-              <a:rPr lang="en-US" dirty="0"/>
-              <a:t> </a:t>
-            </a:r>
-            <a:r>
-              <a:rPr lang="en-US" dirty="0">
-                <a:solidFill>
-                  <a:schemeClr val="tx1"/>
-                </a:solidFill>
-              </a:rPr>
-              <a:t>vs.</a:t>
-            </a:r>
-            <a:r>
-              <a:rPr lang="en-US" dirty="0"/>
-              <a:t> </a:t>
-            </a:r>
-            <a:r>
-              <a:rPr lang="en-US" b="1" dirty="0">
-                <a:solidFill>
-                  <a:srgbClr val="92D050"/>
-                </a:solidFill>
-              </a:rPr>
-              <a:t>Unsigned</a:t>
-            </a:r>
-            <a:r>
-              <a:rPr lang="en-US" dirty="0">
-                <a:solidFill>
-                  <a:schemeClr val="tx1"/>
-                </a:solidFill>
-              </a:rPr>
-              <a:t>:</a:t>
-            </a:r>
-            <a:r>
-              <a:rPr lang="en-US" dirty="0"/>
-              <a:t> </a:t>
-            </a:r>
-            <a:r>
-              <a:rPr lang="en-US" dirty="0">
-                <a:solidFill>
-                  <a:srgbClr val="0070C0"/>
-                </a:solidFill>
-              </a:rPr>
-              <a:t>Use </a:t>
-            </a:r>
-            <a:r>
-              <a:rPr lang="en-US" b="1" dirty="0">
-                <a:solidFill>
-                  <a:srgbClr val="0070C0"/>
-                </a:solidFill>
-              </a:rPr>
-              <a:t>same</a:t>
-            </a:r>
-            <a:r>
-              <a:rPr lang="en-US" dirty="0">
-                <a:solidFill>
-                  <a:srgbClr val="0070C0"/>
-                </a:solidFill>
-              </a:rPr>
-              <a:t> instruction</a:t>
-            </a:r>
-          </a:p>
-          <a:p>
-            <a:endParaRPr lang="en-US" dirty="0"/>
-          </a:p>
-          <a:p>
-            <a:r>
-              <a:rPr lang="en-US" dirty="0">
-                <a:solidFill>
-                  <a:schemeClr val="tx1"/>
-                </a:solidFill>
-              </a:rPr>
-              <a:t>Format Examples:</a:t>
-            </a:r>
-          </a:p>
-          <a:p>
-            <a:pPr lvl="1"/>
-            <a:r>
-              <a:rPr lang="en-US" dirty="0">
-                <a:solidFill>
-                  <a:schemeClr val="tx1"/>
-                </a:solidFill>
-              </a:rPr>
-              <a:t>MUL	R0,</a:t>
-            </a:r>
-            <a:r>
-              <a:rPr lang="en-US" b="1" dirty="0">
-                <a:solidFill>
-                  <a:srgbClr val="0000FF"/>
-                </a:solidFill>
-              </a:rPr>
-              <a:t>R1,R2</a:t>
-            </a:r>
-            <a:r>
-              <a:rPr lang="en-US" dirty="0">
-                <a:solidFill>
-                  <a:schemeClr val="tx1"/>
-                </a:solidFill>
-              </a:rPr>
-              <a:t>		// R0 </a:t>
-            </a:r>
-            <a:r>
-              <a:rPr lang="en-US" dirty="0">
-                <a:solidFill>
-                  <a:schemeClr val="tx1"/>
-                </a:solidFill>
                 <a:sym typeface="Wingdings" panose="05000000000000000000" pitchFamily="2" charset="2"/>
               </a:rPr>
-              <a:t>= </a:t>
-            </a:r>
-            <a:r>
-              <a:rPr lang="en-US" b="1" dirty="0">
-                <a:solidFill>
-                  <a:srgbClr val="0000FF"/>
-                </a:solidFill>
-                <a:sym typeface="Wingdings" panose="05000000000000000000" pitchFamily="2" charset="2"/>
-              </a:rPr>
-              <a:t>R1 × R2</a:t>
-            </a:r>
-          </a:p>
-          <a:p>
-            <a:pPr lvl="1"/>
-            <a:r>
-              <a:rPr lang="en-US" dirty="0">
-                <a:solidFill>
-                  <a:schemeClr val="tx1"/>
-                </a:solidFill>
-              </a:rPr>
-              <a:t>MLA	R0,</a:t>
-            </a:r>
-            <a:r>
-              <a:rPr lang="en-US" b="1" dirty="0">
-                <a:solidFill>
-                  <a:srgbClr val="0000FF"/>
-                </a:solidFill>
-              </a:rPr>
-              <a:t>R1,R2</a:t>
-            </a:r>
-            <a:r>
-              <a:rPr lang="en-US" dirty="0">
-                <a:solidFill>
-                  <a:schemeClr val="tx1"/>
-                </a:solidFill>
-              </a:rPr>
-              <a:t>,R3		// R0 </a:t>
-            </a:r>
-            <a:r>
-              <a:rPr lang="en-US" dirty="0">
-                <a:solidFill>
-                  <a:schemeClr val="tx1"/>
-                </a:solidFill>
-                <a:sym typeface="Wingdings" panose="05000000000000000000" pitchFamily="2" charset="2"/>
-              </a:rPr>
-              <a:t>= R3 + </a:t>
-            </a:r>
-            <a:r>
-              <a:rPr lang="en-US" b="1" dirty="0">
-                <a:solidFill>
-                  <a:srgbClr val="0000FF"/>
-                </a:solidFill>
-                <a:sym typeface="Wingdings" panose="05000000000000000000" pitchFamily="2" charset="2"/>
-              </a:rPr>
-              <a:t>R1 × R2</a:t>
-            </a:r>
-          </a:p>
-          <a:p>
-            <a:pPr lvl="1"/>
-            <a:r>
-              <a:rPr lang="en-US" dirty="0">
-                <a:solidFill>
-                  <a:schemeClr val="tx1"/>
-                </a:solidFill>
-              </a:rPr>
-              <a:t>MLS	R0,</a:t>
-            </a:r>
-            <a:r>
-              <a:rPr lang="en-US" b="1" dirty="0">
-                <a:solidFill>
-                  <a:srgbClr val="0000FF"/>
-                </a:solidFill>
-              </a:rPr>
-              <a:t>R1,R2</a:t>
-            </a:r>
-            <a:r>
-              <a:rPr lang="en-US" dirty="0">
-                <a:solidFill>
-                  <a:schemeClr val="tx1"/>
-                </a:solidFill>
-              </a:rPr>
-              <a:t>,R3		// R0 </a:t>
-            </a:r>
-            <a:r>
-              <a:rPr lang="en-US" dirty="0">
-                <a:solidFill>
-                  <a:schemeClr val="tx1"/>
-                </a:solidFill>
-                <a:sym typeface="Wingdings" panose="05000000000000000000" pitchFamily="2" charset="2"/>
-              </a:rPr>
-              <a:t>= R3 -  </a:t>
-            </a:r>
-            <a:r>
-              <a:rPr lang="en-US" b="1" dirty="0">
-                <a:solidFill>
-                  <a:srgbClr val="0000FF"/>
-                </a:solidFill>
-                <a:sym typeface="Wingdings" panose="05000000000000000000" pitchFamily="2" charset="2"/>
-              </a:rPr>
-              <a:t>R1 × R2</a:t>
-            </a:r>
-          </a:p>
-          <a:p>
-            <a:endParaRPr lang="en-US" dirty="0"/>
-          </a:p>
-          <a:p>
-            <a:r>
-              <a:rPr lang="en-US" dirty="0">
-                <a:solidFill>
-                  <a:schemeClr val="tx1"/>
-                </a:solidFill>
-              </a:rPr>
-              <a:t>Flags:</a:t>
-            </a:r>
-            <a:r>
-              <a:rPr lang="en-US" dirty="0"/>
-              <a:t> </a:t>
-            </a:r>
-            <a:r>
-              <a:rPr lang="en-US" dirty="0">
-                <a:solidFill>
-                  <a:srgbClr val="0070C0"/>
-                </a:solidFill>
-              </a:rPr>
-              <a:t>Append “S” (only MUL) to capture result characteristics in N and Z flags</a:t>
-            </a:r>
-          </a:p>
-          <a:p>
-            <a:endParaRPr lang="en-US" dirty="0"/>
-          </a:p>
-          <a:p>
-            <a:r>
-              <a:rPr lang="en-US" dirty="0">
-                <a:solidFill>
-                  <a:schemeClr val="tx1"/>
-                </a:solidFill>
-              </a:rPr>
-              <a:t>Overflow: </a:t>
-            </a:r>
-            <a:r>
-              <a:rPr lang="en-US" b="1" dirty="0">
-                <a:solidFill>
-                  <a:srgbClr val="FF0000"/>
-                </a:solidFill>
-              </a:rPr>
-              <a:t>May happen but impossible to detect!</a:t>
-            </a:r>
+              <a:t> SBC</a:t>
+            </a:r>
+            <a:endParaRPr lang="en-US" sz="2100" dirty="0">
+              <a:solidFill>
+                <a:srgbClr val="0070C0"/>
+              </a:solidFill>
+            </a:endParaRPr>
+          </a:p>
+          <a:p>
+            <a:endParaRPr lang="en-US" sz="2100" dirty="0"/>
+          </a:p>
+          <a:p>
+            <a:endParaRPr lang="en-US" sz="2100" dirty="0"/>
           </a:p>
         </p:txBody>
       </p:sp>
     </p:spTree>
     <p:extLst>
       <p:ext uri="{BB962C8B-B14F-4D97-AF65-F5344CB8AC3E}">
-        <p14:creationId xmlns:p14="http://schemas.microsoft.com/office/powerpoint/2010/main" val="3196419567"/>
+        <p14:creationId xmlns:p14="http://schemas.microsoft.com/office/powerpoint/2010/main" val="2046813644"/>
       </p:ext>
     </p:extLst>
   </p:cSld>
@@ -43310,8 +42987,8 @@
         </p:nvSpPr>
         <p:spPr>
           <a:xfrm>
-            <a:off x="936516" y="741171"/>
-            <a:ext cx="9643252" cy="734703"/>
+            <a:off x="936516" y="745181"/>
+            <a:ext cx="9466789" cy="686577"/>
           </a:xfrm>
         </p:spPr>
         <p:txBody>
@@ -43322,7 +42999,7 @@
           <a:p>
             <a:r>
               <a:rPr lang="en-US" dirty="0"/>
-              <a:t>Double-Length 32x32 Integer Multiplication</a:t>
+              <a:t>Single-Length 32x32 Integer Multiplication</a:t>
             </a:r>
           </a:p>
         </p:txBody>
@@ -43339,13 +43016,13 @@
         </p:nvSpPr>
         <p:spPr>
           <a:xfrm>
-            <a:off x="936515" y="1795670"/>
-            <a:ext cx="10425305" cy="4833730"/>
+            <a:off x="936515" y="1807701"/>
+            <a:ext cx="10441347" cy="4841752"/>
           </a:xfrm>
         </p:spPr>
         <p:txBody>
           <a:bodyPr>
-            <a:normAutofit fontScale="92500" lnSpcReduction="10000"/>
+            <a:normAutofit lnSpcReduction="10000"/>
           </a:bodyPr>
           <a:lstStyle/>
           <a:p>
@@ -43367,7 +43044,23 @@
                   <a:srgbClr val="0070C0"/>
                 </a:solidFill>
               </a:rPr>
-              <a:t>UMULL, SMULL, UMLAL, SMLAL</a:t>
+              <a:t>MUL{</a:t>
+            </a:r>
+            <a:r>
+              <a:rPr lang="en-US" b="1" dirty="0">
+                <a:solidFill>
+                  <a:srgbClr val="FF0000"/>
+                </a:solidFill>
+              </a:rPr>
+              <a:t>S</a:t>
+            </a:r>
+            <a:r>
+              <a:rPr lang="en-US" dirty="0">
+                <a:solidFill>
+                  <a:srgbClr val="0070C0"/>
+                </a:solidFill>
+              </a:rPr>
+              <a:t>}, MLA, MLS</a:t>
             </a:r>
           </a:p>
           <a:p>
@@ -43392,184 +43085,27 @@
                   <a:schemeClr val="tx1"/>
                 </a:solidFill>
               </a:rPr>
-              <a:t>vs. </a:t>
-            </a:r>
-            <a:r>
-              <a:rPr lang="en-US" b="1" dirty="0">
-                <a:solidFill>
-                  <a:srgbClr val="92D050"/>
-                </a:solidFill>
-              </a:rPr>
-              <a:t>Unsigned</a:t>
-            </a:r>
-            <a:r>
-              <a:rPr lang="en-US" dirty="0"/>
-              <a:t>: </a:t>
-            </a:r>
-            <a:r>
-              <a:rPr lang="en-US" dirty="0">
-                <a:solidFill>
-                  <a:srgbClr val="0070C0"/>
-                </a:solidFill>
-              </a:rPr>
-              <a:t>Use </a:t>
-            </a:r>
-            <a:r>
-              <a:rPr lang="en-US" b="1" dirty="0">
-                <a:solidFill>
-                  <a:srgbClr val="0070C0"/>
-                </a:solidFill>
-              </a:rPr>
-              <a:t>different</a:t>
-            </a:r>
-            <a:r>
-              <a:rPr lang="en-US" dirty="0">
-                <a:solidFill>
-                  <a:srgbClr val="0070C0"/>
-                </a:solidFill>
-              </a:rPr>
-              <a:t> instructions!</a:t>
-            </a:r>
-          </a:p>
-          <a:p>
-            <a:endParaRPr lang="en-US" dirty="0"/>
-          </a:p>
-          <a:p>
-            <a:r>
-              <a:rPr lang="en-US" b="1" dirty="0">
-                <a:solidFill>
-                  <a:srgbClr val="FF0000"/>
-                </a:solidFill>
-              </a:rPr>
-              <a:t>Signed</a:t>
+              <a:t>vs.</a:t>
             </a:r>
             <a:r>
               <a:rPr lang="en-US" dirty="0"/>
               <a:t> </a:t>
             </a:r>
             <a:r>
+              <a:rPr lang="en-US" b="1" dirty="0">
+                <a:solidFill>
+                  <a:srgbClr val="92D050"/>
+                </a:solidFill>
+              </a:rPr>
+              <a:t>Unsigned</a:t>
+            </a:r>
+            <a:r>
               <a:rPr lang="en-US" dirty="0">
                 <a:solidFill>
                   <a:schemeClr val="tx1"/>
                 </a:solidFill>
               </a:rPr>
-              <a:t>Instruction Formats:</a:t>
-            </a:r>
-          </a:p>
-          <a:p>
-            <a:pPr lvl="1"/>
-            <a:r>
-              <a:rPr lang="en-US" b="1" dirty="0">
-                <a:solidFill>
-                  <a:srgbClr val="FF0000"/>
-                </a:solidFill>
-              </a:rPr>
-              <a:t>S</a:t>
-            </a:r>
-            <a:r>
-              <a:rPr lang="en-US" dirty="0">
-                <a:solidFill>
-                  <a:schemeClr val="tx1"/>
-                </a:solidFill>
-              </a:rPr>
-              <a:t>MULL	R0,R1,</a:t>
-            </a:r>
-            <a:r>
-              <a:rPr lang="en-US" b="1" dirty="0">
-                <a:solidFill>
-                  <a:srgbClr val="0000FF"/>
-                </a:solidFill>
-              </a:rPr>
-              <a:t>R2,R3</a:t>
-            </a:r>
-            <a:r>
-              <a:rPr lang="en-US" dirty="0">
-                <a:solidFill>
-                  <a:schemeClr val="tx1"/>
-                </a:solidFill>
-              </a:rPr>
-              <a:t>		// R0.R1 </a:t>
-            </a:r>
-            <a:r>
-              <a:rPr lang="en-US" dirty="0">
-                <a:solidFill>
-                  <a:schemeClr val="tx1"/>
-                </a:solidFill>
-                <a:sym typeface="Wingdings" panose="05000000000000000000" pitchFamily="2" charset="2"/>
-              </a:rPr>
-              <a:t>=               </a:t>
-            </a:r>
-            <a:r>
-              <a:rPr lang="en-US" b="1" dirty="0">
-                <a:solidFill>
-                  <a:srgbClr val="0000FF"/>
-                </a:solidFill>
-                <a:sym typeface="Wingdings" panose="05000000000000000000" pitchFamily="2" charset="2"/>
-              </a:rPr>
-              <a:t>R2 × R3</a:t>
-            </a:r>
-          </a:p>
-          <a:p>
-            <a:pPr lvl="1"/>
-            <a:r>
-              <a:rPr lang="en-US" b="1" dirty="0">
-                <a:solidFill>
-                  <a:srgbClr val="FF0000"/>
-                </a:solidFill>
-              </a:rPr>
-              <a:t>S</a:t>
-            </a:r>
-            <a:r>
-              <a:rPr lang="en-US" dirty="0">
-                <a:solidFill>
-                  <a:schemeClr val="tx1"/>
-                </a:solidFill>
-              </a:rPr>
-              <a:t>MLAL	R0,R1,</a:t>
-            </a:r>
-            <a:r>
-              <a:rPr lang="en-US" b="1" dirty="0">
-                <a:solidFill>
-                  <a:srgbClr val="0000FF"/>
-                </a:solidFill>
-              </a:rPr>
-              <a:t>R2,R3</a:t>
-            </a:r>
-            <a:r>
-              <a:rPr lang="en-US" dirty="0">
-                <a:solidFill>
-                  <a:schemeClr val="tx1"/>
-                </a:solidFill>
-              </a:rPr>
-              <a:t>		// R0.R1 </a:t>
-            </a:r>
-            <a:r>
-              <a:rPr lang="en-US" dirty="0">
-                <a:solidFill>
-                  <a:schemeClr val="tx1"/>
-                </a:solidFill>
-                <a:sym typeface="Wingdings" panose="05000000000000000000" pitchFamily="2" charset="2"/>
-              </a:rPr>
-              <a:t>= R0.R1 + </a:t>
-            </a:r>
-            <a:r>
-              <a:rPr lang="en-US" b="1" dirty="0">
-                <a:solidFill>
-                  <a:srgbClr val="0000FF"/>
-                </a:solidFill>
-                <a:sym typeface="Wingdings" panose="05000000000000000000" pitchFamily="2" charset="2"/>
-              </a:rPr>
-              <a:t>R2 × R3</a:t>
-            </a:r>
-          </a:p>
-          <a:p>
-            <a:r>
-              <a:rPr lang="en-US" b="1" dirty="0">
-                <a:solidFill>
-                  <a:srgbClr val="92D050"/>
-                </a:solidFill>
-              </a:rPr>
-              <a:t>Unsigned</a:t>
+              <a:t>:</a:t>
             </a:r>
             <a:r>
               <a:rPr lang="en-US" dirty="0"/>
@@ -43578,21 +43114,58 @@
             <a:r>
               <a:rPr lang="en-US" dirty="0">
                 <a:solidFill>
+                  <a:srgbClr val="0070C0"/>
+                </a:solidFill>
+              </a:rPr>
+              <a:t>Use </a:t>
+            </a:r>
+            <a:r>
+              <a:rPr lang="en-US" b="1" dirty="0">
+                <a:solidFill>
+                  <a:srgbClr val="0070C0"/>
+                </a:solidFill>
+              </a:rPr>
+              <a:t>same</a:t>
+            </a:r>
+            <a:r>
+              <a:rPr lang="en-US" dirty="0">
+                <a:solidFill>
+                  <a:srgbClr val="0070C0"/>
+                </a:solidFill>
+              </a:rPr>
+              <a:t> instruction</a:t>
+            </a:r>
+          </a:p>
+          <a:p>
+            <a:endParaRPr lang="en-US" dirty="0"/>
+          </a:p>
+          <a:p>
+            <a:r>
+              <a:rPr lang="en-US" dirty="0">
+                <a:solidFill>
                   <a:schemeClr val="tx1"/>
                 </a:solidFill>
               </a:rPr>
-              <a:t>Instruction Formats:</a:t>
+              <a:t>Format Examples:</a:t>
             </a:r>
           </a:p>
           <a:p>
             <a:pPr lvl="1"/>
             <a:r>
+              <a:rPr lang="en-US" dirty="0">
+                <a:solidFill>
+                  <a:schemeClr val="tx1"/>
+                </a:solidFill>
+              </a:rPr>
+              <a:t>MUL	R0,</a:t>
+            </a:r>
+            <a:r>
               <a:rPr lang="en-US" b="1" dirty="0">
                 <a:solidFill>
-                  <a:srgbClr val="92D050"/>
-                </a:solidFill>
-              </a:rPr>
-              <a:t>U</a:t>
+                  <a:srgbClr val="0000FF"/>
+                </a:solidFill>
+              </a:rPr>
+              <a:t>R1,R2</a:t>
             </a:r>
             <a:r>
               <a:rPr lang="en-US" dirty="0">
@@ -43600,32 +43173,61 @@
                   <a:schemeClr val="tx1"/>
                 </a:solidFill>
               </a:rPr>
-              <a:t>MULL	R0,R1,</a:t>
+              <a:t>		// R0 </a:t>
+            </a:r>
+            <a:r>
+              <a:rPr lang="en-US" dirty="0">
+                <a:solidFill>
+                  <a:schemeClr val="tx1"/>
+                </a:solidFill>
+                <a:sym typeface="Wingdings" panose="05000000000000000000" pitchFamily="2" charset="2"/>
+              </a:rPr>
+              <a:t>= </a:t>
             </a:r>
             <a:r>
               <a:rPr lang="en-US" b="1" dirty="0">
                 <a:solidFill>
                   <a:srgbClr val="0000FF"/>
                 </a:solidFill>
-              </a:rPr>
-              <a:t>R2,R3</a:t>
-            </a:r>
+                <a:sym typeface="Wingdings" panose="05000000000000000000" pitchFamily="2" charset="2"/>
+              </a:rPr>
+              <a:t>R1 × R2</a:t>
+            </a:r>
+          </a:p>
+          <a:p>
+            <a:pPr lvl="1"/>
             <a:r>
               <a:rPr lang="en-US" dirty="0">
                 <a:solidFill>
                   <a:schemeClr val="tx1"/>
                 </a:solidFill>
               </a:rPr>
-              <a:t>		// R0.R1 </a:t>
+              <a:t>MLA	R0,</a:t>
+            </a:r>
+            <a:r>
+              <a:rPr lang="en-US" b="1" dirty="0">
+                <a:solidFill>
+                  <a:srgbClr val="0000FF"/>
+                </a:solidFill>
+              </a:rPr>
+              <a:t>R1,R2</a:t>
             </a:r>
             <a:r>
               <a:rPr lang="en-US" dirty="0">
                 <a:solidFill>
                   <a:schemeClr val="tx1"/>
                 </a:solidFill>
+              </a:rPr>
+              <a:t>,R3		// R0 </a:t>
+            </a:r>
+            <a:r>
+              <a:rPr lang="en-US" dirty="0">
+                <a:solidFill>
+                  <a:schemeClr val="tx1"/>
+                </a:solidFill>
                 <a:sym typeface="Wingdings" panose="05000000000000000000" pitchFamily="2" charset="2"/>
               </a:rPr>
-              <a:t>=               </a:t>
+              <a:t>= R3 + </a:t>
             </a:r>
             <a:r>
               <a:rPr lang="en-US" b="1" dirty="0">
@@ -43634,18 +43236,26 @@
                 </a:solidFill>
                 <a:sym typeface="Wingdings" panose="05000000000000000000" pitchFamily="2" charset="2"/>
               </a:rPr>
-              <a:t>R2 × R3</a:t>
+              <a:t>R1 × R2</a:t>
             </a:r>
           </a:p>
           <a:p>
             <a:pPr lvl="1"/>
             <a:r>
+              <a:rPr lang="en-US" dirty="0">
+                <a:solidFill>
+                  <a:schemeClr val="tx1"/>
+                </a:solidFill>
+              </a:rPr>
+              <a:t>MLS	R0,</a:t>
+            </a:r>
+            <a:r>
               <a:rPr lang="en-US" b="1" dirty="0">
                 <a:solidFill>
-                  <a:srgbClr val="92D050"/>
-                </a:solidFill>
-              </a:rPr>
-              <a:t>U</a:t>
+                  <a:srgbClr val="0000FF"/>
+                </a:solidFill>
+              </a:rPr>
+              <a:t>R1,R2</a:t>
             </a:r>
             <a:r>
               <a:rPr lang="en-US" dirty="0">
@@ -43653,84 +43263,71 @@
                   <a:schemeClr val="tx1"/>
                 </a:solidFill>
               </a:rPr>
-              <a:t>MLAL	R0,R1,</a:t>
+              <a:t>,R3		// R0 </a:t>
+            </a:r>
+            <a:r>
+              <a:rPr lang="en-US" dirty="0">
+                <a:solidFill>
+                  <a:schemeClr val="tx1"/>
+                </a:solidFill>
+                <a:sym typeface="Wingdings" panose="05000000000000000000" pitchFamily="2" charset="2"/>
+              </a:rPr>
+              <a:t>= R3 -  </a:t>
             </a:r>
             <a:r>
               <a:rPr lang="en-US" b="1" dirty="0">
                 <a:solidFill>
                   <a:srgbClr val="0000FF"/>
                 </a:solidFill>
-              </a:rPr>
-              <a:t>R2,R3</a:t>
-            </a:r>
+                <a:sym typeface="Wingdings" panose="05000000000000000000" pitchFamily="2" charset="2"/>
+              </a:rPr>
+              <a:t>R1 × R2</a:t>
+            </a:r>
+          </a:p>
+          <a:p>
+            <a:endParaRPr lang="en-US" dirty="0"/>
+          </a:p>
+          <a:p>
             <a:r>
               <a:rPr lang="en-US" dirty="0">
                 <a:solidFill>
                   <a:schemeClr val="tx1"/>
                 </a:solidFill>
               </a:rPr>
-              <a:t>		// R0.R1 </a:t>
+              <a:t>Flags:</a:t>
+            </a:r>
+            <a:r>
+              <a:rPr lang="en-US" dirty="0"/>
+              <a:t> </a:t>
             </a:r>
             <a:r>
               <a:rPr lang="en-US" dirty="0">
                 <a:solidFill>
+                  <a:srgbClr val="0070C0"/>
+                </a:solidFill>
+              </a:rPr>
+              <a:t>Append “S” (only MUL) to capture result characteristics in N and Z flags</a:t>
+            </a:r>
+          </a:p>
+          <a:p>
+            <a:endParaRPr lang="en-US" dirty="0"/>
+          </a:p>
+          <a:p>
+            <a:r>
+              <a:rPr lang="en-US" dirty="0">
+                <a:solidFill>
                   <a:schemeClr val="tx1"/>
                 </a:solidFill>
-                <a:sym typeface="Wingdings" panose="05000000000000000000" pitchFamily="2" charset="2"/>
-              </a:rPr>
-              <a:t>= R0.R1 + </a:t>
+              </a:rPr>
+              <a:t>Overflow: </a:t>
             </a:r>
             <a:r>
               <a:rPr lang="en-US" b="1" dirty="0">
                 <a:solidFill>
-                  <a:srgbClr val="0000FF"/>
-                </a:solidFill>
-                <a:sym typeface="Wingdings" panose="05000000000000000000" pitchFamily="2" charset="2"/>
-              </a:rPr>
-              <a:t>R2 × R3</a:t>
-            </a:r>
-          </a:p>
-          <a:p>
-            <a:endParaRPr lang="en-US" dirty="0"/>
-          </a:p>
-          <a:p>
-            <a:r>
-              <a:rPr lang="en-US" dirty="0">
-                <a:solidFill>
-                  <a:schemeClr val="tx1"/>
-                </a:solidFill>
-              </a:rPr>
-              <a:t>Flags:</a:t>
-            </a:r>
-            <a:r>
-              <a:rPr lang="en-US" dirty="0"/>
-              <a:t>      </a:t>
-            </a:r>
-            <a:r>
-              <a:rPr lang="en-US" b="1" dirty="0">
-                <a:solidFill>
                   <a:srgbClr val="FF0000"/>
                 </a:solidFill>
               </a:rPr>
-              <a:t>Unaffected!</a:t>
-            </a:r>
-          </a:p>
-          <a:p>
-            <a:r>
-              <a:rPr lang="en-US" dirty="0">
-                <a:solidFill>
-                  <a:schemeClr val="tx1"/>
-                </a:solidFill>
-              </a:rPr>
-              <a:t>Overflow: </a:t>
-            </a:r>
-            <a:r>
-              <a:rPr lang="en-US" b="1" dirty="0">
-                <a:solidFill>
-                  <a:srgbClr val="FF0000"/>
-                </a:solidFill>
-              </a:rPr>
-              <a:t>Can’t happen</a:t>
+              <a:t>May happen but impossible to detect!</a:t>
             </a:r>
           </a:p>
         </p:txBody>
@@ -43738,7 +43335,7 @@
     </p:spTree>
     <p:extLst>
       <p:ext uri="{BB962C8B-B14F-4D97-AF65-F5344CB8AC3E}">
-        <p14:creationId xmlns:p14="http://schemas.microsoft.com/office/powerpoint/2010/main" val="228742505"/>
+        <p14:creationId xmlns:p14="http://schemas.microsoft.com/office/powerpoint/2010/main" val="3196419567"/>
       </p:ext>
     </p:extLst>
   </p:cSld>
@@ -43777,8 +43374,8 @@
         </p:nvSpPr>
         <p:spPr>
           <a:xfrm>
-            <a:off x="940526" y="745181"/>
-            <a:ext cx="8315769" cy="746735"/>
+            <a:off x="936516" y="741171"/>
+            <a:ext cx="9643252" cy="734703"/>
           </a:xfrm>
         </p:spPr>
         <p:txBody>
@@ -43789,7 +43386,7 @@
           <a:p>
             <a:r>
               <a:rPr lang="en-US" dirty="0"/>
-              <a:t>Single-Length 32÷32 Integer Division</a:t>
+              <a:t>Double-Length 32x32 Integer Multiplication</a:t>
             </a:r>
           </a:p>
         </p:txBody>
@@ -43806,8 +43403,8 @@
         </p:nvSpPr>
         <p:spPr>
           <a:xfrm>
-            <a:off x="940525" y="1806366"/>
-            <a:ext cx="10409263" cy="4835066"/>
+            <a:off x="936515" y="1795670"/>
+            <a:ext cx="10425305" cy="4833730"/>
           </a:xfrm>
         </p:spPr>
         <p:txBody>
@@ -43822,65 +43419,7 @@
                   <a:schemeClr val="tx1"/>
                 </a:solidFill>
               </a:rPr>
-              <a:t>Instructions: </a:t>
-            </a:r>
-            <a:r>
-              <a:rPr lang="en-US" b="1" dirty="0">
-                <a:solidFill>
-                  <a:srgbClr val="FF0000"/>
-                </a:solidFill>
-              </a:rPr>
-              <a:t>S</a:t>
-            </a:r>
-            <a:r>
-              <a:rPr lang="en-US" dirty="0">
-                <a:solidFill>
-                  <a:srgbClr val="0070C0"/>
-                </a:solidFill>
-              </a:rPr>
-              <a:t>DIV</a:t>
-            </a:r>
-            <a:r>
-              <a:rPr lang="en-US" dirty="0">
-                <a:solidFill>
-                  <a:schemeClr val="tx1"/>
-                </a:solidFill>
-              </a:rPr>
-              <a:t>,</a:t>
-            </a:r>
-            <a:r>
-              <a:rPr lang="en-US" dirty="0">
-                <a:solidFill>
-                  <a:srgbClr val="0070C0"/>
-                </a:solidFill>
-              </a:rPr>
-              <a:t> </a:t>
-            </a:r>
-            <a:r>
-              <a:rPr lang="en-US" b="1" dirty="0">
-                <a:solidFill>
-                  <a:srgbClr val="92D050"/>
-                </a:solidFill>
-              </a:rPr>
-              <a:t>U</a:t>
-            </a:r>
-            <a:r>
-              <a:rPr lang="en-US" dirty="0">
-                <a:solidFill>
-                  <a:srgbClr val="0070C0"/>
-                </a:solidFill>
-              </a:rPr>
-              <a:t>DIV</a:t>
-            </a:r>
-          </a:p>
-          <a:p>
-            <a:r>
-              <a:rPr lang="en-US" b="1" dirty="0">
-                <a:solidFill>
-                  <a:srgbClr val="FF0000"/>
-                </a:solidFill>
-              </a:rPr>
-              <a:t>Signed</a:t>
+              <a:t>Instructions:</a:t>
             </a:r>
             <a:r>
               <a:rPr lang="en-US" dirty="0"/>
@@ -43889,16 +43428,37 @@
             <a:r>
               <a:rPr lang="en-US" dirty="0">
                 <a:solidFill>
-                  <a:schemeClr val="tx1"/>
-                </a:solidFill>
-              </a:rPr>
-              <a:t>vs.</a:t>
+                  <a:srgbClr val="0070C0"/>
+                </a:solidFill>
+              </a:rPr>
+              <a:t>UMULL, SMULL, UMLAL, SMLAL</a:t>
+            </a:r>
+          </a:p>
+          <a:p>
+            <a:endParaRPr lang="en-US" dirty="0"/>
+          </a:p>
+          <a:p>
+            <a:r>
+              <a:rPr lang="en-US" b="1" dirty="0">
+                <a:solidFill>
+                  <a:srgbClr val="FF0000"/>
+                </a:solidFill>
+              </a:rPr>
+              <a:t>Signed</a:t>
             </a:r>
             <a:r>
               <a:rPr lang="en-US" dirty="0"/>
               <a:t> </a:t>
             </a:r>
             <a:r>
+              <a:rPr lang="en-US" dirty="0">
+                <a:solidFill>
+                  <a:schemeClr val="tx1"/>
+                </a:solidFill>
+              </a:rPr>
+              <a:t>vs. </a:t>
+            </a:r>
+            <a:r>
               <a:rPr lang="en-US" b="1" dirty="0">
                 <a:solidFill>
                   <a:srgbClr val="92D050"/>
@@ -43919,9 +43479,9 @@
               <a:t>Use </a:t>
             </a:r>
             <a:r>
-              <a:rPr lang="en-US" dirty="0">
-                <a:solidFill>
-                  <a:srgbClr val="FF0000"/>
+              <a:rPr lang="en-US" b="1" dirty="0">
+                <a:solidFill>
+                  <a:srgbClr val="0070C0"/>
                 </a:solidFill>
               </a:rPr>
               <a:t>different</a:t>
@@ -43957,7 +43517,7 @@
                   <a:schemeClr val="tx1"/>
                 </a:solidFill>
               </a:rPr>
-              <a:t>Instruction Format:</a:t>
+              <a:t>Instruction Formats:</a:t>
             </a:r>
           </a:p>
           <a:p>
@@ -43973,19 +43533,97 @@
             <a:r>
               <a:rPr lang="en-US" dirty="0">
                 <a:solidFill>
-                  <a:srgbClr val="0070C0"/>
-                </a:solidFill>
-              </a:rPr>
-              <a:t>DIV	R0,R1,R2		// R0 </a:t>
+                  <a:schemeClr val="tx1"/>
+                </a:solidFill>
+              </a:rPr>
+              <a:t>MULL	R0,R1,</a:t>
+            </a:r>
+            <a:r>
+              <a:rPr lang="en-US" b="1" dirty="0">
+                <a:solidFill>
+                  <a:srgbClr val="0000FF"/>
+                </a:solidFill>
+              </a:rPr>
+              <a:t>R2,R3</a:t>
             </a:r>
             <a:r>
               <a:rPr lang="en-US" dirty="0">
                 <a:solidFill>
-                  <a:srgbClr val="0070C0"/>
+                  <a:schemeClr val="tx1"/>
+                </a:solidFill>
+              </a:rPr>
+              <a:t>		// R0.R1 </a:t>
+            </a:r>
+            <a:r>
+              <a:rPr lang="en-US" dirty="0">
+                <a:solidFill>
+                  <a:schemeClr val="tx1"/>
                 </a:solidFill>
                 <a:sym typeface="Wingdings" panose="05000000000000000000" pitchFamily="2" charset="2"/>
               </a:rPr>
-              <a:t>= R1 ÷ R2</a:t>
+              <a:t>=               </a:t>
+            </a:r>
+            <a:r>
+              <a:rPr lang="en-US" b="1" dirty="0">
+                <a:solidFill>
+                  <a:srgbClr val="0000FF"/>
+                </a:solidFill>
+                <a:sym typeface="Wingdings" panose="05000000000000000000" pitchFamily="2" charset="2"/>
+              </a:rPr>
+              <a:t>R2 × R3</a:t>
+            </a:r>
+          </a:p>
+          <a:p>
+            <a:pPr lvl="1"/>
+            <a:r>
+              <a:rPr lang="en-US" b="1" dirty="0">
+                <a:solidFill>
+                  <a:srgbClr val="FF0000"/>
+                </a:solidFill>
+              </a:rPr>
+              <a:t>S</a:t>
+            </a:r>
+            <a:r>
+              <a:rPr lang="en-US" dirty="0">
+                <a:solidFill>
+                  <a:schemeClr val="tx1"/>
+                </a:solidFill>
+              </a:rPr>
+              <a:t>MLAL	R0,R1,</a:t>
+            </a:r>
+            <a:r>
+              <a:rPr lang="en-US" b="1" dirty="0">
+                <a:solidFill>
+                  <a:srgbClr val="0000FF"/>
+                </a:solidFill>
+              </a:rPr>
+              <a:t>R2,R3</a:t>
+            </a:r>
+            <a:r>
+              <a:rPr lang="en-US" dirty="0">
+                <a:solidFill>
+                  <a:schemeClr val="tx1"/>
+                </a:solidFill>
+              </a:rPr>
+              <a:t>		// R0.R1 </a:t>
+            </a:r>
+            <a:r>
+              <a:rPr lang="en-US" dirty="0">
+                <a:solidFill>
+                  <a:schemeClr val="tx1"/>
+                </a:solidFill>
+                <a:sym typeface="Wingdings" panose="05000000000000000000" pitchFamily="2" charset="2"/>
+              </a:rPr>
+              <a:t>= R0.R1 + </a:t>
+            </a:r>
+            <a:r>
+              <a:rPr lang="en-US" b="1" dirty="0">
+                <a:solidFill>
+                  <a:srgbClr val="0000FF"/>
+                </a:solidFill>
+                <a:sym typeface="Wingdings" panose="05000000000000000000" pitchFamily="2" charset="2"/>
+              </a:rPr>
+              <a:t>R2 × R3</a:t>
             </a:r>
           </a:p>
           <a:p>
@@ -44007,7 +43645,7 @@
                   <a:schemeClr val="tx1"/>
                 </a:solidFill>
               </a:rPr>
-              <a:t>Instruction Format:</a:t>
+              <a:t>Instruction Formats:</a:t>
             </a:r>
           </a:p>
           <a:p>
@@ -44023,19 +43661,97 @@
             <a:r>
               <a:rPr lang="en-US" dirty="0">
                 <a:solidFill>
-                  <a:srgbClr val="0070C0"/>
-                </a:solidFill>
-              </a:rPr>
-              <a:t>DIV	R0,R1,R2		// R0 </a:t>
+                  <a:schemeClr val="tx1"/>
+                </a:solidFill>
+              </a:rPr>
+              <a:t>MULL	R0,R1,</a:t>
+            </a:r>
+            <a:r>
+              <a:rPr lang="en-US" b="1" dirty="0">
+                <a:solidFill>
+                  <a:srgbClr val="0000FF"/>
+                </a:solidFill>
+              </a:rPr>
+              <a:t>R2,R3</a:t>
             </a:r>
             <a:r>
               <a:rPr lang="en-US" dirty="0">
                 <a:solidFill>
-                  <a:srgbClr val="0070C0"/>
+                  <a:schemeClr val="tx1"/>
+                </a:solidFill>
+              </a:rPr>
+              <a:t>		// R0.R1 </a:t>
+            </a:r>
+            <a:r>
+              <a:rPr lang="en-US" dirty="0">
+                <a:solidFill>
+                  <a:schemeClr val="tx1"/>
                 </a:solidFill>
                 <a:sym typeface="Wingdings" panose="05000000000000000000" pitchFamily="2" charset="2"/>
               </a:rPr>
-              <a:t>= R1 ÷ R2</a:t>
+              <a:t>=               </a:t>
+            </a:r>
+            <a:r>
+              <a:rPr lang="en-US" b="1" dirty="0">
+                <a:solidFill>
+                  <a:srgbClr val="0000FF"/>
+                </a:solidFill>
+                <a:sym typeface="Wingdings" panose="05000000000000000000" pitchFamily="2" charset="2"/>
+              </a:rPr>
+              <a:t>R2 × R3</a:t>
+            </a:r>
+          </a:p>
+          <a:p>
+            <a:pPr lvl="1"/>
+            <a:r>
+              <a:rPr lang="en-US" b="1" dirty="0">
+                <a:solidFill>
+                  <a:srgbClr val="92D050"/>
+                </a:solidFill>
+              </a:rPr>
+              <a:t>U</a:t>
+            </a:r>
+            <a:r>
+              <a:rPr lang="en-US" dirty="0">
+                <a:solidFill>
+                  <a:schemeClr val="tx1"/>
+                </a:solidFill>
+              </a:rPr>
+              <a:t>MLAL	R0,R1,</a:t>
+            </a:r>
+            <a:r>
+              <a:rPr lang="en-US" b="1" dirty="0">
+                <a:solidFill>
+                  <a:srgbClr val="0000FF"/>
+                </a:solidFill>
+              </a:rPr>
+              <a:t>R2,R3</a:t>
+            </a:r>
+            <a:r>
+              <a:rPr lang="en-US" dirty="0">
+                <a:solidFill>
+                  <a:schemeClr val="tx1"/>
+                </a:solidFill>
+              </a:rPr>
+              <a:t>		// R0.R1 </a:t>
+            </a:r>
+            <a:r>
+              <a:rPr lang="en-US" dirty="0">
+                <a:solidFill>
+                  <a:schemeClr val="tx1"/>
+                </a:solidFill>
+                <a:sym typeface="Wingdings" panose="05000000000000000000" pitchFamily="2" charset="2"/>
+              </a:rPr>
+              <a:t>= R0.R1 + </a:t>
+            </a:r>
+            <a:r>
+              <a:rPr lang="en-US" b="1" dirty="0">
+                <a:solidFill>
+                  <a:srgbClr val="0000FF"/>
+                </a:solidFill>
+                <a:sym typeface="Wingdings" panose="05000000000000000000" pitchFamily="2" charset="2"/>
+              </a:rPr>
+              <a:t>R2 × R3</a:t>
             </a:r>
           </a:p>
           <a:p>
@@ -44052,7 +43768,7 @@
             </a:r>
             <a:r>
               <a:rPr lang="en-US" dirty="0"/>
-              <a:t> </a:t>
+              <a:t>      </a:t>
             </a:r>
             <a:r>
               <a:rPr lang="en-US" b="1" dirty="0">
@@ -44060,11 +43776,8 @@
                   <a:srgbClr val="FF0000"/>
                 </a:solidFill>
               </a:rPr>
-              <a:t>Unaffected</a:t>
-            </a:r>
-          </a:p>
-          <a:p>
-            <a:endParaRPr lang="en-US" dirty="0"/>
+              <a:t>Unaffected!</a:t>
+            </a:r>
           </a:p>
           <a:p>
             <a:r>
@@ -44073,29 +43786,15 @@
                   <a:schemeClr val="tx1"/>
                 </a:solidFill>
               </a:rPr>
-              <a:t>Overflow:</a:t>
-            </a:r>
-          </a:p>
-          <a:p>
-            <a:pPr lvl="1"/>
-            <a:r>
-              <a:rPr lang="en-US" dirty="0">
-                <a:solidFill>
-                  <a:srgbClr val="0070C0"/>
-                </a:solidFill>
-              </a:rPr>
-              <a:t>Division by zero</a:t>
-            </a:r>
-          </a:p>
-          <a:p>
-            <a:pPr lvl="1"/>
-            <a:r>
-              <a:rPr lang="en-US" dirty="0">
-                <a:solidFill>
-                  <a:srgbClr val="0070C0"/>
-                </a:solidFill>
-              </a:rPr>
-              <a:t>Full-scale negative divided by -1</a:t>
+              <a:t>Overflow: </a:t>
+            </a:r>
+            <a:r>
+              <a:rPr lang="en-US" b="1" dirty="0">
+                <a:solidFill>
+                  <a:srgbClr val="FF0000"/>
+                </a:solidFill>
+              </a:rPr>
+              <a:t>Can’t happen</a:t>
             </a:r>
           </a:p>
         </p:txBody>
@@ -44103,7 +43802,7 @@
     </p:spTree>
     <p:extLst>
       <p:ext uri="{BB962C8B-B14F-4D97-AF65-F5344CB8AC3E}">
-        <p14:creationId xmlns:p14="http://schemas.microsoft.com/office/powerpoint/2010/main" val="3769027795"/>
+        <p14:creationId xmlns:p14="http://schemas.microsoft.com/office/powerpoint/2010/main" val="228742505"/>
       </p:ext>
     </p:extLst>
   </p:cSld>
@@ -44140,6 +43839,371 @@
             <p:ph type="title"/>
           </p:nvPr>
         </p:nvSpPr>
+        <p:spPr>
+          <a:xfrm>
+            <a:off x="940526" y="745181"/>
+            <a:ext cx="8315769" cy="746735"/>
+          </a:xfrm>
+        </p:spPr>
+        <p:txBody>
+          <a:bodyPr>
+            <a:normAutofit/>
+          </a:bodyPr>
+          <a:lstStyle/>
+          <a:p>
+            <a:r>
+              <a:rPr lang="en-US" dirty="0"/>
+              <a:t>Single-Length 32÷32 Integer Division</a:t>
+            </a:r>
+          </a:p>
+        </p:txBody>
+      </p:sp>
+      <p:sp>
+        <p:nvSpPr>
+          <p:cNvPr id="3" name="Content Placeholder 2"/>
+          <p:cNvSpPr>
+            <a:spLocks noGrp="1"/>
+          </p:cNvSpPr>
+          <p:nvPr>
+            <p:ph idx="1"/>
+          </p:nvPr>
+        </p:nvSpPr>
+        <p:spPr>
+          <a:xfrm>
+            <a:off x="940525" y="1806366"/>
+            <a:ext cx="10409263" cy="4835066"/>
+          </a:xfrm>
+        </p:spPr>
+        <p:txBody>
+          <a:bodyPr>
+            <a:normAutofit fontScale="92500" lnSpcReduction="10000"/>
+          </a:bodyPr>
+          <a:lstStyle/>
+          <a:p>
+            <a:r>
+              <a:rPr lang="en-US" dirty="0">
+                <a:solidFill>
+                  <a:schemeClr val="tx1"/>
+                </a:solidFill>
+              </a:rPr>
+              <a:t>Instructions: </a:t>
+            </a:r>
+            <a:r>
+              <a:rPr lang="en-US" b="1" dirty="0">
+                <a:solidFill>
+                  <a:srgbClr val="FF0000"/>
+                </a:solidFill>
+              </a:rPr>
+              <a:t>S</a:t>
+            </a:r>
+            <a:r>
+              <a:rPr lang="en-US" dirty="0">
+                <a:solidFill>
+                  <a:srgbClr val="0070C0"/>
+                </a:solidFill>
+              </a:rPr>
+              <a:t>DIV</a:t>
+            </a:r>
+            <a:r>
+              <a:rPr lang="en-US" dirty="0">
+                <a:solidFill>
+                  <a:schemeClr val="tx1"/>
+                </a:solidFill>
+              </a:rPr>
+              <a:t>,</a:t>
+            </a:r>
+            <a:r>
+              <a:rPr lang="en-US" dirty="0">
+                <a:solidFill>
+                  <a:srgbClr val="0070C0"/>
+                </a:solidFill>
+              </a:rPr>
+              <a:t> </a:t>
+            </a:r>
+            <a:r>
+              <a:rPr lang="en-US" b="1" dirty="0">
+                <a:solidFill>
+                  <a:srgbClr val="92D050"/>
+                </a:solidFill>
+              </a:rPr>
+              <a:t>U</a:t>
+            </a:r>
+            <a:r>
+              <a:rPr lang="en-US" dirty="0">
+                <a:solidFill>
+                  <a:srgbClr val="0070C0"/>
+                </a:solidFill>
+              </a:rPr>
+              <a:t>DIV</a:t>
+            </a:r>
+          </a:p>
+          <a:p>
+            <a:r>
+              <a:rPr lang="en-US" b="1" dirty="0">
+                <a:solidFill>
+                  <a:srgbClr val="FF0000"/>
+                </a:solidFill>
+              </a:rPr>
+              <a:t>Signed</a:t>
+            </a:r>
+            <a:r>
+              <a:rPr lang="en-US" dirty="0"/>
+              <a:t> </a:t>
+            </a:r>
+            <a:r>
+              <a:rPr lang="en-US" dirty="0">
+                <a:solidFill>
+                  <a:schemeClr val="tx1"/>
+                </a:solidFill>
+              </a:rPr>
+              <a:t>vs.</a:t>
+            </a:r>
+            <a:r>
+              <a:rPr lang="en-US" dirty="0"/>
+              <a:t> </a:t>
+            </a:r>
+            <a:r>
+              <a:rPr lang="en-US" b="1" dirty="0">
+                <a:solidFill>
+                  <a:srgbClr val="92D050"/>
+                </a:solidFill>
+              </a:rPr>
+              <a:t>Unsigned</a:t>
+            </a:r>
+            <a:r>
+              <a:rPr lang="en-US" dirty="0"/>
+              <a:t>: </a:t>
+            </a:r>
+            <a:r>
+              <a:rPr lang="en-US" dirty="0">
+                <a:solidFill>
+                  <a:srgbClr val="0070C0"/>
+                </a:solidFill>
+              </a:rPr>
+              <a:t>Use </a:t>
+            </a:r>
+            <a:r>
+              <a:rPr lang="en-US" dirty="0">
+                <a:solidFill>
+                  <a:srgbClr val="FF0000"/>
+                </a:solidFill>
+              </a:rPr>
+              <a:t>different</a:t>
+            </a:r>
+            <a:r>
+              <a:rPr lang="en-US" dirty="0">
+                <a:solidFill>
+                  <a:srgbClr val="0070C0"/>
+                </a:solidFill>
+              </a:rPr>
+              <a:t> instructions!</a:t>
+            </a:r>
+          </a:p>
+          <a:p>
+            <a:endParaRPr lang="en-US" dirty="0"/>
+          </a:p>
+          <a:p>
+            <a:r>
+              <a:rPr lang="en-US" b="1" dirty="0">
+                <a:solidFill>
+                  <a:srgbClr val="FF0000"/>
+                </a:solidFill>
+              </a:rPr>
+              <a:t>Signed</a:t>
+            </a:r>
+            <a:r>
+              <a:rPr lang="en-US" dirty="0"/>
+              <a:t> </a:t>
+            </a:r>
+            <a:r>
+              <a:rPr lang="en-US" dirty="0">
+                <a:solidFill>
+                  <a:schemeClr val="tx1"/>
+                </a:solidFill>
+              </a:rPr>
+              <a:t>Instruction Format:</a:t>
+            </a:r>
+          </a:p>
+          <a:p>
+            <a:pPr lvl="1"/>
+            <a:r>
+              <a:rPr lang="en-US" b="1" dirty="0">
+                <a:solidFill>
+                  <a:srgbClr val="FF0000"/>
+                </a:solidFill>
+              </a:rPr>
+              <a:t>S</a:t>
+            </a:r>
+            <a:r>
+              <a:rPr lang="en-US" dirty="0">
+                <a:solidFill>
+                  <a:srgbClr val="0070C0"/>
+                </a:solidFill>
+              </a:rPr>
+              <a:t>DIV	R0,R1,R2		// R0 </a:t>
+            </a:r>
+            <a:r>
+              <a:rPr lang="en-US" dirty="0">
+                <a:solidFill>
+                  <a:srgbClr val="0070C0"/>
+                </a:solidFill>
+                <a:sym typeface="Wingdings" panose="05000000000000000000" pitchFamily="2" charset="2"/>
+              </a:rPr>
+              <a:t>= R1 ÷ R2</a:t>
+            </a:r>
+          </a:p>
+          <a:p>
+            <a:r>
+              <a:rPr lang="en-US" b="1" dirty="0">
+                <a:solidFill>
+                  <a:srgbClr val="92D050"/>
+                </a:solidFill>
+              </a:rPr>
+              <a:t>Unsigned</a:t>
+            </a:r>
+            <a:r>
+              <a:rPr lang="en-US" dirty="0"/>
+              <a:t> </a:t>
+            </a:r>
+            <a:r>
+              <a:rPr lang="en-US" dirty="0">
+                <a:solidFill>
+                  <a:schemeClr val="tx1"/>
+                </a:solidFill>
+              </a:rPr>
+              <a:t>Instruction Format:</a:t>
+            </a:r>
+          </a:p>
+          <a:p>
+            <a:pPr lvl="1"/>
+            <a:r>
+              <a:rPr lang="en-US" b="1" dirty="0">
+                <a:solidFill>
+                  <a:srgbClr val="92D050"/>
+                </a:solidFill>
+              </a:rPr>
+              <a:t>U</a:t>
+            </a:r>
+            <a:r>
+              <a:rPr lang="en-US" dirty="0">
+                <a:solidFill>
+                  <a:srgbClr val="0070C0"/>
+                </a:solidFill>
+              </a:rPr>
+              <a:t>DIV	R0,R1,R2		// R0 </a:t>
+            </a:r>
+            <a:r>
+              <a:rPr lang="en-US" dirty="0">
+                <a:solidFill>
+                  <a:srgbClr val="0070C0"/>
+                </a:solidFill>
+                <a:sym typeface="Wingdings" panose="05000000000000000000" pitchFamily="2" charset="2"/>
+              </a:rPr>
+              <a:t>= R1 ÷ R2</a:t>
+            </a:r>
+          </a:p>
+          <a:p>
+            <a:endParaRPr lang="en-US" dirty="0"/>
+          </a:p>
+          <a:p>
+            <a:r>
+              <a:rPr lang="en-US" dirty="0">
+                <a:solidFill>
+                  <a:schemeClr val="tx1"/>
+                </a:solidFill>
+              </a:rPr>
+              <a:t>Flags:</a:t>
+            </a:r>
+            <a:r>
+              <a:rPr lang="en-US" dirty="0"/>
+              <a:t> </a:t>
+            </a:r>
+            <a:r>
+              <a:rPr lang="en-US" b="1" dirty="0">
+                <a:solidFill>
+                  <a:srgbClr val="FF0000"/>
+                </a:solidFill>
+              </a:rPr>
+              <a:t>Unaffected</a:t>
+            </a:r>
+          </a:p>
+          <a:p>
+            <a:endParaRPr lang="en-US" dirty="0"/>
+          </a:p>
+          <a:p>
+            <a:r>
+              <a:rPr lang="en-US" dirty="0">
+                <a:solidFill>
+                  <a:schemeClr val="tx1"/>
+                </a:solidFill>
+              </a:rPr>
+              <a:t>Overflow:</a:t>
+            </a:r>
+          </a:p>
+          <a:p>
+            <a:pPr lvl="1"/>
+            <a:r>
+              <a:rPr lang="en-US" dirty="0">
+                <a:solidFill>
+                  <a:srgbClr val="0070C0"/>
+                </a:solidFill>
+              </a:rPr>
+              <a:t>Division by zero</a:t>
+            </a:r>
+          </a:p>
+          <a:p>
+            <a:pPr lvl="1"/>
+            <a:r>
+              <a:rPr lang="en-US" dirty="0">
+                <a:solidFill>
+                  <a:srgbClr val="0070C0"/>
+                </a:solidFill>
+              </a:rPr>
+              <a:t>Full-scale negative divided by -1</a:t>
+            </a:r>
+          </a:p>
+        </p:txBody>
+      </p:sp>
+    </p:spTree>
+    <p:extLst>
+      <p:ext uri="{BB962C8B-B14F-4D97-AF65-F5344CB8AC3E}">
+        <p14:creationId xmlns:p14="http://schemas.microsoft.com/office/powerpoint/2010/main" val="3769027795"/>
+      </p:ext>
+    </p:extLst>
+  </p:cSld>
+  <p:clrMapOvr>
+    <a:masterClrMapping/>
+  </p:clrMapOvr>
+</p:sld>
+</file>
+
+<file path=ppt/slides/slide38.xml><?xml version="1.0" encoding="utf-8"?>
+<p:sld xmlns:a="http://schemas.openxmlformats.org/drawingml/2006/main" xmlns:r="http://schemas.openxmlformats.org/officeDocument/2006/relationships" xmlns:p="http://schemas.openxmlformats.org/presentationml/2006/main">
+  <p:cSld>
+    <p:spTree>
+      <p:nvGrpSpPr>
+        <p:cNvPr id="1" name=""/>
+        <p:cNvGrpSpPr/>
+        <p:nvPr/>
+      </p:nvGrpSpPr>
+      <p:grpSpPr>
+        <a:xfrm>
+          <a:off x="0" y="0"/>
+          <a:ext cx="0" cy="0"/>
+          <a:chOff x="0" y="0"/>
+          <a:chExt cx="0" cy="0"/>
+        </a:xfrm>
+      </p:grpSpPr>
+      <p:sp>
+        <p:nvSpPr>
+          <p:cNvPr id="2" name="Title 1"/>
+          <p:cNvSpPr>
+            <a:spLocks noGrp="1"/>
+          </p:cNvSpPr>
+          <p:nvPr>
+            <p:ph type="title"/>
+          </p:nvPr>
+        </p:nvSpPr>
         <p:spPr/>
         <p:txBody>
           <a:bodyPr rtlCol="0">
@@ -44364,70 +44428,6 @@
     <p:extLst>
       <p:ext uri="{BB962C8B-B14F-4D97-AF65-F5344CB8AC3E}">
         <p14:creationId xmlns:p14="http://schemas.microsoft.com/office/powerpoint/2010/main" val="2453586173"/>
-      </p:ext>
-    </p:extLst>
-  </p:cSld>
-  <p:clrMapOvr>
-    <a:masterClrMapping/>
-  </p:clrMapOvr>
-</p:sld>
-</file>
-
-<file path=ppt/slides/slide38.xml><?xml version="1.0" encoding="utf-8"?>
-<p:sld xmlns:a="http://schemas.openxmlformats.org/drawingml/2006/main" xmlns:r="http://schemas.openxmlformats.org/officeDocument/2006/relationships" xmlns:p="http://schemas.openxmlformats.org/presentationml/2006/main">
-  <p:cSld>
-    <p:spTree>
-      <p:nvGrpSpPr>
-        <p:cNvPr id="1" name="">
-          <a:extLst>
-            <a:ext uri="{FF2B5EF4-FFF2-40B4-BE49-F238E27FC236}">
-              <a16:creationId xmlns:a16="http://schemas.microsoft.com/office/drawing/2014/main" id="{84DA25F2-3AE0-BDCF-0880-EDD5EEF55E54}"/>
-            </a:ext>
-          </a:extLst>
-        </p:cNvPr>
-        <p:cNvGrpSpPr/>
-        <p:nvPr/>
-      </p:nvGrpSpPr>
-      <p:grpSpPr>
-        <a:xfrm>
-          <a:off x="0" y="0"/>
-          <a:ext cx="0" cy="0"/>
-          <a:chOff x="0" y="0"/>
-          <a:chExt cx="0" cy="0"/>
-        </a:xfrm>
-      </p:grpSpPr>
-      <p:sp>
-        <p:nvSpPr>
-          <p:cNvPr id="2" name="Title 1">
-            <a:extLst>
-              <a:ext uri="{FF2B5EF4-FFF2-40B4-BE49-F238E27FC236}">
-                <a16:creationId xmlns:a16="http://schemas.microsoft.com/office/drawing/2014/main" id="{6EAE57A2-3A61-C5F8-EEFD-EA2961784338}"/>
-              </a:ext>
-            </a:extLst>
-          </p:cNvPr>
-          <p:cNvSpPr>
-            <a:spLocks noGrp="1"/>
-          </p:cNvSpPr>
-          <p:nvPr>
-            <p:ph type="ctrTitle"/>
-          </p:nvPr>
-        </p:nvSpPr>
-        <p:spPr/>
-        <p:txBody>
-          <a:bodyPr/>
-          <a:lstStyle/>
-          <a:p>
-            <a:r>
-              <a:rPr lang="en-US" dirty="0"/>
-              <a:t>… to here …</a:t>
-            </a:r>
-          </a:p>
-        </p:txBody>
-      </p:sp>
-    </p:spTree>
-    <p:extLst>
-      <p:ext uri="{BB962C8B-B14F-4D97-AF65-F5344CB8AC3E}">
-        <p14:creationId xmlns:p14="http://schemas.microsoft.com/office/powerpoint/2010/main" val="2815624037"/>
       </p:ext>
     </p:extLst>
   </p:cSld>
@@ -51275,8 +51275,8 @@
           </a:p>
         </p:txBody>
       </p:sp>
-      <mc:AlternateContent xmlns:mc="http://schemas.openxmlformats.org/markup-compatibility/2006">
-        <mc:Choice xmlns:a14="http://schemas.microsoft.com/office/drawing/2010/main" Requires="a14">
+      <mc:AlternateContent xmlns:mc="http://schemas.openxmlformats.org/markup-compatibility/2006" xmlns:a14="http://schemas.microsoft.com/office/drawing/2010/main">
+        <mc:Choice Requires="a14">
           <p:sp>
             <p:nvSpPr>
               <p:cNvPr id="3" name="Rectangle 2">
@@ -51460,7 +51460,7 @@
             </p:txBody>
           </p:sp>
         </mc:Choice>
-        <mc:Fallback>
+        <mc:Fallback xmlns="">
           <p:sp>
             <p:nvSpPr>
               <p:cNvPr id="3" name="Rectangle 2">

</xml_diff>

<commit_message>
Move "to here" page ...
</commit_message>
<xml_diff>
--- a/Week04_IntegerArithmetic/Ch05_Integer Arithmetic_V4.pptx
+++ b/Week04_IntegerArithmetic/Ch05_Integer Arithmetic_V4.pptx
@@ -38,19 +38,19 @@
     <p:sldId id="378" r:id="rId26"/>
     <p:sldId id="358" r:id="rId27"/>
     <p:sldId id="362" r:id="rId28"/>
-    <p:sldId id="509" r:id="rId29"/>
-    <p:sldId id="363" r:id="rId30"/>
-    <p:sldId id="364" r:id="rId31"/>
-    <p:sldId id="365" r:id="rId32"/>
-    <p:sldId id="379" r:id="rId33"/>
-    <p:sldId id="380" r:id="rId34"/>
-    <p:sldId id="368" r:id="rId35"/>
-    <p:sldId id="369" r:id="rId36"/>
-    <p:sldId id="370" r:id="rId37"/>
-    <p:sldId id="371" r:id="rId38"/>
-    <p:sldId id="372" r:id="rId39"/>
-    <p:sldId id="373" r:id="rId40"/>
-    <p:sldId id="336" r:id="rId41"/>
+    <p:sldId id="363" r:id="rId29"/>
+    <p:sldId id="364" r:id="rId30"/>
+    <p:sldId id="365" r:id="rId31"/>
+    <p:sldId id="379" r:id="rId32"/>
+    <p:sldId id="380" r:id="rId33"/>
+    <p:sldId id="368" r:id="rId34"/>
+    <p:sldId id="369" r:id="rId35"/>
+    <p:sldId id="370" r:id="rId36"/>
+    <p:sldId id="371" r:id="rId37"/>
+    <p:sldId id="372" r:id="rId38"/>
+    <p:sldId id="373" r:id="rId39"/>
+    <p:sldId id="336" r:id="rId40"/>
+    <p:sldId id="509" r:id="rId41"/>
   </p:sldIdLst>
   <p:sldSz cx="12192000" cy="6858000"/>
   <p:notesSz cx="7010400" cy="9296400"/>
@@ -239,7 +239,7 @@
           <a:p>
             <a:fld id="{8E938536-29D3-49BD-A567-41CAF057586A}" type="datetimeFigureOut">
               <a:rPr lang="en-US" smtClean="0"/>
-              <a:t>10/21/2026</a:t>
+              <a:t>10/26/2026</a:t>
             </a:fld>
             <a:endParaRPr lang="en-US"/>
           </a:p>
@@ -404,7 +404,7 @@
           <a:p>
             <a:fld id="{71559A16-B3AD-4CE2-9A5E-FAAD3C2C27CA}" type="datetimeFigureOut">
               <a:rPr lang="en-US" smtClean="0"/>
-              <a:t>10/21/2026</a:t>
+              <a:t>10/26/2026</a:t>
             </a:fld>
             <a:endParaRPr lang="en-US"/>
           </a:p>
@@ -6059,7 +6059,7 @@
                 <a:tabLst/>
                 <a:defRPr/>
               </a:pPr>
-              <a:t>10/21/2026</a:t>
+              <a:t>10/26/2026</a:t>
             </a:fld>
             <a:endParaRPr kumimoji="0" lang="en-US" sz="1800" b="0" i="0" u="none" strike="noStrike" kern="1200" cap="none" spc="0" normalizeH="0" baseline="0" noProof="0">
               <a:ln>
@@ -6288,7 +6288,7 @@
             <a:fld id="{1D8BD707-D9CF-40AE-B4C6-C98DA3205C09}" type="datetimeFigureOut">
               <a:rPr lang="en-US" smtClean="0"/>
               <a:pPr/>
-              <a:t>10/21/2026</a:t>
+              <a:t>10/26/2026</a:t>
             </a:fld>
             <a:endParaRPr lang="en-US"/>
           </a:p>
@@ -6385,7 +6385,7 @@
             <a:fld id="{1D8BD707-D9CF-40AE-B4C6-C98DA3205C09}" type="datetimeFigureOut">
               <a:rPr lang="en-US" smtClean="0"/>
               <a:pPr/>
-              <a:t>10/21/2026</a:t>
+              <a:t>10/26/2026</a:t>
             </a:fld>
             <a:endParaRPr lang="en-US"/>
           </a:p>
@@ -32619,70 +32619,6 @@
   <p:cSld>
     <p:spTree>
       <p:nvGrpSpPr>
-        <p:cNvPr id="1" name="">
-          <a:extLst>
-            <a:ext uri="{FF2B5EF4-FFF2-40B4-BE49-F238E27FC236}">
-              <a16:creationId xmlns:a16="http://schemas.microsoft.com/office/drawing/2014/main" id="{84DA25F2-3AE0-BDCF-0880-EDD5EEF55E54}"/>
-            </a:ext>
-          </a:extLst>
-        </p:cNvPr>
-        <p:cNvGrpSpPr/>
-        <p:nvPr/>
-      </p:nvGrpSpPr>
-      <p:grpSpPr>
-        <a:xfrm>
-          <a:off x="0" y="0"/>
-          <a:ext cx="0" cy="0"/>
-          <a:chOff x="0" y="0"/>
-          <a:chExt cx="0" cy="0"/>
-        </a:xfrm>
-      </p:grpSpPr>
-      <p:sp>
-        <p:nvSpPr>
-          <p:cNvPr id="2" name="Title 1">
-            <a:extLst>
-              <a:ext uri="{FF2B5EF4-FFF2-40B4-BE49-F238E27FC236}">
-                <a16:creationId xmlns:a16="http://schemas.microsoft.com/office/drawing/2014/main" id="{6EAE57A2-3A61-C5F8-EEFD-EA2961784338}"/>
-              </a:ext>
-            </a:extLst>
-          </p:cNvPr>
-          <p:cNvSpPr>
-            <a:spLocks noGrp="1"/>
-          </p:cNvSpPr>
-          <p:nvPr>
-            <p:ph type="ctrTitle"/>
-          </p:nvPr>
-        </p:nvSpPr>
-        <p:spPr/>
-        <p:txBody>
-          <a:bodyPr/>
-          <a:lstStyle/>
-          <a:p>
-            <a:r>
-              <a:rPr lang="en-US" dirty="0"/>
-              <a:t>… to here …</a:t>
-            </a:r>
-          </a:p>
-        </p:txBody>
-      </p:sp>
-    </p:spTree>
-    <p:extLst>
-      <p:ext uri="{BB962C8B-B14F-4D97-AF65-F5344CB8AC3E}">
-        <p14:creationId xmlns:p14="http://schemas.microsoft.com/office/powerpoint/2010/main" val="2815624037"/>
-      </p:ext>
-    </p:extLst>
-  </p:cSld>
-  <p:clrMapOvr>
-    <a:masterClrMapping/>
-  </p:clrMapOvr>
-</p:sld>
-</file>
-
-<file path=ppt/slides/slide27.xml><?xml version="1.0" encoding="utf-8"?>
-<p:sld xmlns:a="http://schemas.openxmlformats.org/drawingml/2006/main" xmlns:r="http://schemas.openxmlformats.org/officeDocument/2006/relationships" xmlns:p="http://schemas.openxmlformats.org/presentationml/2006/main">
-  <p:cSld>
-    <p:spTree>
-      <p:nvGrpSpPr>
         <p:cNvPr id="1" name=""/>
         <p:cNvGrpSpPr/>
         <p:nvPr/>
@@ -32771,7 +32707,7 @@
 </p:sld>
 </file>
 
-<file path=ppt/slides/slide28.xml><?xml version="1.0" encoding="utf-8"?>
+<file path=ppt/slides/slide27.xml><?xml version="1.0" encoding="utf-8"?>
 <p:sld xmlns:a="http://schemas.openxmlformats.org/drawingml/2006/main" xmlns:r="http://schemas.openxmlformats.org/officeDocument/2006/relationships" xmlns:p="http://schemas.openxmlformats.org/presentationml/2006/main">
   <p:cSld>
     <p:spTree>
@@ -33305,7 +33241,7 @@
 </p:sld>
 </file>
 
-<file path=ppt/slides/slide29.xml><?xml version="1.0" encoding="utf-8"?>
+<file path=ppt/slides/slide28.xml><?xml version="1.0" encoding="utf-8"?>
 <p:sld xmlns:a="http://schemas.openxmlformats.org/drawingml/2006/main" xmlns:r="http://schemas.openxmlformats.org/officeDocument/2006/relationships" xmlns:p="http://schemas.openxmlformats.org/presentationml/2006/main">
   <p:cSld>
     <p:spTree>
@@ -35393,564 +35329,7 @@
 </p:sld>
 </file>
 
-<file path=ppt/slides/slide3.xml><?xml version="1.0" encoding="utf-8"?>
-<p:sld xmlns:a="http://schemas.openxmlformats.org/drawingml/2006/main" xmlns:r="http://schemas.openxmlformats.org/officeDocument/2006/relationships" xmlns:p="http://schemas.openxmlformats.org/presentationml/2006/main">
-  <p:cSld>
-    <p:spTree>
-      <p:nvGrpSpPr>
-        <p:cNvPr id="1" name=""/>
-        <p:cNvGrpSpPr/>
-        <p:nvPr/>
-      </p:nvGrpSpPr>
-      <p:grpSpPr>
-        <a:xfrm>
-          <a:off x="0" y="0"/>
-          <a:ext cx="0" cy="0"/>
-          <a:chOff x="0" y="0"/>
-          <a:chExt cx="0" cy="0"/>
-        </a:xfrm>
-      </p:grpSpPr>
-      <p:sp>
-        <p:nvSpPr>
-          <p:cNvPr id="2" name="Title 1"/>
-          <p:cNvSpPr>
-            <a:spLocks noGrp="1"/>
-          </p:cNvSpPr>
-          <p:nvPr>
-            <p:ph type="title"/>
-          </p:nvPr>
-        </p:nvSpPr>
-        <p:spPr>
-          <a:xfrm>
-            <a:off x="940527" y="726230"/>
-            <a:ext cx="7136673" cy="666899"/>
-          </a:xfrm>
-        </p:spPr>
-        <p:txBody>
-          <a:bodyPr/>
-          <a:lstStyle/>
-          <a:p>
-            <a:r>
-              <a:rPr lang="en-US" dirty="0"/>
-              <a:t>ADDITION AND SUBTRACTION</a:t>
-            </a:r>
-          </a:p>
-        </p:txBody>
-      </p:sp>
-      <p:sp>
-        <p:nvSpPr>
-          <p:cNvPr id="5" name="TextBox 4"/>
-          <p:cNvSpPr txBox="1"/>
-          <p:nvPr/>
-        </p:nvSpPr>
-        <p:spPr>
-          <a:xfrm>
-            <a:off x="5390583" y="2101586"/>
-            <a:ext cx="1283576" cy="2246769"/>
-          </a:xfrm>
-          <a:prstGeom prst="rect">
-            <a:avLst/>
-          </a:prstGeom>
-          <a:noFill/>
-        </p:spPr>
-        <p:txBody>
-          <a:bodyPr wrap="square" rtlCol="0">
-            <a:spAutoFit/>
-          </a:bodyPr>
-          <a:lstStyle/>
-          <a:p>
-            <a:pPr algn="ctr">
-              <a:tabLst>
-                <a:tab pos="3086100" algn="l"/>
-                <a:tab pos="5715000" algn="l"/>
-              </a:tabLst>
-            </a:pPr>
-            <a:r>
-              <a:rPr lang="en-US" sz="2800" i="1" dirty="0"/>
-              <a:t>Binary</a:t>
-            </a:r>
-          </a:p>
-          <a:p>
-            <a:pPr>
-              <a:tabLst>
-                <a:tab pos="3086100" algn="l"/>
-                <a:tab pos="5715000" algn="l"/>
-              </a:tabLst>
-            </a:pPr>
-            <a:endParaRPr lang="en-US" sz="2800" i="1" dirty="0"/>
-          </a:p>
-          <a:p>
-            <a:pPr>
-              <a:tabLst>
-                <a:tab pos="571500" algn="r"/>
-                <a:tab pos="3886200" algn="r"/>
-                <a:tab pos="6686550" algn="r"/>
-              </a:tabLst>
-            </a:pPr>
-            <a:r>
-              <a:rPr lang="en-US" sz="2800" dirty="0"/>
-              <a:t>  	0011</a:t>
-            </a:r>
-          </a:p>
-          <a:p>
-            <a:pPr>
-              <a:tabLst>
-                <a:tab pos="571500" algn="r"/>
-                <a:tab pos="3886200" algn="r"/>
-                <a:tab pos="6686550" algn="r"/>
-              </a:tabLst>
-            </a:pPr>
-            <a:r>
-              <a:rPr lang="en-US" sz="2800" dirty="0"/>
-              <a:t>+</a:t>
-            </a:r>
-            <a:r>
-              <a:rPr lang="en-US" sz="2800" u="sng" dirty="0"/>
-              <a:t>1010</a:t>
-            </a:r>
-          </a:p>
-          <a:p>
-            <a:pPr>
-              <a:tabLst>
-                <a:tab pos="857250" algn="r"/>
-                <a:tab pos="4000500" algn="r"/>
-                <a:tab pos="6858000" algn="r"/>
-              </a:tabLst>
-            </a:pPr>
-            <a:r>
-              <a:rPr lang="en-US" sz="2800" dirty="0"/>
-              <a:t>	  1101</a:t>
-            </a:r>
-            <a:r>
-              <a:rPr lang="en-US" sz="2800" baseline="-25000" dirty="0"/>
-              <a:t>2</a:t>
-            </a:r>
-            <a:endParaRPr lang="en-US" sz="2800" dirty="0"/>
-          </a:p>
-        </p:txBody>
-      </p:sp>
-      <p:grpSp>
-        <p:nvGrpSpPr>
-          <p:cNvPr id="12" name="Group 11"/>
-          <p:cNvGrpSpPr/>
-          <p:nvPr/>
-        </p:nvGrpSpPr>
-        <p:grpSpPr>
-          <a:xfrm>
-            <a:off x="4438569" y="5026231"/>
-            <a:ext cx="3794760" cy="1015663"/>
-            <a:chOff x="1620391" y="4175686"/>
-            <a:chExt cx="3794760" cy="1015663"/>
-          </a:xfrm>
-          <a:solidFill>
-            <a:schemeClr val="accent4">
-              <a:lumMod val="20000"/>
-              <a:lumOff val="80000"/>
-            </a:schemeClr>
-          </a:solidFill>
-        </p:grpSpPr>
-        <p:sp>
-          <p:nvSpPr>
-            <p:cNvPr id="10" name="TextBox 9"/>
-            <p:cNvSpPr txBox="1"/>
-            <p:nvPr/>
-          </p:nvSpPr>
-          <p:spPr>
-            <a:xfrm>
-              <a:off x="1620391" y="4175686"/>
-              <a:ext cx="3794760" cy="1015663"/>
-            </a:xfrm>
-            <a:prstGeom prst="rect">
-              <a:avLst/>
-            </a:prstGeom>
-            <a:grpFill/>
-            <a:ln/>
-          </p:spPr>
-          <p:style>
-            <a:lnRef idx="1">
-              <a:schemeClr val="accent2"/>
-            </a:lnRef>
-            <a:fillRef idx="2">
-              <a:schemeClr val="accent2"/>
-            </a:fillRef>
-            <a:effectRef idx="1">
-              <a:schemeClr val="accent2"/>
-            </a:effectRef>
-            <a:fontRef idx="minor">
-              <a:schemeClr val="dk1"/>
-            </a:fontRef>
-          </p:style>
-          <p:txBody>
-            <a:bodyPr wrap="square" tIns="91440" bIns="91440" rtlCol="0">
-              <a:spAutoFit/>
-            </a:bodyPr>
-            <a:lstStyle/>
-            <a:p>
-              <a:pPr marL="1027113" lvl="1"/>
-              <a:r>
-                <a:rPr lang="en-US" dirty="0"/>
-                <a:t>A single ADD (or SUB) instruction works for both </a:t>
-              </a:r>
-              <a:r>
-                <a:rPr lang="en-US" b="1" dirty="0">
-                  <a:solidFill>
-                    <a:srgbClr val="92D050"/>
-                  </a:solidFill>
-                </a:rPr>
-                <a:t>unsigned</a:t>
-              </a:r>
-              <a:r>
-                <a:rPr lang="en-US" dirty="0"/>
-                <a:t> and </a:t>
-              </a:r>
-              <a:r>
-                <a:rPr lang="en-US" b="1" dirty="0">
-                  <a:solidFill>
-                    <a:srgbClr val="FF0000"/>
-                  </a:solidFill>
-                </a:rPr>
-                <a:t>2’s comp</a:t>
-              </a:r>
-              <a:r>
-                <a:rPr lang="en-US" dirty="0"/>
-                <a:t>.</a:t>
-              </a:r>
-            </a:p>
-          </p:txBody>
-        </p:sp>
-        <p:pic>
-          <p:nvPicPr>
-            <p:cNvPr id="11" name="Picture 10" descr="http://www.aamu.edu/campuslife/living-on-campus/residentialLife/SiteAssets/pages/default/Warning_sign.png"/>
-            <p:cNvPicPr>
-              <a:picLocks noChangeAspect="1" noChangeArrowheads="1"/>
-            </p:cNvPicPr>
-            <p:nvPr/>
-          </p:nvPicPr>
-          <p:blipFill>
-            <a:blip r:embed="rId2" cstate="print">
-              <a:extLst>
-                <a:ext uri="{28A0092B-C50C-407E-A947-70E740481C1C}">
-                  <a14:useLocalDpi xmlns:a14="http://schemas.microsoft.com/office/drawing/2010/main" val="0"/>
-                </a:ext>
-              </a:extLst>
-            </a:blip>
-            <a:srcRect/>
-            <a:stretch>
-              <a:fillRect/>
-            </a:stretch>
-          </p:blipFill>
-          <p:spPr bwMode="auto">
-            <a:xfrm flipH="1">
-              <a:off x="1620391" y="4264417"/>
-              <a:ext cx="971826" cy="838200"/>
-            </a:xfrm>
-            <a:prstGeom prst="rect">
-              <a:avLst/>
-            </a:prstGeom>
-            <a:grpFill/>
-          </p:spPr>
-        </p:pic>
-      </p:grpSp>
-      <p:sp>
-        <p:nvSpPr>
-          <p:cNvPr id="22" name="TextBox 21"/>
-          <p:cNvSpPr txBox="1"/>
-          <p:nvPr/>
-        </p:nvSpPr>
-        <p:spPr>
-          <a:xfrm>
-            <a:off x="2057400" y="2101585"/>
-            <a:ext cx="1905000" cy="2246769"/>
-          </a:xfrm>
-          <a:prstGeom prst="rect">
-            <a:avLst/>
-          </a:prstGeom>
-          <a:noFill/>
-        </p:spPr>
-        <p:txBody>
-          <a:bodyPr wrap="square" rtlCol="0">
-            <a:spAutoFit/>
-          </a:bodyPr>
-          <a:lstStyle/>
-          <a:p>
-            <a:r>
-              <a:rPr lang="en-US" sz="2800" b="1" dirty="0">
-                <a:solidFill>
-                  <a:srgbClr val="92D050"/>
-                </a:solidFill>
-              </a:rPr>
-              <a:t>Unsigned</a:t>
-            </a:r>
-          </a:p>
-          <a:p>
-            <a:r>
-              <a:rPr lang="en-US" sz="2800" i="1" dirty="0"/>
-              <a:t> </a:t>
-            </a:r>
-          </a:p>
-          <a:p>
-            <a:r>
-              <a:rPr lang="en-US" sz="2800" dirty="0">
-                <a:latin typeface="Consolas" panose="020B0609020204030204" pitchFamily="49" charset="0"/>
-              </a:rPr>
-              <a:t>   3</a:t>
-            </a:r>
-          </a:p>
-          <a:p>
-            <a:r>
-              <a:rPr lang="en-US" sz="2800" dirty="0">
-                <a:latin typeface="Consolas" panose="020B0609020204030204" pitchFamily="49" charset="0"/>
-              </a:rPr>
-              <a:t> </a:t>
-            </a:r>
-            <a:r>
-              <a:rPr lang="en-US" sz="2800" u="sng" dirty="0">
-                <a:latin typeface="Consolas" panose="020B0609020204030204" pitchFamily="49" charset="0"/>
-              </a:rPr>
-              <a:t>+10</a:t>
-            </a:r>
-          </a:p>
-          <a:p>
-            <a:r>
-              <a:rPr lang="en-US" sz="2800" dirty="0">
-                <a:latin typeface="Consolas" panose="020B0609020204030204" pitchFamily="49" charset="0"/>
-              </a:rPr>
-              <a:t>  13</a:t>
-            </a:r>
-            <a:r>
-              <a:rPr lang="en-US" sz="2800" baseline="-25000" dirty="0">
-                <a:latin typeface="Consolas" panose="020B0609020204030204" pitchFamily="49" charset="0"/>
-              </a:rPr>
-              <a:t>10</a:t>
-            </a:r>
-          </a:p>
-        </p:txBody>
-      </p:sp>
-      <p:sp>
-        <p:nvSpPr>
-          <p:cNvPr id="23" name="TextBox 22"/>
-          <p:cNvSpPr txBox="1"/>
-          <p:nvPr/>
-        </p:nvSpPr>
-        <p:spPr>
-          <a:xfrm>
-            <a:off x="7821856" y="2108310"/>
-            <a:ext cx="3166986" cy="2246769"/>
-          </a:xfrm>
-          <a:prstGeom prst="rect">
-            <a:avLst/>
-          </a:prstGeom>
-          <a:noFill/>
-        </p:spPr>
-        <p:txBody>
-          <a:bodyPr wrap="square" rtlCol="0">
-            <a:spAutoFit/>
-          </a:bodyPr>
-          <a:lstStyle/>
-          <a:p>
-            <a:r>
-              <a:rPr lang="en-US" sz="2800" i="1" dirty="0"/>
-              <a:t>  </a:t>
-            </a:r>
-            <a:r>
-              <a:rPr lang="en-US" sz="2800" b="1" dirty="0">
-                <a:solidFill>
-                  <a:srgbClr val="FF0000"/>
-                </a:solidFill>
-              </a:rPr>
-              <a:t>2’s Complement </a:t>
-            </a:r>
-          </a:p>
-          <a:p>
-            <a:r>
-              <a:rPr lang="en-US" sz="2800" i="1" dirty="0"/>
-              <a:t> </a:t>
-            </a:r>
-          </a:p>
-          <a:p>
-            <a:r>
-              <a:rPr lang="en-US" sz="2800" dirty="0">
-                <a:latin typeface="Consolas" panose="020B0609020204030204" pitchFamily="49" charset="0"/>
-              </a:rPr>
-              <a:t>   (+3)</a:t>
-            </a:r>
-          </a:p>
-          <a:p>
-            <a:r>
-              <a:rPr lang="en-US" sz="2800" dirty="0">
-                <a:latin typeface="Consolas" panose="020B0609020204030204" pitchFamily="49" charset="0"/>
-              </a:rPr>
-              <a:t>  </a:t>
-            </a:r>
-            <a:r>
-              <a:rPr lang="en-US" sz="2800" u="sng" dirty="0">
-                <a:latin typeface="Consolas" panose="020B0609020204030204" pitchFamily="49" charset="0"/>
-              </a:rPr>
-              <a:t>+(-6)</a:t>
-            </a:r>
-          </a:p>
-          <a:p>
-            <a:r>
-              <a:rPr lang="en-US" sz="2800" dirty="0">
-                <a:latin typeface="Consolas" panose="020B0609020204030204" pitchFamily="49" charset="0"/>
-              </a:rPr>
-              <a:t>    -3</a:t>
-            </a:r>
-            <a:r>
-              <a:rPr lang="en-US" sz="2800" baseline="-25000" dirty="0">
-                <a:latin typeface="Consolas" panose="020B0609020204030204" pitchFamily="49" charset="0"/>
-              </a:rPr>
-              <a:t>10</a:t>
-            </a:r>
-          </a:p>
-        </p:txBody>
-      </p:sp>
-      <p:cxnSp>
-        <p:nvCxnSpPr>
-          <p:cNvPr id="34" name="Straight Arrow Connector 33"/>
-          <p:cNvCxnSpPr/>
-          <p:nvPr/>
-        </p:nvCxnSpPr>
-        <p:spPr>
-          <a:xfrm>
-            <a:off x="6915150" y="3503268"/>
-            <a:ext cx="906706" cy="0"/>
-          </a:xfrm>
-          <a:prstGeom prst="straightConnector1">
-            <a:avLst/>
-          </a:prstGeom>
-          <a:ln w="76200">
-            <a:solidFill>
-              <a:srgbClr val="FF0000"/>
-            </a:solidFill>
-            <a:tailEnd type="triangle"/>
-          </a:ln>
-        </p:spPr>
-        <p:style>
-          <a:lnRef idx="1">
-            <a:schemeClr val="accent1"/>
-          </a:lnRef>
-          <a:fillRef idx="0">
-            <a:schemeClr val="accent1"/>
-          </a:fillRef>
-          <a:effectRef idx="0">
-            <a:schemeClr val="accent1"/>
-          </a:effectRef>
-          <a:fontRef idx="minor">
-            <a:schemeClr val="tx1"/>
-          </a:fontRef>
-        </p:style>
-      </p:cxnSp>
-      <p:cxnSp>
-        <p:nvCxnSpPr>
-          <p:cNvPr id="35" name="Straight Arrow Connector 34"/>
-          <p:cNvCxnSpPr/>
-          <p:nvPr/>
-        </p:nvCxnSpPr>
-        <p:spPr>
-          <a:xfrm flipH="1" flipV="1">
-            <a:off x="3967547" y="3457930"/>
-            <a:ext cx="942045" cy="11332"/>
-          </a:xfrm>
-          <a:prstGeom prst="straightConnector1">
-            <a:avLst/>
-          </a:prstGeom>
-          <a:ln w="76200">
-            <a:solidFill>
-              <a:srgbClr val="FF0000"/>
-            </a:solidFill>
-            <a:tailEnd type="triangle"/>
-          </a:ln>
-        </p:spPr>
-        <p:style>
-          <a:lnRef idx="1">
-            <a:schemeClr val="accent1"/>
-          </a:lnRef>
-          <a:fillRef idx="0">
-            <a:schemeClr val="accent1"/>
-          </a:fillRef>
-          <a:effectRef idx="0">
-            <a:schemeClr val="accent1"/>
-          </a:effectRef>
-          <a:fontRef idx="minor">
-            <a:schemeClr val="tx1"/>
-          </a:fontRef>
-        </p:style>
-      </p:cxnSp>
-      <p:pic>
-        <p:nvPicPr>
-          <p:cNvPr id="13" name="Picture 12"/>
-          <p:cNvPicPr>
-            <a:picLocks noChangeAspect="1"/>
-          </p:cNvPicPr>
-          <p:nvPr/>
-        </p:nvPicPr>
-        <p:blipFill>
-          <a:blip r:embed="rId3" cstate="print">
-            <a:extLst>
-              <a:ext uri="{28A0092B-C50C-407E-A947-70E740481C1C}">
-                <a14:useLocalDpi xmlns:a14="http://schemas.microsoft.com/office/drawing/2010/main" val="0"/>
-              </a:ext>
-            </a:extLst>
-          </a:blip>
-          <a:stretch>
-            <a:fillRect/>
-          </a:stretch>
-        </p:blipFill>
-        <p:spPr>
-          <a:xfrm>
-            <a:off x="3413280" y="3765302"/>
-            <a:ext cx="533399" cy="523398"/>
-          </a:xfrm>
-          <a:prstGeom prst="rect">
-            <a:avLst/>
-          </a:prstGeom>
-        </p:spPr>
-      </p:pic>
-      <p:pic>
-        <p:nvPicPr>
-          <p:cNvPr id="14" name="Picture 13"/>
-          <p:cNvPicPr>
-            <a:picLocks noChangeAspect="1"/>
-          </p:cNvPicPr>
-          <p:nvPr/>
-        </p:nvPicPr>
-        <p:blipFill>
-          <a:blip r:embed="rId3" cstate="print">
-            <a:extLst>
-              <a:ext uri="{28A0092B-C50C-407E-A947-70E740481C1C}">
-                <a14:useLocalDpi xmlns:a14="http://schemas.microsoft.com/office/drawing/2010/main" val="0"/>
-              </a:ext>
-            </a:extLst>
-          </a:blip>
-          <a:stretch>
-            <a:fillRect/>
-          </a:stretch>
-        </p:blipFill>
-        <p:spPr>
-          <a:xfrm>
-            <a:off x="9533148" y="3766324"/>
-            <a:ext cx="533399" cy="523398"/>
-          </a:xfrm>
-          <a:prstGeom prst="rect">
-            <a:avLst/>
-          </a:prstGeom>
-        </p:spPr>
-      </p:pic>
-    </p:spTree>
-    <p:extLst>
-      <p:ext uri="{BB962C8B-B14F-4D97-AF65-F5344CB8AC3E}">
-        <p14:creationId xmlns:p14="http://schemas.microsoft.com/office/powerpoint/2010/main" val="1403904733"/>
-      </p:ext>
-    </p:extLst>
-  </p:cSld>
-  <p:clrMapOvr>
-    <a:masterClrMapping/>
-  </p:clrMapOvr>
-</p:sld>
-</file>
-
-<file path=ppt/slides/slide30.xml><?xml version="1.0" encoding="utf-8"?>
+<file path=ppt/slides/slide29.xml><?xml version="1.0" encoding="utf-8"?>
 <p:sld xmlns:a="http://schemas.openxmlformats.org/drawingml/2006/main" xmlns:r="http://schemas.openxmlformats.org/officeDocument/2006/relationships" xmlns:p="http://schemas.openxmlformats.org/presentationml/2006/main">
   <p:cSld>
     <p:spTree>
@@ -36882,7 +36261,564 @@
 </p:sld>
 </file>
 
-<file path=ppt/slides/slide31.xml><?xml version="1.0" encoding="utf-8"?>
+<file path=ppt/slides/slide3.xml><?xml version="1.0" encoding="utf-8"?>
+<p:sld xmlns:a="http://schemas.openxmlformats.org/drawingml/2006/main" xmlns:r="http://schemas.openxmlformats.org/officeDocument/2006/relationships" xmlns:p="http://schemas.openxmlformats.org/presentationml/2006/main">
+  <p:cSld>
+    <p:spTree>
+      <p:nvGrpSpPr>
+        <p:cNvPr id="1" name=""/>
+        <p:cNvGrpSpPr/>
+        <p:nvPr/>
+      </p:nvGrpSpPr>
+      <p:grpSpPr>
+        <a:xfrm>
+          <a:off x="0" y="0"/>
+          <a:ext cx="0" cy="0"/>
+          <a:chOff x="0" y="0"/>
+          <a:chExt cx="0" cy="0"/>
+        </a:xfrm>
+      </p:grpSpPr>
+      <p:sp>
+        <p:nvSpPr>
+          <p:cNvPr id="2" name="Title 1"/>
+          <p:cNvSpPr>
+            <a:spLocks noGrp="1"/>
+          </p:cNvSpPr>
+          <p:nvPr>
+            <p:ph type="title"/>
+          </p:nvPr>
+        </p:nvSpPr>
+        <p:spPr>
+          <a:xfrm>
+            <a:off x="940527" y="726230"/>
+            <a:ext cx="7136673" cy="666899"/>
+          </a:xfrm>
+        </p:spPr>
+        <p:txBody>
+          <a:bodyPr/>
+          <a:lstStyle/>
+          <a:p>
+            <a:r>
+              <a:rPr lang="en-US" dirty="0"/>
+              <a:t>ADDITION AND SUBTRACTION</a:t>
+            </a:r>
+          </a:p>
+        </p:txBody>
+      </p:sp>
+      <p:sp>
+        <p:nvSpPr>
+          <p:cNvPr id="5" name="TextBox 4"/>
+          <p:cNvSpPr txBox="1"/>
+          <p:nvPr/>
+        </p:nvSpPr>
+        <p:spPr>
+          <a:xfrm>
+            <a:off x="5390583" y="2101586"/>
+            <a:ext cx="1283576" cy="2246769"/>
+          </a:xfrm>
+          <a:prstGeom prst="rect">
+            <a:avLst/>
+          </a:prstGeom>
+          <a:noFill/>
+        </p:spPr>
+        <p:txBody>
+          <a:bodyPr wrap="square" rtlCol="0">
+            <a:spAutoFit/>
+          </a:bodyPr>
+          <a:lstStyle/>
+          <a:p>
+            <a:pPr algn="ctr">
+              <a:tabLst>
+                <a:tab pos="3086100" algn="l"/>
+                <a:tab pos="5715000" algn="l"/>
+              </a:tabLst>
+            </a:pPr>
+            <a:r>
+              <a:rPr lang="en-US" sz="2800" i="1" dirty="0"/>
+              <a:t>Binary</a:t>
+            </a:r>
+          </a:p>
+          <a:p>
+            <a:pPr>
+              <a:tabLst>
+                <a:tab pos="3086100" algn="l"/>
+                <a:tab pos="5715000" algn="l"/>
+              </a:tabLst>
+            </a:pPr>
+            <a:endParaRPr lang="en-US" sz="2800" i="1" dirty="0"/>
+          </a:p>
+          <a:p>
+            <a:pPr>
+              <a:tabLst>
+                <a:tab pos="571500" algn="r"/>
+                <a:tab pos="3886200" algn="r"/>
+                <a:tab pos="6686550" algn="r"/>
+              </a:tabLst>
+            </a:pPr>
+            <a:r>
+              <a:rPr lang="en-US" sz="2800" dirty="0"/>
+              <a:t>  	0011</a:t>
+            </a:r>
+          </a:p>
+          <a:p>
+            <a:pPr>
+              <a:tabLst>
+                <a:tab pos="571500" algn="r"/>
+                <a:tab pos="3886200" algn="r"/>
+                <a:tab pos="6686550" algn="r"/>
+              </a:tabLst>
+            </a:pPr>
+            <a:r>
+              <a:rPr lang="en-US" sz="2800" dirty="0"/>
+              <a:t>+</a:t>
+            </a:r>
+            <a:r>
+              <a:rPr lang="en-US" sz="2800" u="sng" dirty="0"/>
+              <a:t>1010</a:t>
+            </a:r>
+          </a:p>
+          <a:p>
+            <a:pPr>
+              <a:tabLst>
+                <a:tab pos="857250" algn="r"/>
+                <a:tab pos="4000500" algn="r"/>
+                <a:tab pos="6858000" algn="r"/>
+              </a:tabLst>
+            </a:pPr>
+            <a:r>
+              <a:rPr lang="en-US" sz="2800" dirty="0"/>
+              <a:t>	  1101</a:t>
+            </a:r>
+            <a:r>
+              <a:rPr lang="en-US" sz="2800" baseline="-25000" dirty="0"/>
+              <a:t>2</a:t>
+            </a:r>
+            <a:endParaRPr lang="en-US" sz="2800" dirty="0"/>
+          </a:p>
+        </p:txBody>
+      </p:sp>
+      <p:grpSp>
+        <p:nvGrpSpPr>
+          <p:cNvPr id="12" name="Group 11"/>
+          <p:cNvGrpSpPr/>
+          <p:nvPr/>
+        </p:nvGrpSpPr>
+        <p:grpSpPr>
+          <a:xfrm>
+            <a:off x="4438569" y="5026231"/>
+            <a:ext cx="3794760" cy="1015663"/>
+            <a:chOff x="1620391" y="4175686"/>
+            <a:chExt cx="3794760" cy="1015663"/>
+          </a:xfrm>
+          <a:solidFill>
+            <a:schemeClr val="accent4">
+              <a:lumMod val="20000"/>
+              <a:lumOff val="80000"/>
+            </a:schemeClr>
+          </a:solidFill>
+        </p:grpSpPr>
+        <p:sp>
+          <p:nvSpPr>
+            <p:cNvPr id="10" name="TextBox 9"/>
+            <p:cNvSpPr txBox="1"/>
+            <p:nvPr/>
+          </p:nvSpPr>
+          <p:spPr>
+            <a:xfrm>
+              <a:off x="1620391" y="4175686"/>
+              <a:ext cx="3794760" cy="1015663"/>
+            </a:xfrm>
+            <a:prstGeom prst="rect">
+              <a:avLst/>
+            </a:prstGeom>
+            <a:grpFill/>
+            <a:ln/>
+          </p:spPr>
+          <p:style>
+            <a:lnRef idx="1">
+              <a:schemeClr val="accent2"/>
+            </a:lnRef>
+            <a:fillRef idx="2">
+              <a:schemeClr val="accent2"/>
+            </a:fillRef>
+            <a:effectRef idx="1">
+              <a:schemeClr val="accent2"/>
+            </a:effectRef>
+            <a:fontRef idx="minor">
+              <a:schemeClr val="dk1"/>
+            </a:fontRef>
+          </p:style>
+          <p:txBody>
+            <a:bodyPr wrap="square" tIns="91440" bIns="91440" rtlCol="0">
+              <a:spAutoFit/>
+            </a:bodyPr>
+            <a:lstStyle/>
+            <a:p>
+              <a:pPr marL="1027113" lvl="1"/>
+              <a:r>
+                <a:rPr lang="en-US" dirty="0"/>
+                <a:t>A single ADD (or SUB) instruction works for both </a:t>
+              </a:r>
+              <a:r>
+                <a:rPr lang="en-US" b="1" dirty="0">
+                  <a:solidFill>
+                    <a:srgbClr val="92D050"/>
+                  </a:solidFill>
+                </a:rPr>
+                <a:t>unsigned</a:t>
+              </a:r>
+              <a:r>
+                <a:rPr lang="en-US" dirty="0"/>
+                <a:t> and </a:t>
+              </a:r>
+              <a:r>
+                <a:rPr lang="en-US" b="1" dirty="0">
+                  <a:solidFill>
+                    <a:srgbClr val="FF0000"/>
+                  </a:solidFill>
+                </a:rPr>
+                <a:t>2’s comp</a:t>
+              </a:r>
+              <a:r>
+                <a:rPr lang="en-US" dirty="0"/>
+                <a:t>.</a:t>
+              </a:r>
+            </a:p>
+          </p:txBody>
+        </p:sp>
+        <p:pic>
+          <p:nvPicPr>
+            <p:cNvPr id="11" name="Picture 10" descr="http://www.aamu.edu/campuslife/living-on-campus/residentialLife/SiteAssets/pages/default/Warning_sign.png"/>
+            <p:cNvPicPr>
+              <a:picLocks noChangeAspect="1" noChangeArrowheads="1"/>
+            </p:cNvPicPr>
+            <p:nvPr/>
+          </p:nvPicPr>
+          <p:blipFill>
+            <a:blip r:embed="rId2" cstate="print">
+              <a:extLst>
+                <a:ext uri="{28A0092B-C50C-407E-A947-70E740481C1C}">
+                  <a14:useLocalDpi xmlns:a14="http://schemas.microsoft.com/office/drawing/2010/main" val="0"/>
+                </a:ext>
+              </a:extLst>
+            </a:blip>
+            <a:srcRect/>
+            <a:stretch>
+              <a:fillRect/>
+            </a:stretch>
+          </p:blipFill>
+          <p:spPr bwMode="auto">
+            <a:xfrm flipH="1">
+              <a:off x="1620391" y="4264417"/>
+              <a:ext cx="971826" cy="838200"/>
+            </a:xfrm>
+            <a:prstGeom prst="rect">
+              <a:avLst/>
+            </a:prstGeom>
+            <a:grpFill/>
+          </p:spPr>
+        </p:pic>
+      </p:grpSp>
+      <p:sp>
+        <p:nvSpPr>
+          <p:cNvPr id="22" name="TextBox 21"/>
+          <p:cNvSpPr txBox="1"/>
+          <p:nvPr/>
+        </p:nvSpPr>
+        <p:spPr>
+          <a:xfrm>
+            <a:off x="2057400" y="2101585"/>
+            <a:ext cx="1905000" cy="2246769"/>
+          </a:xfrm>
+          <a:prstGeom prst="rect">
+            <a:avLst/>
+          </a:prstGeom>
+          <a:noFill/>
+        </p:spPr>
+        <p:txBody>
+          <a:bodyPr wrap="square" rtlCol="0">
+            <a:spAutoFit/>
+          </a:bodyPr>
+          <a:lstStyle/>
+          <a:p>
+            <a:r>
+              <a:rPr lang="en-US" sz="2800" b="1" dirty="0">
+                <a:solidFill>
+                  <a:srgbClr val="92D050"/>
+                </a:solidFill>
+              </a:rPr>
+              <a:t>Unsigned</a:t>
+            </a:r>
+          </a:p>
+          <a:p>
+            <a:r>
+              <a:rPr lang="en-US" sz="2800" i="1" dirty="0"/>
+              <a:t> </a:t>
+            </a:r>
+          </a:p>
+          <a:p>
+            <a:r>
+              <a:rPr lang="en-US" sz="2800" dirty="0">
+                <a:latin typeface="Consolas" panose="020B0609020204030204" pitchFamily="49" charset="0"/>
+              </a:rPr>
+              <a:t>   3</a:t>
+            </a:r>
+          </a:p>
+          <a:p>
+            <a:r>
+              <a:rPr lang="en-US" sz="2800" dirty="0">
+                <a:latin typeface="Consolas" panose="020B0609020204030204" pitchFamily="49" charset="0"/>
+              </a:rPr>
+              <a:t> </a:t>
+            </a:r>
+            <a:r>
+              <a:rPr lang="en-US" sz="2800" u="sng" dirty="0">
+                <a:latin typeface="Consolas" panose="020B0609020204030204" pitchFamily="49" charset="0"/>
+              </a:rPr>
+              <a:t>+10</a:t>
+            </a:r>
+          </a:p>
+          <a:p>
+            <a:r>
+              <a:rPr lang="en-US" sz="2800" dirty="0">
+                <a:latin typeface="Consolas" panose="020B0609020204030204" pitchFamily="49" charset="0"/>
+              </a:rPr>
+              <a:t>  13</a:t>
+            </a:r>
+            <a:r>
+              <a:rPr lang="en-US" sz="2800" baseline="-25000" dirty="0">
+                <a:latin typeface="Consolas" panose="020B0609020204030204" pitchFamily="49" charset="0"/>
+              </a:rPr>
+              <a:t>10</a:t>
+            </a:r>
+          </a:p>
+        </p:txBody>
+      </p:sp>
+      <p:sp>
+        <p:nvSpPr>
+          <p:cNvPr id="23" name="TextBox 22"/>
+          <p:cNvSpPr txBox="1"/>
+          <p:nvPr/>
+        </p:nvSpPr>
+        <p:spPr>
+          <a:xfrm>
+            <a:off x="7821856" y="2108310"/>
+            <a:ext cx="3166986" cy="2246769"/>
+          </a:xfrm>
+          <a:prstGeom prst="rect">
+            <a:avLst/>
+          </a:prstGeom>
+          <a:noFill/>
+        </p:spPr>
+        <p:txBody>
+          <a:bodyPr wrap="square" rtlCol="0">
+            <a:spAutoFit/>
+          </a:bodyPr>
+          <a:lstStyle/>
+          <a:p>
+            <a:r>
+              <a:rPr lang="en-US" sz="2800" i="1" dirty="0"/>
+              <a:t>  </a:t>
+            </a:r>
+            <a:r>
+              <a:rPr lang="en-US" sz="2800" b="1" dirty="0">
+                <a:solidFill>
+                  <a:srgbClr val="FF0000"/>
+                </a:solidFill>
+              </a:rPr>
+              <a:t>2’s Complement </a:t>
+            </a:r>
+          </a:p>
+          <a:p>
+            <a:r>
+              <a:rPr lang="en-US" sz="2800" i="1" dirty="0"/>
+              <a:t> </a:t>
+            </a:r>
+          </a:p>
+          <a:p>
+            <a:r>
+              <a:rPr lang="en-US" sz="2800" dirty="0">
+                <a:latin typeface="Consolas" panose="020B0609020204030204" pitchFamily="49" charset="0"/>
+              </a:rPr>
+              <a:t>   (+3)</a:t>
+            </a:r>
+          </a:p>
+          <a:p>
+            <a:r>
+              <a:rPr lang="en-US" sz="2800" dirty="0">
+                <a:latin typeface="Consolas" panose="020B0609020204030204" pitchFamily="49" charset="0"/>
+              </a:rPr>
+              <a:t>  </a:t>
+            </a:r>
+            <a:r>
+              <a:rPr lang="en-US" sz="2800" u="sng" dirty="0">
+                <a:latin typeface="Consolas" panose="020B0609020204030204" pitchFamily="49" charset="0"/>
+              </a:rPr>
+              <a:t>+(-6)</a:t>
+            </a:r>
+          </a:p>
+          <a:p>
+            <a:r>
+              <a:rPr lang="en-US" sz="2800" dirty="0">
+                <a:latin typeface="Consolas" panose="020B0609020204030204" pitchFamily="49" charset="0"/>
+              </a:rPr>
+              <a:t>    -3</a:t>
+            </a:r>
+            <a:r>
+              <a:rPr lang="en-US" sz="2800" baseline="-25000" dirty="0">
+                <a:latin typeface="Consolas" panose="020B0609020204030204" pitchFamily="49" charset="0"/>
+              </a:rPr>
+              <a:t>10</a:t>
+            </a:r>
+          </a:p>
+        </p:txBody>
+      </p:sp>
+      <p:cxnSp>
+        <p:nvCxnSpPr>
+          <p:cNvPr id="34" name="Straight Arrow Connector 33"/>
+          <p:cNvCxnSpPr/>
+          <p:nvPr/>
+        </p:nvCxnSpPr>
+        <p:spPr>
+          <a:xfrm>
+            <a:off x="6915150" y="3503268"/>
+            <a:ext cx="906706" cy="0"/>
+          </a:xfrm>
+          <a:prstGeom prst="straightConnector1">
+            <a:avLst/>
+          </a:prstGeom>
+          <a:ln w="76200">
+            <a:solidFill>
+              <a:srgbClr val="FF0000"/>
+            </a:solidFill>
+            <a:tailEnd type="triangle"/>
+          </a:ln>
+        </p:spPr>
+        <p:style>
+          <a:lnRef idx="1">
+            <a:schemeClr val="accent1"/>
+          </a:lnRef>
+          <a:fillRef idx="0">
+            <a:schemeClr val="accent1"/>
+          </a:fillRef>
+          <a:effectRef idx="0">
+            <a:schemeClr val="accent1"/>
+          </a:effectRef>
+          <a:fontRef idx="minor">
+            <a:schemeClr val="tx1"/>
+          </a:fontRef>
+        </p:style>
+      </p:cxnSp>
+      <p:cxnSp>
+        <p:nvCxnSpPr>
+          <p:cNvPr id="35" name="Straight Arrow Connector 34"/>
+          <p:cNvCxnSpPr/>
+          <p:nvPr/>
+        </p:nvCxnSpPr>
+        <p:spPr>
+          <a:xfrm flipH="1" flipV="1">
+            <a:off x="3967547" y="3457930"/>
+            <a:ext cx="942045" cy="11332"/>
+          </a:xfrm>
+          <a:prstGeom prst="straightConnector1">
+            <a:avLst/>
+          </a:prstGeom>
+          <a:ln w="76200">
+            <a:solidFill>
+              <a:srgbClr val="FF0000"/>
+            </a:solidFill>
+            <a:tailEnd type="triangle"/>
+          </a:ln>
+        </p:spPr>
+        <p:style>
+          <a:lnRef idx="1">
+            <a:schemeClr val="accent1"/>
+          </a:lnRef>
+          <a:fillRef idx="0">
+            <a:schemeClr val="accent1"/>
+          </a:fillRef>
+          <a:effectRef idx="0">
+            <a:schemeClr val="accent1"/>
+          </a:effectRef>
+          <a:fontRef idx="minor">
+            <a:schemeClr val="tx1"/>
+          </a:fontRef>
+        </p:style>
+      </p:cxnSp>
+      <p:pic>
+        <p:nvPicPr>
+          <p:cNvPr id="13" name="Picture 12"/>
+          <p:cNvPicPr>
+            <a:picLocks noChangeAspect="1"/>
+          </p:cNvPicPr>
+          <p:nvPr/>
+        </p:nvPicPr>
+        <p:blipFill>
+          <a:blip r:embed="rId3" cstate="print">
+            <a:extLst>
+              <a:ext uri="{28A0092B-C50C-407E-A947-70E740481C1C}">
+                <a14:useLocalDpi xmlns:a14="http://schemas.microsoft.com/office/drawing/2010/main" val="0"/>
+              </a:ext>
+            </a:extLst>
+          </a:blip>
+          <a:stretch>
+            <a:fillRect/>
+          </a:stretch>
+        </p:blipFill>
+        <p:spPr>
+          <a:xfrm>
+            <a:off x="3413280" y="3765302"/>
+            <a:ext cx="533399" cy="523398"/>
+          </a:xfrm>
+          <a:prstGeom prst="rect">
+            <a:avLst/>
+          </a:prstGeom>
+        </p:spPr>
+      </p:pic>
+      <p:pic>
+        <p:nvPicPr>
+          <p:cNvPr id="14" name="Picture 13"/>
+          <p:cNvPicPr>
+            <a:picLocks noChangeAspect="1"/>
+          </p:cNvPicPr>
+          <p:nvPr/>
+        </p:nvPicPr>
+        <p:blipFill>
+          <a:blip r:embed="rId3" cstate="print">
+            <a:extLst>
+              <a:ext uri="{28A0092B-C50C-407E-A947-70E740481C1C}">
+                <a14:useLocalDpi xmlns:a14="http://schemas.microsoft.com/office/drawing/2010/main" val="0"/>
+              </a:ext>
+            </a:extLst>
+          </a:blip>
+          <a:stretch>
+            <a:fillRect/>
+          </a:stretch>
+        </p:blipFill>
+        <p:spPr>
+          <a:xfrm>
+            <a:off x="9533148" y="3766324"/>
+            <a:ext cx="533399" cy="523398"/>
+          </a:xfrm>
+          <a:prstGeom prst="rect">
+            <a:avLst/>
+          </a:prstGeom>
+        </p:spPr>
+      </p:pic>
+    </p:spTree>
+    <p:extLst>
+      <p:ext uri="{BB962C8B-B14F-4D97-AF65-F5344CB8AC3E}">
+        <p14:creationId xmlns:p14="http://schemas.microsoft.com/office/powerpoint/2010/main" val="1403904733"/>
+      </p:ext>
+    </p:extLst>
+  </p:cSld>
+  <p:clrMapOvr>
+    <a:masterClrMapping/>
+  </p:clrMapOvr>
+</p:sld>
+</file>
+
+<file path=ppt/slides/slide30.xml><?xml version="1.0" encoding="utf-8"?>
 <p:sld xmlns:a="http://schemas.openxmlformats.org/drawingml/2006/main" xmlns:r="http://schemas.openxmlformats.org/officeDocument/2006/relationships" xmlns:p="http://schemas.openxmlformats.org/presentationml/2006/main">
   <p:cSld>
     <p:spTree>
@@ -41925,7 +41861,7 @@
 </p:sld>
 </file>
 
-<file path=ppt/slides/slide32.xml><?xml version="1.0" encoding="utf-8"?>
+<file path=ppt/slides/slide31.xml><?xml version="1.0" encoding="utf-8"?>
 <p:sld xmlns:a="http://schemas.openxmlformats.org/drawingml/2006/main" xmlns:r="http://schemas.openxmlformats.org/officeDocument/2006/relationships" xmlns:p="http://schemas.openxmlformats.org/presentationml/2006/main">
   <p:cSld>
     <p:spTree>
@@ -42002,6 +41938,444 @@
     <p:extLst>
       <p:ext uri="{BB962C8B-B14F-4D97-AF65-F5344CB8AC3E}">
         <p14:creationId xmlns:p14="http://schemas.microsoft.com/office/powerpoint/2010/main" val="338773540"/>
+      </p:ext>
+    </p:extLst>
+  </p:cSld>
+  <p:clrMapOvr>
+    <a:masterClrMapping/>
+  </p:clrMapOvr>
+</p:sld>
+</file>
+
+<file path=ppt/slides/slide32.xml><?xml version="1.0" encoding="utf-8"?>
+<p:sld xmlns:a="http://schemas.openxmlformats.org/drawingml/2006/main" xmlns:r="http://schemas.openxmlformats.org/officeDocument/2006/relationships" xmlns:p="http://schemas.openxmlformats.org/presentationml/2006/main">
+  <p:cSld>
+    <p:spTree>
+      <p:nvGrpSpPr>
+        <p:cNvPr id="1" name=""/>
+        <p:cNvGrpSpPr/>
+        <p:nvPr/>
+      </p:nvGrpSpPr>
+      <p:grpSpPr>
+        <a:xfrm>
+          <a:off x="0" y="0"/>
+          <a:ext cx="0" cy="0"/>
+          <a:chOff x="0" y="0"/>
+          <a:chExt cx="0" cy="0"/>
+        </a:xfrm>
+      </p:grpSpPr>
+      <p:sp>
+        <p:nvSpPr>
+          <p:cNvPr id="2" name="Title 1"/>
+          <p:cNvSpPr>
+            <a:spLocks noGrp="1"/>
+          </p:cNvSpPr>
+          <p:nvPr>
+            <p:ph type="title"/>
+          </p:nvPr>
+        </p:nvSpPr>
+        <p:spPr>
+          <a:xfrm>
+            <a:off x="936516" y="749193"/>
+            <a:ext cx="4112737" cy="654492"/>
+          </a:xfrm>
+        </p:spPr>
+        <p:txBody>
+          <a:bodyPr/>
+          <a:lstStyle/>
+          <a:p>
+            <a:r>
+              <a:rPr lang="en-US" dirty="0"/>
+              <a:t>Integer Addition</a:t>
+            </a:r>
+          </a:p>
+        </p:txBody>
+      </p:sp>
+      <p:sp>
+        <p:nvSpPr>
+          <p:cNvPr id="5" name="Content Placeholder 4"/>
+          <p:cNvSpPr>
+            <a:spLocks noGrp="1"/>
+          </p:cNvSpPr>
+          <p:nvPr>
+            <p:ph idx="1"/>
+          </p:nvPr>
+        </p:nvSpPr>
+        <p:spPr>
+          <a:xfrm>
+            <a:off x="936516" y="1643270"/>
+            <a:ext cx="10433326" cy="4974098"/>
+          </a:xfrm>
+        </p:spPr>
+        <p:txBody>
+          <a:bodyPr>
+            <a:normAutofit/>
+          </a:bodyPr>
+          <a:lstStyle/>
+          <a:p>
+            <a:r>
+              <a:rPr lang="en-US" dirty="0">
+                <a:solidFill>
+                  <a:schemeClr val="tx1"/>
+                </a:solidFill>
+              </a:rPr>
+              <a:t>Instructions: </a:t>
+            </a:r>
+            <a:r>
+              <a:rPr lang="en-US" dirty="0">
+                <a:solidFill>
+                  <a:srgbClr val="0070C0"/>
+                </a:solidFill>
+              </a:rPr>
+              <a:t>ADD{</a:t>
+            </a:r>
+            <a:r>
+              <a:rPr lang="en-US" b="1" dirty="0">
+                <a:solidFill>
+                  <a:srgbClr val="FF0000"/>
+                </a:solidFill>
+              </a:rPr>
+              <a:t>S</a:t>
+            </a:r>
+            <a:r>
+              <a:rPr lang="en-US" dirty="0">
+                <a:solidFill>
+                  <a:srgbClr val="0070C0"/>
+                </a:solidFill>
+              </a:rPr>
+              <a:t>}</a:t>
+            </a:r>
+            <a:r>
+              <a:rPr lang="en-US" dirty="0">
+                <a:solidFill>
+                  <a:schemeClr val="tx1"/>
+                </a:solidFill>
+              </a:rPr>
+              <a:t>,</a:t>
+            </a:r>
+            <a:r>
+              <a:rPr lang="en-US" dirty="0">
+                <a:solidFill>
+                  <a:srgbClr val="0070C0"/>
+                </a:solidFill>
+              </a:rPr>
+              <a:t> ADC{</a:t>
+            </a:r>
+            <a:r>
+              <a:rPr lang="en-US" b="1" dirty="0">
+                <a:solidFill>
+                  <a:srgbClr val="FF0000"/>
+                </a:solidFill>
+              </a:rPr>
+              <a:t>S</a:t>
+            </a:r>
+            <a:r>
+              <a:rPr lang="en-US" dirty="0">
+                <a:solidFill>
+                  <a:srgbClr val="0070C0"/>
+                </a:solidFill>
+              </a:rPr>
+              <a:t>}</a:t>
+            </a:r>
+          </a:p>
+          <a:p>
+            <a:r>
+              <a:rPr lang="en-US" dirty="0">
+                <a:solidFill>
+                  <a:schemeClr val="tx1"/>
+                </a:solidFill>
+              </a:rPr>
+              <a:t>Format Examples:</a:t>
+            </a:r>
+          </a:p>
+          <a:p>
+            <a:pPr lvl="1"/>
+            <a:r>
+              <a:rPr lang="en-US" dirty="0">
+                <a:solidFill>
+                  <a:schemeClr val="tx1"/>
+                </a:solidFill>
+              </a:rPr>
+              <a:t>ADD	R0,R1,</a:t>
+            </a:r>
+            <a:r>
+              <a:rPr lang="en-US" b="1" dirty="0">
+                <a:solidFill>
+                  <a:srgbClr val="0000FF"/>
+                </a:solidFill>
+              </a:rPr>
+              <a:t>#5</a:t>
+            </a:r>
+            <a:r>
+              <a:rPr lang="en-US" dirty="0">
+                <a:solidFill>
+                  <a:schemeClr val="tx1"/>
+                </a:solidFill>
+              </a:rPr>
+              <a:t>			// R0 </a:t>
+            </a:r>
+            <a:r>
+              <a:rPr lang="en-US" dirty="0">
+                <a:solidFill>
+                  <a:schemeClr val="tx1"/>
+                </a:solidFill>
+                <a:sym typeface="Wingdings" panose="05000000000000000000" pitchFamily="2" charset="2"/>
+              </a:rPr>
+              <a:t>= R1 + 5</a:t>
+            </a:r>
+            <a:endParaRPr lang="en-US" dirty="0">
+              <a:solidFill>
+                <a:schemeClr val="tx1"/>
+              </a:solidFill>
+            </a:endParaRPr>
+          </a:p>
+          <a:p>
+            <a:pPr lvl="1"/>
+            <a:r>
+              <a:rPr lang="en-US" dirty="0">
+                <a:solidFill>
+                  <a:schemeClr val="tx1"/>
+                </a:solidFill>
+              </a:rPr>
+              <a:t>ADD	R0,R1,R2		// R0 </a:t>
+            </a:r>
+            <a:r>
+              <a:rPr lang="en-US" dirty="0">
+                <a:solidFill>
+                  <a:schemeClr val="tx1"/>
+                </a:solidFill>
+                <a:sym typeface="Wingdings" panose="05000000000000000000" pitchFamily="2" charset="2"/>
+              </a:rPr>
+              <a:t>= R1 + R2</a:t>
+            </a:r>
+            <a:endParaRPr lang="en-US" dirty="0">
+              <a:solidFill>
+                <a:schemeClr val="tx1"/>
+              </a:solidFill>
+            </a:endParaRPr>
+          </a:p>
+          <a:p>
+            <a:pPr lvl="1"/>
+            <a:r>
+              <a:rPr lang="en-US" dirty="0">
+                <a:solidFill>
+                  <a:schemeClr val="tx1"/>
+                </a:solidFill>
+              </a:rPr>
+              <a:t>ADD	R0,R1,</a:t>
+            </a:r>
+            <a:r>
+              <a:rPr lang="en-US" b="1" dirty="0">
+                <a:solidFill>
+                  <a:srgbClr val="0000FF"/>
+                </a:solidFill>
+              </a:rPr>
+              <a:t>R2,LSL #2</a:t>
+            </a:r>
+            <a:r>
+              <a:rPr lang="en-US" dirty="0">
+                <a:solidFill>
+                  <a:schemeClr val="tx1"/>
+                </a:solidFill>
+              </a:rPr>
+              <a:t>		// R0 </a:t>
+            </a:r>
+            <a:r>
+              <a:rPr lang="en-US" dirty="0">
+                <a:solidFill>
+                  <a:schemeClr val="tx1"/>
+                </a:solidFill>
+                <a:sym typeface="Wingdings" panose="05000000000000000000" pitchFamily="2" charset="2"/>
+              </a:rPr>
+              <a:t>= R1 + </a:t>
+            </a:r>
+            <a:r>
+              <a:rPr lang="en-US" b="1" dirty="0">
+                <a:solidFill>
+                  <a:srgbClr val="0000FF"/>
+                </a:solidFill>
+                <a:sym typeface="Wingdings" panose="05000000000000000000" pitchFamily="2" charset="2"/>
+              </a:rPr>
+              <a:t>(R2 &lt;&lt; 2)</a:t>
+            </a:r>
+            <a:endParaRPr lang="en-US" b="1" dirty="0">
+              <a:solidFill>
+                <a:srgbClr val="0000FF"/>
+              </a:solidFill>
+            </a:endParaRPr>
+          </a:p>
+          <a:p>
+            <a:r>
+              <a:rPr lang="en-US" dirty="0">
+                <a:solidFill>
+                  <a:schemeClr val="tx1"/>
+                </a:solidFill>
+              </a:rPr>
+              <a:t>Flags: </a:t>
+            </a:r>
+            <a:r>
+              <a:rPr lang="en-US" dirty="0">
+                <a:solidFill>
+                  <a:srgbClr val="0070C0"/>
+                </a:solidFill>
+              </a:rPr>
+              <a:t>Append “S” to capture result characteristics in NCVZ</a:t>
+            </a:r>
+          </a:p>
+          <a:p>
+            <a:endParaRPr lang="en-US" dirty="0"/>
+          </a:p>
+          <a:p>
+            <a:r>
+              <a:rPr lang="en-US" dirty="0">
+                <a:solidFill>
+                  <a:schemeClr val="tx1"/>
+                </a:solidFill>
+              </a:rPr>
+              <a:t>Overflow:</a:t>
+            </a:r>
+          </a:p>
+          <a:p>
+            <a:pPr lvl="1"/>
+            <a:r>
+              <a:rPr lang="en-US" b="1" dirty="0">
+                <a:solidFill>
+                  <a:srgbClr val="92D050"/>
+                </a:solidFill>
+              </a:rPr>
+              <a:t>Unsigned</a:t>
+            </a:r>
+            <a:r>
+              <a:rPr lang="en-US" dirty="0">
+                <a:solidFill>
+                  <a:srgbClr val="0070C0"/>
+                </a:solidFill>
+              </a:rPr>
+              <a:t>: Carry Flag (C) = 1</a:t>
+            </a:r>
+          </a:p>
+          <a:p>
+            <a:pPr lvl="1"/>
+            <a:r>
+              <a:rPr lang="en-US" dirty="0">
+                <a:solidFill>
+                  <a:srgbClr val="0070C0"/>
+                </a:solidFill>
+              </a:rPr>
+              <a:t>     </a:t>
+            </a:r>
+            <a:r>
+              <a:rPr lang="en-US" b="1" dirty="0">
+                <a:solidFill>
+                  <a:srgbClr val="FF0000"/>
+                </a:solidFill>
+              </a:rPr>
+              <a:t>Signed</a:t>
+            </a:r>
+            <a:r>
+              <a:rPr lang="en-US" dirty="0">
+                <a:solidFill>
+                  <a:srgbClr val="0070C0"/>
+                </a:solidFill>
+              </a:rPr>
+              <a:t>: Overflow Flag (V) = 1 (Set when C</a:t>
+            </a:r>
+            <a:r>
+              <a:rPr lang="en-US" baseline="-25000" dirty="0">
+                <a:solidFill>
+                  <a:srgbClr val="0070C0"/>
+                </a:solidFill>
+              </a:rPr>
+              <a:t>N</a:t>
+            </a:r>
+            <a:r>
+              <a:rPr lang="en-US" dirty="0">
+                <a:solidFill>
+                  <a:srgbClr val="0070C0"/>
+                </a:solidFill>
+              </a:rPr>
+              <a:t>≠C</a:t>
+            </a:r>
+            <a:r>
+              <a:rPr lang="en-US" baseline="-25000" dirty="0">
+                <a:solidFill>
+                  <a:srgbClr val="0070C0"/>
+                </a:solidFill>
+              </a:rPr>
+              <a:t>N-1</a:t>
+            </a:r>
+            <a:r>
+              <a:rPr lang="en-US" dirty="0">
+                <a:solidFill>
+                  <a:srgbClr val="0070C0"/>
+                </a:solidFill>
+              </a:rPr>
+              <a:t>)</a:t>
+            </a:r>
+          </a:p>
+          <a:p>
+            <a:endParaRPr lang="en-US" dirty="0"/>
+          </a:p>
+          <a:p>
+            <a:r>
+              <a:rPr lang="en-US" dirty="0">
+                <a:solidFill>
+                  <a:schemeClr val="tx1"/>
+                </a:solidFill>
+              </a:rPr>
+              <a:t>Multiple precision addition: </a:t>
+            </a:r>
+            <a:r>
+              <a:rPr lang="en-US" dirty="0">
+                <a:solidFill>
+                  <a:srgbClr val="0070C0"/>
+                </a:solidFill>
+              </a:rPr>
+              <a:t>ADD</a:t>
+            </a:r>
+            <a:r>
+              <a:rPr lang="en-US" b="1" dirty="0">
+                <a:solidFill>
+                  <a:srgbClr val="FF0000"/>
+                </a:solidFill>
+              </a:rPr>
+              <a:t>S</a:t>
+            </a:r>
+            <a:r>
+              <a:rPr lang="en-US" dirty="0">
+                <a:solidFill>
+                  <a:srgbClr val="0070C0"/>
+                </a:solidFill>
+              </a:rPr>
+              <a:t> </a:t>
+            </a:r>
+            <a:r>
+              <a:rPr lang="en-US" dirty="0">
+                <a:solidFill>
+                  <a:srgbClr val="0070C0"/>
+                </a:solidFill>
+                <a:sym typeface="Wingdings" panose="05000000000000000000" pitchFamily="2" charset="2"/>
+              </a:rPr>
+              <a:t> ADC</a:t>
+            </a:r>
+            <a:endParaRPr lang="en-US" dirty="0">
+              <a:solidFill>
+                <a:srgbClr val="0070C0"/>
+              </a:solidFill>
+            </a:endParaRPr>
+          </a:p>
+          <a:p>
+            <a:endParaRPr lang="en-US" dirty="0"/>
+          </a:p>
+          <a:p>
+            <a:endParaRPr lang="en-US" dirty="0"/>
+          </a:p>
+        </p:txBody>
+      </p:sp>
+    </p:spTree>
+    <p:extLst>
+      <p:ext uri="{BB962C8B-B14F-4D97-AF65-F5344CB8AC3E}">
+        <p14:creationId xmlns:p14="http://schemas.microsoft.com/office/powerpoint/2010/main" val="385189333"/>
       </p:ext>
     </p:extLst>
   </p:cSld>
@@ -42040,8 +42414,8 @@
         </p:nvSpPr>
         <p:spPr>
           <a:xfrm>
-            <a:off x="936516" y="749193"/>
-            <a:ext cx="4112737" cy="654492"/>
+            <a:off x="936516" y="749192"/>
+            <a:ext cx="4606031" cy="662513"/>
           </a:xfrm>
         </p:spPr>
         <p:txBody>
@@ -42050,396 +42424,467 @@
           <a:p>
             <a:r>
               <a:rPr lang="en-US" dirty="0"/>
-              <a:t>Integer Addition</a:t>
+              <a:t>Integer Subtraction</a:t>
             </a:r>
           </a:p>
         </p:txBody>
       </p:sp>
       <p:sp>
         <p:nvSpPr>
-          <p:cNvPr id="5" name="Content Placeholder 4"/>
-          <p:cNvSpPr>
-            <a:spLocks noGrp="1"/>
+          <p:cNvPr id="6" name="Content Placeholder 4"/>
+          <p:cNvSpPr txBox="1">
+            <a:spLocks/>
           </p:cNvSpPr>
-          <p:nvPr>
-            <p:ph idx="1"/>
-          </p:nvPr>
+          <p:nvPr/>
         </p:nvSpPr>
         <p:spPr>
           <a:xfrm>
-            <a:off x="936516" y="1643270"/>
-            <a:ext cx="10433326" cy="4974098"/>
+            <a:off x="936515" y="1708172"/>
+            <a:ext cx="10425305" cy="4953311"/>
           </a:xfrm>
+          <a:prstGeom prst="rect">
+            <a:avLst/>
+          </a:prstGeom>
         </p:spPr>
         <p:txBody>
-          <a:bodyPr>
+          <a:bodyPr vert="horz" lIns="68580" tIns="34290" rIns="68580" bIns="34290" rtlCol="0">
             <a:normAutofit/>
           </a:bodyPr>
-          <a:lstStyle/>
-          <a:p>
-            <a:r>
-              <a:rPr lang="en-US" dirty="0">
+          <a:lstStyle>
+            <a:lvl1pPr marL="228600" indent="-228600" algn="l" defTabSz="914400" rtl="0" eaLnBrk="1" latinLnBrk="0" hangingPunct="1">
+              <a:lnSpc>
+                <a:spcPct val="90000"/>
+              </a:lnSpc>
+              <a:spcBef>
+                <a:spcPts val="1000"/>
+              </a:spcBef>
+              <a:buFont typeface="Arial" panose="020B0604020202020204" pitchFamily="34" charset="0"/>
+              <a:buChar char="•"/>
+              <a:defRPr sz="2800" kern="1200">
                 <a:solidFill>
                   <a:schemeClr val="tx1"/>
                 </a:solidFill>
-              </a:rPr>
+                <a:latin typeface="+mn-lt"/>
+                <a:ea typeface="+mn-ea"/>
+                <a:cs typeface="+mn-cs"/>
+              </a:defRPr>
+            </a:lvl1pPr>
+            <a:lvl2pPr marL="685800" indent="-228600" algn="l" defTabSz="914400" rtl="0" eaLnBrk="1" latinLnBrk="0" hangingPunct="1">
+              <a:lnSpc>
+                <a:spcPct val="90000"/>
+              </a:lnSpc>
+              <a:spcBef>
+                <a:spcPts val="500"/>
+              </a:spcBef>
+              <a:buFont typeface="Arial" panose="020B0604020202020204" pitchFamily="34" charset="0"/>
+              <a:buChar char="•"/>
+              <a:defRPr sz="2400" kern="1200">
+                <a:solidFill>
+                  <a:schemeClr val="tx1"/>
+                </a:solidFill>
+                <a:latin typeface="+mn-lt"/>
+                <a:ea typeface="+mn-ea"/>
+                <a:cs typeface="+mn-cs"/>
+              </a:defRPr>
+            </a:lvl2pPr>
+            <a:lvl3pPr marL="1143000" indent="-228600" algn="l" defTabSz="914400" rtl="0" eaLnBrk="1" latinLnBrk="0" hangingPunct="1">
+              <a:lnSpc>
+                <a:spcPct val="90000"/>
+              </a:lnSpc>
+              <a:spcBef>
+                <a:spcPts val="500"/>
+              </a:spcBef>
+              <a:buFont typeface="Arial" panose="020B0604020202020204" pitchFamily="34" charset="0"/>
+              <a:buChar char="•"/>
+              <a:defRPr sz="2000" kern="1200">
+                <a:solidFill>
+                  <a:schemeClr val="tx1"/>
+                </a:solidFill>
+                <a:latin typeface="+mn-lt"/>
+                <a:ea typeface="+mn-ea"/>
+                <a:cs typeface="+mn-cs"/>
+              </a:defRPr>
+            </a:lvl3pPr>
+            <a:lvl4pPr marL="1600200" indent="-228600" algn="l" defTabSz="914400" rtl="0" eaLnBrk="1" latinLnBrk="0" hangingPunct="1">
+              <a:lnSpc>
+                <a:spcPct val="90000"/>
+              </a:lnSpc>
+              <a:spcBef>
+                <a:spcPts val="500"/>
+              </a:spcBef>
+              <a:buFont typeface="Arial" panose="020B0604020202020204" pitchFamily="34" charset="0"/>
+              <a:buChar char="•"/>
+              <a:defRPr sz="1800" kern="1200">
+                <a:solidFill>
+                  <a:schemeClr val="tx1"/>
+                </a:solidFill>
+                <a:latin typeface="+mn-lt"/>
+                <a:ea typeface="+mn-ea"/>
+                <a:cs typeface="+mn-cs"/>
+              </a:defRPr>
+            </a:lvl4pPr>
+            <a:lvl5pPr marL="2057400" indent="-228600" algn="l" defTabSz="914400" rtl="0" eaLnBrk="1" latinLnBrk="0" hangingPunct="1">
+              <a:lnSpc>
+                <a:spcPct val="90000"/>
+              </a:lnSpc>
+              <a:spcBef>
+                <a:spcPts val="500"/>
+              </a:spcBef>
+              <a:buFont typeface="Arial" panose="020B0604020202020204" pitchFamily="34" charset="0"/>
+              <a:buChar char="•"/>
+              <a:defRPr sz="1800" kern="1200">
+                <a:solidFill>
+                  <a:schemeClr val="tx1"/>
+                </a:solidFill>
+                <a:latin typeface="+mn-lt"/>
+                <a:ea typeface="+mn-ea"/>
+                <a:cs typeface="+mn-cs"/>
+              </a:defRPr>
+            </a:lvl5pPr>
+            <a:lvl6pPr marL="2514600" indent="-228600" algn="l" defTabSz="914400" rtl="0" eaLnBrk="1" latinLnBrk="0" hangingPunct="1">
+              <a:lnSpc>
+                <a:spcPct val="90000"/>
+              </a:lnSpc>
+              <a:spcBef>
+                <a:spcPts val="500"/>
+              </a:spcBef>
+              <a:buFont typeface="Arial" panose="020B0604020202020204" pitchFamily="34" charset="0"/>
+              <a:buChar char="•"/>
+              <a:defRPr sz="1800" kern="1200">
+                <a:solidFill>
+                  <a:schemeClr val="tx1"/>
+                </a:solidFill>
+                <a:latin typeface="+mn-lt"/>
+                <a:ea typeface="+mn-ea"/>
+                <a:cs typeface="+mn-cs"/>
+              </a:defRPr>
+            </a:lvl6pPr>
+            <a:lvl7pPr marL="2971800" indent="-228600" algn="l" defTabSz="914400" rtl="0" eaLnBrk="1" latinLnBrk="0" hangingPunct="1">
+              <a:lnSpc>
+                <a:spcPct val="90000"/>
+              </a:lnSpc>
+              <a:spcBef>
+                <a:spcPts val="500"/>
+              </a:spcBef>
+              <a:buFont typeface="Arial" panose="020B0604020202020204" pitchFamily="34" charset="0"/>
+              <a:buChar char="•"/>
+              <a:defRPr sz="1800" kern="1200">
+                <a:solidFill>
+                  <a:schemeClr val="tx1"/>
+                </a:solidFill>
+                <a:latin typeface="+mn-lt"/>
+                <a:ea typeface="+mn-ea"/>
+                <a:cs typeface="+mn-cs"/>
+              </a:defRPr>
+            </a:lvl7pPr>
+            <a:lvl8pPr marL="3429000" indent="-228600" algn="l" defTabSz="914400" rtl="0" eaLnBrk="1" latinLnBrk="0" hangingPunct="1">
+              <a:lnSpc>
+                <a:spcPct val="90000"/>
+              </a:lnSpc>
+              <a:spcBef>
+                <a:spcPts val="500"/>
+              </a:spcBef>
+              <a:buFont typeface="Arial" panose="020B0604020202020204" pitchFamily="34" charset="0"/>
+              <a:buChar char="•"/>
+              <a:defRPr sz="1800" kern="1200">
+                <a:solidFill>
+                  <a:schemeClr val="tx1"/>
+                </a:solidFill>
+                <a:latin typeface="+mn-lt"/>
+                <a:ea typeface="+mn-ea"/>
+                <a:cs typeface="+mn-cs"/>
+              </a:defRPr>
+            </a:lvl8pPr>
+            <a:lvl9pPr marL="3886200" indent="-228600" algn="l" defTabSz="914400" rtl="0" eaLnBrk="1" latinLnBrk="0" hangingPunct="1">
+              <a:lnSpc>
+                <a:spcPct val="90000"/>
+              </a:lnSpc>
+              <a:spcBef>
+                <a:spcPts val="500"/>
+              </a:spcBef>
+              <a:buFont typeface="Arial" panose="020B0604020202020204" pitchFamily="34" charset="0"/>
+              <a:buChar char="•"/>
+              <a:defRPr sz="1800" kern="1200">
+                <a:solidFill>
+                  <a:schemeClr val="tx1"/>
+                </a:solidFill>
+                <a:latin typeface="+mn-lt"/>
+                <a:ea typeface="+mn-ea"/>
+                <a:cs typeface="+mn-cs"/>
+              </a:defRPr>
+            </a:lvl9pPr>
+          </a:lstStyle>
+          <a:p>
+            <a:r>
+              <a:rPr lang="en-US" sz="2100" dirty="0"/>
               <a:t>Instructions: </a:t>
             </a:r>
             <a:r>
-              <a:rPr lang="en-US" dirty="0">
+              <a:rPr lang="en-US" sz="2100" dirty="0">
                 <a:solidFill>
                   <a:srgbClr val="0070C0"/>
                 </a:solidFill>
               </a:rPr>
-              <a:t>ADD{</a:t>
-            </a:r>
-            <a:r>
-              <a:rPr lang="en-US" b="1" dirty="0">
-                <a:solidFill>
-                  <a:srgbClr val="FF0000"/>
-                </a:solidFill>
-              </a:rPr>
-              <a:t>S</a:t>
-            </a:r>
-            <a:r>
-              <a:rPr lang="en-US" dirty="0">
+              <a:t>SUB{S}, SBC{S}, RSB{S}</a:t>
+            </a:r>
+          </a:p>
+          <a:p>
+            <a:r>
+              <a:rPr lang="en-US" sz="2100" dirty="0"/>
+              <a:t>Format Examples:</a:t>
+            </a:r>
+          </a:p>
+          <a:p>
+            <a:pPr lvl="1"/>
+            <a:r>
+              <a:rPr lang="en-US" sz="1800" dirty="0"/>
+              <a:t>SUB	R0,R1,</a:t>
+            </a:r>
+            <a:r>
+              <a:rPr lang="en-US" sz="1800" b="1" dirty="0">
+                <a:solidFill>
+                  <a:srgbClr val="0000FF"/>
+                </a:solidFill>
+              </a:rPr>
+              <a:t>#5</a:t>
+            </a:r>
+            <a:r>
+              <a:rPr lang="en-US" sz="1800" dirty="0"/>
+              <a:t>		// R0 </a:t>
+            </a:r>
+            <a:r>
+              <a:rPr lang="en-US" sz="1800" dirty="0">
+                <a:sym typeface="Wingdings" panose="05000000000000000000" pitchFamily="2" charset="2"/>
+              </a:rPr>
+              <a:t>= R1 - 5</a:t>
+            </a:r>
+            <a:endParaRPr lang="en-US" sz="1800" dirty="0"/>
+          </a:p>
+          <a:p>
+            <a:pPr lvl="1"/>
+            <a:r>
+              <a:rPr lang="en-US" sz="1800" dirty="0"/>
+              <a:t>SUB	R0,R1,R2		// R0 </a:t>
+            </a:r>
+            <a:r>
+              <a:rPr lang="en-US" sz="1800" dirty="0">
+                <a:sym typeface="Wingdings" panose="05000000000000000000" pitchFamily="2" charset="2"/>
+              </a:rPr>
+              <a:t>= R1 - R2</a:t>
+            </a:r>
+            <a:endParaRPr lang="en-US" sz="1800" dirty="0"/>
+          </a:p>
+          <a:p>
+            <a:pPr lvl="1"/>
+            <a:r>
+              <a:rPr lang="en-US" sz="1800" dirty="0"/>
+              <a:t>SUB	R0,R1,</a:t>
+            </a:r>
+            <a:r>
+              <a:rPr lang="en-US" sz="1800" b="1" dirty="0">
+                <a:solidFill>
+                  <a:srgbClr val="0000FF"/>
+                </a:solidFill>
+              </a:rPr>
+              <a:t>R2,LSL #2</a:t>
+            </a:r>
+            <a:r>
+              <a:rPr lang="en-US" sz="1800" dirty="0"/>
+              <a:t>		// R0 </a:t>
+            </a:r>
+            <a:r>
+              <a:rPr lang="en-US" sz="1800" dirty="0">
+                <a:sym typeface="Wingdings" panose="05000000000000000000" pitchFamily="2" charset="2"/>
+              </a:rPr>
+              <a:t>= R1 - </a:t>
+            </a:r>
+            <a:r>
+              <a:rPr lang="en-US" sz="1800" b="1" dirty="0">
+                <a:solidFill>
+                  <a:srgbClr val="0000FF"/>
+                </a:solidFill>
+                <a:sym typeface="Wingdings" panose="05000000000000000000" pitchFamily="2" charset="2"/>
+              </a:rPr>
+              <a:t>(R2 &lt;&lt; 2)</a:t>
+            </a:r>
+            <a:r>
+              <a:rPr lang="en-US" sz="1800" dirty="0">
                 <a:solidFill>
                   <a:srgbClr val="0070C0"/>
                 </a:solidFill>
-              </a:rPr>
-              <a:t>}</a:t>
-            </a:r>
-            <a:r>
-              <a:rPr lang="en-US" dirty="0">
-                <a:solidFill>
-                  <a:schemeClr val="tx1"/>
-                </a:solidFill>
-              </a:rPr>
-              <a:t>,</a:t>
-            </a:r>
-            <a:r>
-              <a:rPr lang="en-US" dirty="0">
-                <a:solidFill>
-                  <a:srgbClr val="0070C0"/>
-                </a:solidFill>
-              </a:rPr>
-              <a:t> ADC{</a:t>
-            </a:r>
-            <a:r>
-              <a:rPr lang="en-US" b="1" dirty="0">
-                <a:solidFill>
-                  <a:srgbClr val="FF0000"/>
-                </a:solidFill>
-              </a:rPr>
-              <a:t>S</a:t>
-            </a:r>
-            <a:r>
-              <a:rPr lang="en-US" dirty="0">
-                <a:solidFill>
-                  <a:srgbClr val="0070C0"/>
-                </a:solidFill>
-              </a:rPr>
-              <a:t>}</a:t>
-            </a:r>
-          </a:p>
-          <a:p>
-            <a:r>
-              <a:rPr lang="en-US" dirty="0">
-                <a:solidFill>
-                  <a:schemeClr val="tx1"/>
-                </a:solidFill>
-              </a:rPr>
-              <a:t>Format Examples:</a:t>
-            </a:r>
-          </a:p>
-          <a:p>
-            <a:pPr lvl="1"/>
-            <a:r>
-              <a:rPr lang="en-US" dirty="0">
-                <a:solidFill>
-                  <a:schemeClr val="tx1"/>
-                </a:solidFill>
-              </a:rPr>
-              <a:t>ADD	R0,R1,</a:t>
-            </a:r>
-            <a:r>
-              <a:rPr lang="en-US" b="1" dirty="0">
-                <a:solidFill>
-                  <a:srgbClr val="0000FF"/>
-                </a:solidFill>
-              </a:rPr>
-              <a:t>#5</a:t>
-            </a:r>
-            <a:r>
-              <a:rPr lang="en-US" dirty="0">
-                <a:solidFill>
-                  <a:schemeClr val="tx1"/>
-                </a:solidFill>
-              </a:rPr>
-              <a:t>			// R0 </a:t>
-            </a:r>
-            <a:r>
-              <a:rPr lang="en-US" dirty="0">
-                <a:solidFill>
-                  <a:schemeClr val="tx1"/>
-                </a:solidFill>
                 <a:sym typeface="Wingdings" panose="05000000000000000000" pitchFamily="2" charset="2"/>
               </a:rPr>
-              <a:t>= R1 + 5</a:t>
-            </a:r>
-            <a:endParaRPr lang="en-US" dirty="0">
-              <a:solidFill>
-                <a:schemeClr val="tx1"/>
-              </a:solidFill>
-            </a:endParaRPr>
-          </a:p>
-          <a:p>
-            <a:pPr lvl="1"/>
-            <a:r>
-              <a:rPr lang="en-US" dirty="0">
-                <a:solidFill>
-                  <a:schemeClr val="tx1"/>
-                </a:solidFill>
-              </a:rPr>
-              <a:t>ADD	R0,R1,R2		// R0 </a:t>
-            </a:r>
-            <a:r>
-              <a:rPr lang="en-US" dirty="0">
-                <a:solidFill>
-                  <a:schemeClr val="tx1"/>
-                </a:solidFill>
-                <a:sym typeface="Wingdings" panose="05000000000000000000" pitchFamily="2" charset="2"/>
-              </a:rPr>
-              <a:t>= R1 + R2</a:t>
-            </a:r>
-            <a:endParaRPr lang="en-US" dirty="0">
-              <a:solidFill>
-                <a:schemeClr val="tx1"/>
-              </a:solidFill>
-            </a:endParaRPr>
-          </a:p>
-          <a:p>
-            <a:pPr lvl="1"/>
-            <a:r>
-              <a:rPr lang="en-US" dirty="0">
-                <a:solidFill>
-                  <a:schemeClr val="tx1"/>
-                </a:solidFill>
-              </a:rPr>
-              <a:t>ADD	R0,R1,</a:t>
-            </a:r>
-            <a:r>
-              <a:rPr lang="en-US" b="1" dirty="0">
-                <a:solidFill>
-                  <a:srgbClr val="0000FF"/>
-                </a:solidFill>
-              </a:rPr>
-              <a:t>R2,LSL #2</a:t>
-            </a:r>
-            <a:r>
-              <a:rPr lang="en-US" dirty="0">
-                <a:solidFill>
-                  <a:schemeClr val="tx1"/>
-                </a:solidFill>
-              </a:rPr>
-              <a:t>		// R0 </a:t>
-            </a:r>
-            <a:r>
-              <a:rPr lang="en-US" dirty="0">
-                <a:solidFill>
-                  <a:schemeClr val="tx1"/>
-                </a:solidFill>
-                <a:sym typeface="Wingdings" panose="05000000000000000000" pitchFamily="2" charset="2"/>
-              </a:rPr>
-              <a:t>= R1 + </a:t>
-            </a:r>
-            <a:r>
-              <a:rPr lang="en-US" b="1" dirty="0">
-                <a:solidFill>
-                  <a:srgbClr val="0000FF"/>
-                </a:solidFill>
-                <a:sym typeface="Wingdings" panose="05000000000000000000" pitchFamily="2" charset="2"/>
-              </a:rPr>
-              <a:t>(R2 &lt;&lt; 2)</a:t>
-            </a:r>
-            <a:endParaRPr lang="en-US" b="1" dirty="0">
-              <a:solidFill>
-                <a:srgbClr val="0000FF"/>
-              </a:solidFill>
-            </a:endParaRPr>
-          </a:p>
-          <a:p>
-            <a:r>
-              <a:rPr lang="en-US" dirty="0">
-                <a:solidFill>
-                  <a:schemeClr val="tx1"/>
-                </a:solidFill>
-              </a:rPr>
-              <a:t>Flags: </a:t>
-            </a:r>
-            <a:r>
-              <a:rPr lang="en-US" dirty="0">
-                <a:solidFill>
-                  <a:srgbClr val="0070C0"/>
-                </a:solidFill>
-              </a:rPr>
-              <a:t>Append “S” to capture result characteristics in NCVZ</a:t>
-            </a:r>
-          </a:p>
-          <a:p>
-            <a:endParaRPr lang="en-US" dirty="0"/>
-          </a:p>
-          <a:p>
-            <a:r>
-              <a:rPr lang="en-US" dirty="0">
-                <a:solidFill>
-                  <a:schemeClr val="tx1"/>
-                </a:solidFill>
-              </a:rPr>
-              <a:t>Overflow:</a:t>
-            </a:r>
-          </a:p>
-          <a:p>
-            <a:pPr lvl="1"/>
-            <a:r>
-              <a:rPr lang="en-US" b="1" dirty="0">
-                <a:solidFill>
-                  <a:srgbClr val="92D050"/>
-                </a:solidFill>
-              </a:rPr>
-              <a:t>Unsigned</a:t>
-            </a:r>
-            <a:r>
-              <a:rPr lang="en-US" dirty="0">
-                <a:solidFill>
-                  <a:srgbClr val="0070C0"/>
-                </a:solidFill>
-              </a:rPr>
-              <a:t>: Carry Flag (C) = 1</a:t>
-            </a:r>
-          </a:p>
-          <a:p>
-            <a:pPr lvl="1"/>
-            <a:r>
-              <a:rPr lang="en-US" dirty="0">
-                <a:solidFill>
-                  <a:srgbClr val="0070C0"/>
-                </a:solidFill>
-              </a:rPr>
-              <a:t>     </a:t>
-            </a:r>
-            <a:r>
-              <a:rPr lang="en-US" b="1" dirty="0">
-                <a:solidFill>
-                  <a:srgbClr val="FF0000"/>
-                </a:solidFill>
-              </a:rPr>
-              <a:t>Signed</a:t>
-            </a:r>
-            <a:r>
-              <a:rPr lang="en-US" dirty="0">
-                <a:solidFill>
-                  <a:srgbClr val="0070C0"/>
-                </a:solidFill>
-              </a:rPr>
-              <a:t>: Overflow Flag (V) = 1 (Set when C</a:t>
-            </a:r>
-            <a:r>
-              <a:rPr lang="en-US" baseline="-25000" dirty="0">
-                <a:solidFill>
-                  <a:srgbClr val="0070C0"/>
-                </a:solidFill>
-              </a:rPr>
-              <a:t>N</a:t>
-            </a:r>
-            <a:r>
-              <a:rPr lang="en-US" dirty="0">
-                <a:solidFill>
-                  <a:srgbClr val="0070C0"/>
-                </a:solidFill>
-              </a:rPr>
-              <a:t>≠C</a:t>
-            </a:r>
-            <a:r>
-              <a:rPr lang="en-US" baseline="-25000" dirty="0">
-                <a:solidFill>
-                  <a:srgbClr val="0070C0"/>
-                </a:solidFill>
-              </a:rPr>
-              <a:t>N-1</a:t>
-            </a:r>
-            <a:r>
-              <a:rPr lang="en-US" dirty="0">
-                <a:solidFill>
-                  <a:srgbClr val="0070C0"/>
-                </a:solidFill>
-              </a:rPr>
-              <a:t>)</a:t>
-            </a:r>
-          </a:p>
-          <a:p>
-            <a:endParaRPr lang="en-US" dirty="0"/>
-          </a:p>
-          <a:p>
-            <a:r>
-              <a:rPr lang="en-US" dirty="0">
-                <a:solidFill>
-                  <a:schemeClr val="tx1"/>
-                </a:solidFill>
-              </a:rPr>
-              <a:t>Multiple precision addition: </a:t>
-            </a:r>
-            <a:r>
-              <a:rPr lang="en-US" dirty="0">
-                <a:solidFill>
-                  <a:srgbClr val="0070C0"/>
-                </a:solidFill>
-              </a:rPr>
-              <a:t>ADD</a:t>
-            </a:r>
-            <a:r>
-              <a:rPr lang="en-US" b="1" dirty="0">
-                <a:solidFill>
-                  <a:srgbClr val="FF0000"/>
-                </a:solidFill>
-              </a:rPr>
-              <a:t>S</a:t>
-            </a:r>
-            <a:r>
-              <a:rPr lang="en-US" dirty="0">
-                <a:solidFill>
-                  <a:srgbClr val="0070C0"/>
-                </a:solidFill>
-              </a:rPr>
-              <a:t> </a:t>
-            </a:r>
-            <a:r>
-              <a:rPr lang="en-US" dirty="0">
-                <a:solidFill>
-                  <a:srgbClr val="0070C0"/>
-                </a:solidFill>
-                <a:sym typeface="Wingdings" panose="05000000000000000000" pitchFamily="2" charset="2"/>
-              </a:rPr>
-              <a:t> ADC</a:t>
-            </a:r>
-            <a:endParaRPr lang="en-US" dirty="0">
+              <a:t>	</a:t>
+            </a:r>
+            <a:endParaRPr lang="en-US" sz="1800" dirty="0">
               <a:solidFill>
                 <a:srgbClr val="0070C0"/>
               </a:solidFill>
             </a:endParaRPr>
           </a:p>
           <a:p>
-            <a:endParaRPr lang="en-US" dirty="0"/>
-          </a:p>
-          <a:p>
-            <a:endParaRPr lang="en-US" dirty="0"/>
+            <a:endParaRPr lang="en-US" sz="2100" dirty="0"/>
+          </a:p>
+          <a:p>
+            <a:r>
+              <a:rPr lang="en-US" sz="2100" dirty="0"/>
+              <a:t>Flags: </a:t>
+            </a:r>
+            <a:r>
+              <a:rPr lang="en-US" sz="2100" dirty="0">
+                <a:solidFill>
+                  <a:srgbClr val="0070C0"/>
+                </a:solidFill>
+              </a:rPr>
+              <a:t>Append “S” to capture result characteristics in NCVZ</a:t>
+            </a:r>
+          </a:p>
+          <a:p>
+            <a:endParaRPr lang="en-US" sz="2100" dirty="0"/>
+          </a:p>
+          <a:p>
+            <a:r>
+              <a:rPr lang="en-US" sz="2100" dirty="0"/>
+              <a:t>Overflow:</a:t>
+            </a:r>
+          </a:p>
+          <a:p>
+            <a:pPr lvl="1"/>
+            <a:r>
+              <a:rPr lang="en-US" sz="1800" b="1" dirty="0">
+                <a:solidFill>
+                  <a:srgbClr val="92D050"/>
+                </a:solidFill>
+              </a:rPr>
+              <a:t>Unsigned</a:t>
+            </a:r>
+            <a:r>
+              <a:rPr lang="en-US" sz="1800" dirty="0">
+                <a:solidFill>
+                  <a:srgbClr val="0070C0"/>
+                </a:solidFill>
+              </a:rPr>
+              <a:t>: Carry Flag       (C) = 0</a:t>
+            </a:r>
+          </a:p>
+          <a:p>
+            <a:pPr lvl="1"/>
+            <a:r>
+              <a:rPr lang="en-US" sz="1800" dirty="0">
+                <a:solidFill>
+                  <a:srgbClr val="0070C0"/>
+                </a:solidFill>
+              </a:rPr>
+              <a:t>     </a:t>
+            </a:r>
+            <a:r>
+              <a:rPr lang="en-US" sz="1800" b="1" dirty="0">
+                <a:solidFill>
+                  <a:srgbClr val="FF0000"/>
+                </a:solidFill>
+              </a:rPr>
+              <a:t>Signed</a:t>
+            </a:r>
+            <a:r>
+              <a:rPr lang="en-US" sz="1800" dirty="0">
+                <a:solidFill>
+                  <a:srgbClr val="0070C0"/>
+                </a:solidFill>
+              </a:rPr>
+              <a:t>: Overflow Flag (V) = 1 (Set when C</a:t>
+            </a:r>
+            <a:r>
+              <a:rPr lang="en-US" sz="1800" baseline="-25000" dirty="0">
+                <a:solidFill>
+                  <a:srgbClr val="0070C0"/>
+                </a:solidFill>
+              </a:rPr>
+              <a:t>N</a:t>
+            </a:r>
+            <a:r>
+              <a:rPr lang="en-US" sz="1800" dirty="0">
+                <a:solidFill>
+                  <a:srgbClr val="0070C0"/>
+                </a:solidFill>
+              </a:rPr>
+              <a:t>≠C</a:t>
+            </a:r>
+            <a:r>
+              <a:rPr lang="en-US" sz="1800" baseline="-25000" dirty="0">
+                <a:solidFill>
+                  <a:srgbClr val="0070C0"/>
+                </a:solidFill>
+              </a:rPr>
+              <a:t>N-1</a:t>
+            </a:r>
+            <a:r>
+              <a:rPr lang="en-US" sz="1800" dirty="0">
+                <a:solidFill>
+                  <a:srgbClr val="0070C0"/>
+                </a:solidFill>
+              </a:rPr>
+              <a:t>)</a:t>
+            </a:r>
+          </a:p>
+          <a:p>
+            <a:endParaRPr lang="en-US" sz="2100" dirty="0"/>
+          </a:p>
+          <a:p>
+            <a:r>
+              <a:rPr lang="en-US" sz="2100" dirty="0"/>
+              <a:t>Multiple precision subtraction: </a:t>
+            </a:r>
+            <a:r>
+              <a:rPr lang="en-US" sz="2100" dirty="0">
+                <a:solidFill>
+                  <a:srgbClr val="0070C0"/>
+                </a:solidFill>
+              </a:rPr>
+              <a:t>SUB</a:t>
+            </a:r>
+            <a:r>
+              <a:rPr lang="en-US" sz="2100" b="1" dirty="0">
+                <a:solidFill>
+                  <a:srgbClr val="FF0000"/>
+                </a:solidFill>
+              </a:rPr>
+              <a:t>S</a:t>
+            </a:r>
+            <a:r>
+              <a:rPr lang="en-US" sz="2100" dirty="0">
+                <a:solidFill>
+                  <a:srgbClr val="0070C0"/>
+                </a:solidFill>
+              </a:rPr>
+              <a:t> </a:t>
+            </a:r>
+            <a:r>
+              <a:rPr lang="en-US" sz="2100" dirty="0">
+                <a:solidFill>
+                  <a:srgbClr val="0070C0"/>
+                </a:solidFill>
+                <a:sym typeface="Wingdings" panose="05000000000000000000" pitchFamily="2" charset="2"/>
+              </a:rPr>
+              <a:t> SBC</a:t>
+            </a:r>
+            <a:endParaRPr lang="en-US" sz="2100" dirty="0">
+              <a:solidFill>
+                <a:srgbClr val="0070C0"/>
+              </a:solidFill>
+            </a:endParaRPr>
+          </a:p>
+          <a:p>
+            <a:endParaRPr lang="en-US" sz="2100" dirty="0"/>
+          </a:p>
+          <a:p>
+            <a:endParaRPr lang="en-US" sz="2100" dirty="0"/>
           </a:p>
         </p:txBody>
       </p:sp>
     </p:spTree>
     <p:extLst>
       <p:ext uri="{BB962C8B-B14F-4D97-AF65-F5344CB8AC3E}">
-        <p14:creationId xmlns:p14="http://schemas.microsoft.com/office/powerpoint/2010/main" val="385189333"/>
+        <p14:creationId xmlns:p14="http://schemas.microsoft.com/office/powerpoint/2010/main" val="2046813644"/>
       </p:ext>
     </p:extLst>
   </p:cSld>
@@ -42478,477 +42923,355 @@
         </p:nvSpPr>
         <p:spPr>
           <a:xfrm>
-            <a:off x="936516" y="749192"/>
-            <a:ext cx="4606031" cy="662513"/>
+            <a:off x="936516" y="745181"/>
+            <a:ext cx="9466789" cy="686577"/>
           </a:xfrm>
         </p:spPr>
         <p:txBody>
-          <a:bodyPr/>
+          <a:bodyPr>
+            <a:normAutofit/>
+          </a:bodyPr>
           <a:lstStyle/>
           <a:p>
             <a:r>
               <a:rPr lang="en-US" dirty="0"/>
-              <a:t>Integer Subtraction</a:t>
+              <a:t>Single-Length 32x32 Integer Multiplication</a:t>
             </a:r>
           </a:p>
         </p:txBody>
       </p:sp>
       <p:sp>
         <p:nvSpPr>
-          <p:cNvPr id="6" name="Content Placeholder 4"/>
-          <p:cNvSpPr txBox="1">
-            <a:spLocks/>
+          <p:cNvPr id="3" name="Content Placeholder 2"/>
+          <p:cNvSpPr>
+            <a:spLocks noGrp="1"/>
           </p:cNvSpPr>
-          <p:nvPr/>
+          <p:nvPr>
+            <p:ph idx="1"/>
+          </p:nvPr>
         </p:nvSpPr>
         <p:spPr>
           <a:xfrm>
-            <a:off x="936515" y="1708172"/>
-            <a:ext cx="10425305" cy="4953311"/>
+            <a:off x="936515" y="1807701"/>
+            <a:ext cx="10441347" cy="4841752"/>
           </a:xfrm>
-          <a:prstGeom prst="rect">
-            <a:avLst/>
-          </a:prstGeom>
         </p:spPr>
         <p:txBody>
-          <a:bodyPr vert="horz" lIns="68580" tIns="34290" rIns="68580" bIns="34290" rtlCol="0">
-            <a:normAutofit/>
+          <a:bodyPr>
+            <a:normAutofit lnSpcReduction="10000"/>
           </a:bodyPr>
-          <a:lstStyle>
-            <a:lvl1pPr marL="228600" indent="-228600" algn="l" defTabSz="914400" rtl="0" eaLnBrk="1" latinLnBrk="0" hangingPunct="1">
-              <a:lnSpc>
-                <a:spcPct val="90000"/>
-              </a:lnSpc>
-              <a:spcBef>
-                <a:spcPts val="1000"/>
-              </a:spcBef>
-              <a:buFont typeface="Arial" panose="020B0604020202020204" pitchFamily="34" charset="0"/>
-              <a:buChar char="•"/>
-              <a:defRPr sz="2800" kern="1200">
+          <a:lstStyle/>
+          <a:p>
+            <a:r>
+              <a:rPr lang="en-US" dirty="0">
                 <a:solidFill>
                   <a:schemeClr val="tx1"/>
                 </a:solidFill>
-                <a:latin typeface="+mn-lt"/>
-                <a:ea typeface="+mn-ea"/>
-                <a:cs typeface="+mn-cs"/>
-              </a:defRPr>
-            </a:lvl1pPr>
-            <a:lvl2pPr marL="685800" indent="-228600" algn="l" defTabSz="914400" rtl="0" eaLnBrk="1" latinLnBrk="0" hangingPunct="1">
-              <a:lnSpc>
-                <a:spcPct val="90000"/>
-              </a:lnSpc>
-              <a:spcBef>
-                <a:spcPts val="500"/>
-              </a:spcBef>
-              <a:buFont typeface="Arial" panose="020B0604020202020204" pitchFamily="34" charset="0"/>
-              <a:buChar char="•"/>
-              <a:defRPr sz="2400" kern="1200">
+              </a:rPr>
+              <a:t>Instructions:</a:t>
+            </a:r>
+            <a:r>
+              <a:rPr lang="en-US" dirty="0"/>
+              <a:t> </a:t>
+            </a:r>
+            <a:r>
+              <a:rPr lang="en-US" dirty="0">
+                <a:solidFill>
+                  <a:srgbClr val="0070C0"/>
+                </a:solidFill>
+              </a:rPr>
+              <a:t>MUL{</a:t>
+            </a:r>
+            <a:r>
+              <a:rPr lang="en-US" b="1" dirty="0">
+                <a:solidFill>
+                  <a:srgbClr val="FF0000"/>
+                </a:solidFill>
+              </a:rPr>
+              <a:t>S</a:t>
+            </a:r>
+            <a:r>
+              <a:rPr lang="en-US" dirty="0">
+                <a:solidFill>
+                  <a:srgbClr val="0070C0"/>
+                </a:solidFill>
+              </a:rPr>
+              <a:t>}, MLA, MLS</a:t>
+            </a:r>
+          </a:p>
+          <a:p>
+            <a:endParaRPr lang="en-US" dirty="0"/>
+          </a:p>
+          <a:p>
+            <a:r>
+              <a:rPr lang="en-US" b="1" dirty="0">
+                <a:solidFill>
+                  <a:srgbClr val="FF0000"/>
+                </a:solidFill>
+              </a:rPr>
+              <a:t>Signed</a:t>
+            </a:r>
+            <a:r>
+              <a:rPr lang="en-US" dirty="0"/>
+              <a:t> </a:t>
+            </a:r>
+            <a:r>
+              <a:rPr lang="en-US" dirty="0">
                 <a:solidFill>
                   <a:schemeClr val="tx1"/>
                 </a:solidFill>
-                <a:latin typeface="+mn-lt"/>
-                <a:ea typeface="+mn-ea"/>
-                <a:cs typeface="+mn-cs"/>
-              </a:defRPr>
-            </a:lvl2pPr>
-            <a:lvl3pPr marL="1143000" indent="-228600" algn="l" defTabSz="914400" rtl="0" eaLnBrk="1" latinLnBrk="0" hangingPunct="1">
-              <a:lnSpc>
-                <a:spcPct val="90000"/>
-              </a:lnSpc>
-              <a:spcBef>
-                <a:spcPts val="500"/>
-              </a:spcBef>
-              <a:buFont typeface="Arial" panose="020B0604020202020204" pitchFamily="34" charset="0"/>
-              <a:buChar char="•"/>
-              <a:defRPr sz="2000" kern="1200">
+              </a:rPr>
+              <a:t>vs.</a:t>
+            </a:r>
+            <a:r>
+              <a:rPr lang="en-US" dirty="0"/>
+              <a:t> </a:t>
+            </a:r>
+            <a:r>
+              <a:rPr lang="en-US" b="1" dirty="0">
+                <a:solidFill>
+                  <a:srgbClr val="92D050"/>
+                </a:solidFill>
+              </a:rPr>
+              <a:t>Unsigned</a:t>
+            </a:r>
+            <a:r>
+              <a:rPr lang="en-US" dirty="0">
                 <a:solidFill>
                   <a:schemeClr val="tx1"/>
                 </a:solidFill>
-                <a:latin typeface="+mn-lt"/>
-                <a:ea typeface="+mn-ea"/>
-                <a:cs typeface="+mn-cs"/>
-              </a:defRPr>
-            </a:lvl3pPr>
-            <a:lvl4pPr marL="1600200" indent="-228600" algn="l" defTabSz="914400" rtl="0" eaLnBrk="1" latinLnBrk="0" hangingPunct="1">
-              <a:lnSpc>
-                <a:spcPct val="90000"/>
-              </a:lnSpc>
-              <a:spcBef>
-                <a:spcPts val="500"/>
-              </a:spcBef>
-              <a:buFont typeface="Arial" panose="020B0604020202020204" pitchFamily="34" charset="0"/>
-              <a:buChar char="•"/>
-              <a:defRPr sz="1800" kern="1200">
+              </a:rPr>
+              <a:t>:</a:t>
+            </a:r>
+            <a:r>
+              <a:rPr lang="en-US" dirty="0"/>
+              <a:t> </a:t>
+            </a:r>
+            <a:r>
+              <a:rPr lang="en-US" dirty="0">
+                <a:solidFill>
+                  <a:srgbClr val="0070C0"/>
+                </a:solidFill>
+              </a:rPr>
+              <a:t>Use </a:t>
+            </a:r>
+            <a:r>
+              <a:rPr lang="en-US" b="1" dirty="0">
+                <a:solidFill>
+                  <a:srgbClr val="0070C0"/>
+                </a:solidFill>
+              </a:rPr>
+              <a:t>same</a:t>
+            </a:r>
+            <a:r>
+              <a:rPr lang="en-US" dirty="0">
+                <a:solidFill>
+                  <a:srgbClr val="0070C0"/>
+                </a:solidFill>
+              </a:rPr>
+              <a:t> instruction</a:t>
+            </a:r>
+          </a:p>
+          <a:p>
+            <a:endParaRPr lang="en-US" dirty="0"/>
+          </a:p>
+          <a:p>
+            <a:r>
+              <a:rPr lang="en-US" dirty="0">
                 <a:solidFill>
                   <a:schemeClr val="tx1"/>
                 </a:solidFill>
-                <a:latin typeface="+mn-lt"/>
-                <a:ea typeface="+mn-ea"/>
-                <a:cs typeface="+mn-cs"/>
-              </a:defRPr>
-            </a:lvl4pPr>
-            <a:lvl5pPr marL="2057400" indent="-228600" algn="l" defTabSz="914400" rtl="0" eaLnBrk="1" latinLnBrk="0" hangingPunct="1">
-              <a:lnSpc>
-                <a:spcPct val="90000"/>
-              </a:lnSpc>
-              <a:spcBef>
-                <a:spcPts val="500"/>
-              </a:spcBef>
-              <a:buFont typeface="Arial" panose="020B0604020202020204" pitchFamily="34" charset="0"/>
-              <a:buChar char="•"/>
-              <a:defRPr sz="1800" kern="1200">
+              </a:rPr>
+              <a:t>Format Examples:</a:t>
+            </a:r>
+          </a:p>
+          <a:p>
+            <a:pPr lvl="1"/>
+            <a:r>
+              <a:rPr lang="en-US" dirty="0">
                 <a:solidFill>
                   <a:schemeClr val="tx1"/>
                 </a:solidFill>
-                <a:latin typeface="+mn-lt"/>
-                <a:ea typeface="+mn-ea"/>
-                <a:cs typeface="+mn-cs"/>
-              </a:defRPr>
-            </a:lvl5pPr>
-            <a:lvl6pPr marL="2514600" indent="-228600" algn="l" defTabSz="914400" rtl="0" eaLnBrk="1" latinLnBrk="0" hangingPunct="1">
-              <a:lnSpc>
-                <a:spcPct val="90000"/>
-              </a:lnSpc>
-              <a:spcBef>
-                <a:spcPts val="500"/>
-              </a:spcBef>
-              <a:buFont typeface="Arial" panose="020B0604020202020204" pitchFamily="34" charset="0"/>
-              <a:buChar char="•"/>
-              <a:defRPr sz="1800" kern="1200">
+              </a:rPr>
+              <a:t>MUL	R0,</a:t>
+            </a:r>
+            <a:r>
+              <a:rPr lang="en-US" b="1" dirty="0">
+                <a:solidFill>
+                  <a:srgbClr val="0000FF"/>
+                </a:solidFill>
+              </a:rPr>
+              <a:t>R1,R2</a:t>
+            </a:r>
+            <a:r>
+              <a:rPr lang="en-US" dirty="0">
                 <a:solidFill>
                   <a:schemeClr val="tx1"/>
                 </a:solidFill>
-                <a:latin typeface="+mn-lt"/>
-                <a:ea typeface="+mn-ea"/>
-                <a:cs typeface="+mn-cs"/>
-              </a:defRPr>
-            </a:lvl6pPr>
-            <a:lvl7pPr marL="2971800" indent="-228600" algn="l" defTabSz="914400" rtl="0" eaLnBrk="1" latinLnBrk="0" hangingPunct="1">
-              <a:lnSpc>
-                <a:spcPct val="90000"/>
-              </a:lnSpc>
-              <a:spcBef>
-                <a:spcPts val="500"/>
-              </a:spcBef>
-              <a:buFont typeface="Arial" panose="020B0604020202020204" pitchFamily="34" charset="0"/>
-              <a:buChar char="•"/>
-              <a:defRPr sz="1800" kern="1200">
+              </a:rPr>
+              <a:t>		// R0 </a:t>
+            </a:r>
+            <a:r>
+              <a:rPr lang="en-US" dirty="0">
                 <a:solidFill>
                   <a:schemeClr val="tx1"/>
                 </a:solidFill>
-                <a:latin typeface="+mn-lt"/>
-                <a:ea typeface="+mn-ea"/>
-                <a:cs typeface="+mn-cs"/>
-              </a:defRPr>
-            </a:lvl7pPr>
-            <a:lvl8pPr marL="3429000" indent="-228600" algn="l" defTabSz="914400" rtl="0" eaLnBrk="1" latinLnBrk="0" hangingPunct="1">
-              <a:lnSpc>
-                <a:spcPct val="90000"/>
-              </a:lnSpc>
-              <a:spcBef>
-                <a:spcPts val="500"/>
-              </a:spcBef>
-              <a:buFont typeface="Arial" panose="020B0604020202020204" pitchFamily="34" charset="0"/>
-              <a:buChar char="•"/>
-              <a:defRPr sz="1800" kern="1200">
+                <a:sym typeface="Wingdings" panose="05000000000000000000" pitchFamily="2" charset="2"/>
+              </a:rPr>
+              <a:t>= </a:t>
+            </a:r>
+            <a:r>
+              <a:rPr lang="en-US" b="1" dirty="0">
+                <a:solidFill>
+                  <a:srgbClr val="0000FF"/>
+                </a:solidFill>
+                <a:sym typeface="Wingdings" panose="05000000000000000000" pitchFamily="2" charset="2"/>
+              </a:rPr>
+              <a:t>R1 × R2</a:t>
+            </a:r>
+          </a:p>
+          <a:p>
+            <a:pPr lvl="1"/>
+            <a:r>
+              <a:rPr lang="en-US" dirty="0">
                 <a:solidFill>
                   <a:schemeClr val="tx1"/>
                 </a:solidFill>
-                <a:latin typeface="+mn-lt"/>
-                <a:ea typeface="+mn-ea"/>
-                <a:cs typeface="+mn-cs"/>
-              </a:defRPr>
-            </a:lvl8pPr>
-            <a:lvl9pPr marL="3886200" indent="-228600" algn="l" defTabSz="914400" rtl="0" eaLnBrk="1" latinLnBrk="0" hangingPunct="1">
-              <a:lnSpc>
-                <a:spcPct val="90000"/>
-              </a:lnSpc>
-              <a:spcBef>
-                <a:spcPts val="500"/>
-              </a:spcBef>
-              <a:buFont typeface="Arial" panose="020B0604020202020204" pitchFamily="34" charset="0"/>
-              <a:buChar char="•"/>
-              <a:defRPr sz="1800" kern="1200">
+              </a:rPr>
+              <a:t>MLA	R0,</a:t>
+            </a:r>
+            <a:r>
+              <a:rPr lang="en-US" b="1" dirty="0">
+                <a:solidFill>
+                  <a:srgbClr val="0000FF"/>
+                </a:solidFill>
+              </a:rPr>
+              <a:t>R1,R2</a:t>
+            </a:r>
+            <a:r>
+              <a:rPr lang="en-US" dirty="0">
                 <a:solidFill>
                   <a:schemeClr val="tx1"/>
                 </a:solidFill>
-                <a:latin typeface="+mn-lt"/>
-                <a:ea typeface="+mn-ea"/>
-                <a:cs typeface="+mn-cs"/>
-              </a:defRPr>
-            </a:lvl9pPr>
-          </a:lstStyle>
-          <a:p>
-            <a:r>
-              <a:rPr lang="en-US" sz="2100" dirty="0"/>
-              <a:t>Instructions: </a:t>
-            </a:r>
-            <a:r>
-              <a:rPr lang="en-US" sz="2100" dirty="0">
+              </a:rPr>
+              <a:t>,R3		// R0 </a:t>
+            </a:r>
+            <a:r>
+              <a:rPr lang="en-US" dirty="0">
+                <a:solidFill>
+                  <a:schemeClr val="tx1"/>
+                </a:solidFill>
+                <a:sym typeface="Wingdings" panose="05000000000000000000" pitchFamily="2" charset="2"/>
+              </a:rPr>
+              <a:t>= R3 + </a:t>
+            </a:r>
+            <a:r>
+              <a:rPr lang="en-US" b="1" dirty="0">
+                <a:solidFill>
+                  <a:srgbClr val="0000FF"/>
+                </a:solidFill>
+                <a:sym typeface="Wingdings" panose="05000000000000000000" pitchFamily="2" charset="2"/>
+              </a:rPr>
+              <a:t>R1 × R2</a:t>
+            </a:r>
+          </a:p>
+          <a:p>
+            <a:pPr lvl="1"/>
+            <a:r>
+              <a:rPr lang="en-US" dirty="0">
+                <a:solidFill>
+                  <a:schemeClr val="tx1"/>
+                </a:solidFill>
+              </a:rPr>
+              <a:t>MLS	R0,</a:t>
+            </a:r>
+            <a:r>
+              <a:rPr lang="en-US" b="1" dirty="0">
+                <a:solidFill>
+                  <a:srgbClr val="0000FF"/>
+                </a:solidFill>
+              </a:rPr>
+              <a:t>R1,R2</a:t>
+            </a:r>
+            <a:r>
+              <a:rPr lang="en-US" dirty="0">
+                <a:solidFill>
+                  <a:schemeClr val="tx1"/>
+                </a:solidFill>
+              </a:rPr>
+              <a:t>,R3		// R0 </a:t>
+            </a:r>
+            <a:r>
+              <a:rPr lang="en-US" dirty="0">
+                <a:solidFill>
+                  <a:schemeClr val="tx1"/>
+                </a:solidFill>
+                <a:sym typeface="Wingdings" panose="05000000000000000000" pitchFamily="2" charset="2"/>
+              </a:rPr>
+              <a:t>= R3 -  </a:t>
+            </a:r>
+            <a:r>
+              <a:rPr lang="en-US" b="1" dirty="0">
+                <a:solidFill>
+                  <a:srgbClr val="0000FF"/>
+                </a:solidFill>
+                <a:sym typeface="Wingdings" panose="05000000000000000000" pitchFamily="2" charset="2"/>
+              </a:rPr>
+              <a:t>R1 × R2</a:t>
+            </a:r>
+          </a:p>
+          <a:p>
+            <a:endParaRPr lang="en-US" dirty="0"/>
+          </a:p>
+          <a:p>
+            <a:r>
+              <a:rPr lang="en-US" dirty="0">
+                <a:solidFill>
+                  <a:schemeClr val="tx1"/>
+                </a:solidFill>
+              </a:rPr>
+              <a:t>Flags:</a:t>
+            </a:r>
+            <a:r>
+              <a:rPr lang="en-US" dirty="0"/>
+              <a:t> </a:t>
+            </a:r>
+            <a:r>
+              <a:rPr lang="en-US" dirty="0">
                 <a:solidFill>
                   <a:srgbClr val="0070C0"/>
                 </a:solidFill>
               </a:rPr>
-              <a:t>SUB{S}, SBC{S}, RSB{S}</a:t>
-            </a:r>
-          </a:p>
-          <a:p>
-            <a:r>
-              <a:rPr lang="en-US" sz="2100" dirty="0"/>
-              <a:t>Format Examples:</a:t>
-            </a:r>
-          </a:p>
-          <a:p>
-            <a:pPr lvl="1"/>
-            <a:r>
-              <a:rPr lang="en-US" sz="1800" dirty="0"/>
-              <a:t>SUB	R0,R1,</a:t>
-            </a:r>
-            <a:r>
-              <a:rPr lang="en-US" sz="1800" b="1" dirty="0">
-                <a:solidFill>
-                  <a:srgbClr val="0000FF"/>
-                </a:solidFill>
-              </a:rPr>
-              <a:t>#5</a:t>
-            </a:r>
-            <a:r>
-              <a:rPr lang="en-US" sz="1800" dirty="0"/>
-              <a:t>		// R0 </a:t>
-            </a:r>
-            <a:r>
-              <a:rPr lang="en-US" sz="1800" dirty="0">
-                <a:sym typeface="Wingdings" panose="05000000000000000000" pitchFamily="2" charset="2"/>
-              </a:rPr>
-              <a:t>= R1 - 5</a:t>
-            </a:r>
-            <a:endParaRPr lang="en-US" sz="1800" dirty="0"/>
-          </a:p>
-          <a:p>
-            <a:pPr lvl="1"/>
-            <a:r>
-              <a:rPr lang="en-US" sz="1800" dirty="0"/>
-              <a:t>SUB	R0,R1,R2		// R0 </a:t>
-            </a:r>
-            <a:r>
-              <a:rPr lang="en-US" sz="1800" dirty="0">
-                <a:sym typeface="Wingdings" panose="05000000000000000000" pitchFamily="2" charset="2"/>
-              </a:rPr>
-              <a:t>= R1 - R2</a:t>
-            </a:r>
-            <a:endParaRPr lang="en-US" sz="1800" dirty="0"/>
-          </a:p>
-          <a:p>
-            <a:pPr lvl="1"/>
-            <a:r>
-              <a:rPr lang="en-US" sz="1800" dirty="0"/>
-              <a:t>SUB	R0,R1,</a:t>
-            </a:r>
-            <a:r>
-              <a:rPr lang="en-US" sz="1800" b="1" dirty="0">
-                <a:solidFill>
-                  <a:srgbClr val="0000FF"/>
-                </a:solidFill>
-              </a:rPr>
-              <a:t>R2,LSL #2</a:t>
-            </a:r>
-            <a:r>
-              <a:rPr lang="en-US" sz="1800" dirty="0"/>
-              <a:t>		// R0 </a:t>
-            </a:r>
-            <a:r>
-              <a:rPr lang="en-US" sz="1800" dirty="0">
-                <a:sym typeface="Wingdings" panose="05000000000000000000" pitchFamily="2" charset="2"/>
-              </a:rPr>
-              <a:t>= R1 - </a:t>
-            </a:r>
-            <a:r>
-              <a:rPr lang="en-US" sz="1800" b="1" dirty="0">
-                <a:solidFill>
-                  <a:srgbClr val="0000FF"/>
-                </a:solidFill>
-                <a:sym typeface="Wingdings" panose="05000000000000000000" pitchFamily="2" charset="2"/>
-              </a:rPr>
-              <a:t>(R2 &lt;&lt; 2)</a:t>
-            </a:r>
-            <a:r>
-              <a:rPr lang="en-US" sz="1800" dirty="0">
-                <a:solidFill>
-                  <a:srgbClr val="0070C0"/>
-                </a:solidFill>
-                <a:sym typeface="Wingdings" panose="05000000000000000000" pitchFamily="2" charset="2"/>
-              </a:rPr>
-              <a:t>	</a:t>
-            </a:r>
-            <a:endParaRPr lang="en-US" sz="1800" dirty="0">
-              <a:solidFill>
-                <a:srgbClr val="0070C0"/>
-              </a:solidFill>
-            </a:endParaRPr>
-          </a:p>
-          <a:p>
-            <a:endParaRPr lang="en-US" sz="2100" dirty="0"/>
-          </a:p>
-          <a:p>
-            <a:r>
-              <a:rPr lang="en-US" sz="2100" dirty="0"/>
-              <a:t>Flags: </a:t>
-            </a:r>
-            <a:r>
-              <a:rPr lang="en-US" sz="2100" dirty="0">
-                <a:solidFill>
-                  <a:srgbClr val="0070C0"/>
-                </a:solidFill>
-              </a:rPr>
-              <a:t>Append “S” to capture result characteristics in NCVZ</a:t>
-            </a:r>
-          </a:p>
-          <a:p>
-            <a:endParaRPr lang="en-US" sz="2100" dirty="0"/>
-          </a:p>
-          <a:p>
-            <a:r>
-              <a:rPr lang="en-US" sz="2100" dirty="0"/>
-              <a:t>Overflow:</a:t>
-            </a:r>
-          </a:p>
-          <a:p>
-            <a:pPr lvl="1"/>
-            <a:r>
-              <a:rPr lang="en-US" sz="1800" b="1" dirty="0">
-                <a:solidFill>
-                  <a:srgbClr val="92D050"/>
-                </a:solidFill>
-              </a:rPr>
-              <a:t>Unsigned</a:t>
-            </a:r>
-            <a:r>
-              <a:rPr lang="en-US" sz="1800" dirty="0">
-                <a:solidFill>
-                  <a:srgbClr val="0070C0"/>
-                </a:solidFill>
-              </a:rPr>
-              <a:t>: Carry Flag       (C) = 0</a:t>
-            </a:r>
-          </a:p>
-          <a:p>
-            <a:pPr lvl="1"/>
-            <a:r>
-              <a:rPr lang="en-US" sz="1800" dirty="0">
-                <a:solidFill>
-                  <a:srgbClr val="0070C0"/>
-                </a:solidFill>
-              </a:rPr>
-              <a:t>     </a:t>
-            </a:r>
-            <a:r>
-              <a:rPr lang="en-US" sz="1800" b="1" dirty="0">
+              <a:t>Append “S” (only MUL) to capture result characteristics in N and Z flags</a:t>
+            </a:r>
+          </a:p>
+          <a:p>
+            <a:endParaRPr lang="en-US" dirty="0"/>
+          </a:p>
+          <a:p>
+            <a:r>
+              <a:rPr lang="en-US" dirty="0">
+                <a:solidFill>
+                  <a:schemeClr val="tx1"/>
+                </a:solidFill>
+              </a:rPr>
+              <a:t>Overflow: </a:t>
+            </a:r>
+            <a:r>
+              <a:rPr lang="en-US" b="1" dirty="0">
                 <a:solidFill>
                   <a:srgbClr val="FF0000"/>
                 </a:solidFill>
               </a:rPr>
-              <a:t>Signed</a:t>
-            </a:r>
-            <a:r>
-              <a:rPr lang="en-US" sz="1800" dirty="0">
-                <a:solidFill>
-                  <a:srgbClr val="0070C0"/>
-                </a:solidFill>
-              </a:rPr>
-              <a:t>: Overflow Flag (V) = 1 (Set when C</a:t>
-            </a:r>
-            <a:r>
-              <a:rPr lang="en-US" sz="1800" baseline="-25000" dirty="0">
-                <a:solidFill>
-                  <a:srgbClr val="0070C0"/>
-                </a:solidFill>
-              </a:rPr>
-              <a:t>N</a:t>
-            </a:r>
-            <a:r>
-              <a:rPr lang="en-US" sz="1800" dirty="0">
-                <a:solidFill>
-                  <a:srgbClr val="0070C0"/>
-                </a:solidFill>
-              </a:rPr>
-              <a:t>≠C</a:t>
-            </a:r>
-            <a:r>
-              <a:rPr lang="en-US" sz="1800" baseline="-25000" dirty="0">
-                <a:solidFill>
-                  <a:srgbClr val="0070C0"/>
-                </a:solidFill>
-              </a:rPr>
-              <a:t>N-1</a:t>
-            </a:r>
-            <a:r>
-              <a:rPr lang="en-US" sz="1800" dirty="0">
-                <a:solidFill>
-                  <a:srgbClr val="0070C0"/>
-                </a:solidFill>
-              </a:rPr>
-              <a:t>)</a:t>
-            </a:r>
-          </a:p>
-          <a:p>
-            <a:endParaRPr lang="en-US" sz="2100" dirty="0"/>
-          </a:p>
-          <a:p>
-            <a:r>
-              <a:rPr lang="en-US" sz="2100" dirty="0"/>
-              <a:t>Multiple precision subtraction: </a:t>
-            </a:r>
-            <a:r>
-              <a:rPr lang="en-US" sz="2100" dirty="0">
-                <a:solidFill>
-                  <a:srgbClr val="0070C0"/>
-                </a:solidFill>
-              </a:rPr>
-              <a:t>SUB</a:t>
-            </a:r>
-            <a:r>
-              <a:rPr lang="en-US" sz="2100" b="1" dirty="0">
-                <a:solidFill>
-                  <a:srgbClr val="FF0000"/>
-                </a:solidFill>
-              </a:rPr>
-              <a:t>S</a:t>
-            </a:r>
-            <a:r>
-              <a:rPr lang="en-US" sz="2100" dirty="0">
-                <a:solidFill>
-                  <a:srgbClr val="0070C0"/>
-                </a:solidFill>
-              </a:rPr>
-              <a:t> </a:t>
-            </a:r>
-            <a:r>
-              <a:rPr lang="en-US" sz="2100" dirty="0">
-                <a:solidFill>
-                  <a:srgbClr val="0070C0"/>
-                </a:solidFill>
-                <a:sym typeface="Wingdings" panose="05000000000000000000" pitchFamily="2" charset="2"/>
-              </a:rPr>
-              <a:t> SBC</a:t>
-            </a:r>
-            <a:endParaRPr lang="en-US" sz="2100" dirty="0">
-              <a:solidFill>
-                <a:srgbClr val="0070C0"/>
-              </a:solidFill>
-            </a:endParaRPr>
-          </a:p>
-          <a:p>
-            <a:endParaRPr lang="en-US" sz="2100" dirty="0"/>
-          </a:p>
-          <a:p>
-            <a:endParaRPr lang="en-US" sz="2100" dirty="0"/>
+              <a:t>May happen but impossible to detect!</a:t>
+            </a:r>
           </a:p>
         </p:txBody>
       </p:sp>
     </p:spTree>
     <p:extLst>
       <p:ext uri="{BB962C8B-B14F-4D97-AF65-F5344CB8AC3E}">
-        <p14:creationId xmlns:p14="http://schemas.microsoft.com/office/powerpoint/2010/main" val="2046813644"/>
+        <p14:creationId xmlns:p14="http://schemas.microsoft.com/office/powerpoint/2010/main" val="3196419567"/>
       </p:ext>
     </p:extLst>
   </p:cSld>
@@ -42987,8 +43310,8 @@
         </p:nvSpPr>
         <p:spPr>
           <a:xfrm>
-            <a:off x="936516" y="745181"/>
-            <a:ext cx="9466789" cy="686577"/>
+            <a:off x="936516" y="741171"/>
+            <a:ext cx="9643252" cy="734703"/>
           </a:xfrm>
         </p:spPr>
         <p:txBody>
@@ -42999,7 +43322,7 @@
           <a:p>
             <a:r>
               <a:rPr lang="en-US" dirty="0"/>
-              <a:t>Single-Length 32x32 Integer Multiplication</a:t>
+              <a:t>Double-Length 32x32 Integer Multiplication</a:t>
             </a:r>
           </a:p>
         </p:txBody>
@@ -43016,13 +43339,13 @@
         </p:nvSpPr>
         <p:spPr>
           <a:xfrm>
-            <a:off x="936515" y="1807701"/>
-            <a:ext cx="10441347" cy="4841752"/>
+            <a:off x="936515" y="1795670"/>
+            <a:ext cx="10425305" cy="4833730"/>
           </a:xfrm>
         </p:spPr>
         <p:txBody>
           <a:bodyPr>
-            <a:normAutofit lnSpcReduction="10000"/>
+            <a:normAutofit fontScale="92500" lnSpcReduction="10000"/>
           </a:bodyPr>
           <a:lstStyle/>
           <a:p>
@@ -43044,23 +43367,7 @@
                   <a:srgbClr val="0070C0"/>
                 </a:solidFill>
               </a:rPr>
-              <a:t>MUL{</a:t>
-            </a:r>
-            <a:r>
-              <a:rPr lang="en-US" b="1" dirty="0">
-                <a:solidFill>
-                  <a:srgbClr val="FF0000"/>
-                </a:solidFill>
-              </a:rPr>
-              <a:t>S</a:t>
-            </a:r>
-            <a:r>
-              <a:rPr lang="en-US" dirty="0">
-                <a:solidFill>
-                  <a:srgbClr val="0070C0"/>
-                </a:solidFill>
-              </a:rPr>
-              <a:t>}, MLA, MLS</a:t>
+              <a:t>UMULL, SMULL, UMLAL, SMLAL</a:t>
             </a:r>
           </a:p>
           <a:p>
@@ -43085,27 +43392,184 @@
                   <a:schemeClr val="tx1"/>
                 </a:solidFill>
               </a:rPr>
-              <a:t>vs.</a:t>
+              <a:t>vs. </a:t>
+            </a:r>
+            <a:r>
+              <a:rPr lang="en-US" b="1" dirty="0">
+                <a:solidFill>
+                  <a:srgbClr val="92D050"/>
+                </a:solidFill>
+              </a:rPr>
+              <a:t>Unsigned</a:t>
+            </a:r>
+            <a:r>
+              <a:rPr lang="en-US" dirty="0"/>
+              <a:t>: </a:t>
+            </a:r>
+            <a:r>
+              <a:rPr lang="en-US" dirty="0">
+                <a:solidFill>
+                  <a:srgbClr val="0070C0"/>
+                </a:solidFill>
+              </a:rPr>
+              <a:t>Use </a:t>
+            </a:r>
+            <a:r>
+              <a:rPr lang="en-US" b="1" dirty="0">
+                <a:solidFill>
+                  <a:srgbClr val="0070C0"/>
+                </a:solidFill>
+              </a:rPr>
+              <a:t>different</a:t>
+            </a:r>
+            <a:r>
+              <a:rPr lang="en-US" dirty="0">
+                <a:solidFill>
+                  <a:srgbClr val="0070C0"/>
+                </a:solidFill>
+              </a:rPr>
+              <a:t> instructions!</a:t>
+            </a:r>
+          </a:p>
+          <a:p>
+            <a:endParaRPr lang="en-US" dirty="0"/>
+          </a:p>
+          <a:p>
+            <a:r>
+              <a:rPr lang="en-US" b="1" dirty="0">
+                <a:solidFill>
+                  <a:srgbClr val="FF0000"/>
+                </a:solidFill>
+              </a:rPr>
+              <a:t>Signed</a:t>
             </a:r>
             <a:r>
               <a:rPr lang="en-US" dirty="0"/>
               <a:t> </a:t>
             </a:r>
             <a:r>
+              <a:rPr lang="en-US" dirty="0">
+                <a:solidFill>
+                  <a:schemeClr val="tx1"/>
+                </a:solidFill>
+              </a:rPr>
+              <a:t>Instruction Formats:</a:t>
+            </a:r>
+          </a:p>
+          <a:p>
+            <a:pPr lvl="1"/>
+            <a:r>
               <a:rPr lang="en-US" b="1" dirty="0">
                 <a:solidFill>
+                  <a:srgbClr val="FF0000"/>
+                </a:solidFill>
+              </a:rPr>
+              <a:t>S</a:t>
+            </a:r>
+            <a:r>
+              <a:rPr lang="en-US" dirty="0">
+                <a:solidFill>
+                  <a:schemeClr val="tx1"/>
+                </a:solidFill>
+              </a:rPr>
+              <a:t>MULL	R0,R1,</a:t>
+            </a:r>
+            <a:r>
+              <a:rPr lang="en-US" b="1" dirty="0">
+                <a:solidFill>
+                  <a:srgbClr val="0000FF"/>
+                </a:solidFill>
+              </a:rPr>
+              <a:t>R2,R3</a:t>
+            </a:r>
+            <a:r>
+              <a:rPr lang="en-US" dirty="0">
+                <a:solidFill>
+                  <a:schemeClr val="tx1"/>
+                </a:solidFill>
+              </a:rPr>
+              <a:t>		// R0.R1 </a:t>
+            </a:r>
+            <a:r>
+              <a:rPr lang="en-US" dirty="0">
+                <a:solidFill>
+                  <a:schemeClr val="tx1"/>
+                </a:solidFill>
+                <a:sym typeface="Wingdings" panose="05000000000000000000" pitchFamily="2" charset="2"/>
+              </a:rPr>
+              <a:t>=               </a:t>
+            </a:r>
+            <a:r>
+              <a:rPr lang="en-US" b="1" dirty="0">
+                <a:solidFill>
+                  <a:srgbClr val="0000FF"/>
+                </a:solidFill>
+                <a:sym typeface="Wingdings" panose="05000000000000000000" pitchFamily="2" charset="2"/>
+              </a:rPr>
+              <a:t>R2 × R3</a:t>
+            </a:r>
+          </a:p>
+          <a:p>
+            <a:pPr lvl="1"/>
+            <a:r>
+              <a:rPr lang="en-US" b="1" dirty="0">
+                <a:solidFill>
+                  <a:srgbClr val="FF0000"/>
+                </a:solidFill>
+              </a:rPr>
+              <a:t>S</a:t>
+            </a:r>
+            <a:r>
+              <a:rPr lang="en-US" dirty="0">
+                <a:solidFill>
+                  <a:schemeClr val="tx1"/>
+                </a:solidFill>
+              </a:rPr>
+              <a:t>MLAL	R0,R1,</a:t>
+            </a:r>
+            <a:r>
+              <a:rPr lang="en-US" b="1" dirty="0">
+                <a:solidFill>
+                  <a:srgbClr val="0000FF"/>
+                </a:solidFill>
+              </a:rPr>
+              <a:t>R2,R3</a:t>
+            </a:r>
+            <a:r>
+              <a:rPr lang="en-US" dirty="0">
+                <a:solidFill>
+                  <a:schemeClr val="tx1"/>
+                </a:solidFill>
+              </a:rPr>
+              <a:t>		// R0.R1 </a:t>
+            </a:r>
+            <a:r>
+              <a:rPr lang="en-US" dirty="0">
+                <a:solidFill>
+                  <a:schemeClr val="tx1"/>
+                </a:solidFill>
+                <a:sym typeface="Wingdings" panose="05000000000000000000" pitchFamily="2" charset="2"/>
+              </a:rPr>
+              <a:t>= R0.R1 + </a:t>
+            </a:r>
+            <a:r>
+              <a:rPr lang="en-US" b="1" dirty="0">
+                <a:solidFill>
+                  <a:srgbClr val="0000FF"/>
+                </a:solidFill>
+                <a:sym typeface="Wingdings" panose="05000000000000000000" pitchFamily="2" charset="2"/>
+              </a:rPr>
+              <a:t>R2 × R3</a:t>
+            </a:r>
+          </a:p>
+          <a:p>
+            <a:r>
+              <a:rPr lang="en-US" b="1" dirty="0">
+                <a:solidFill>
                   <a:srgbClr val="92D050"/>
                 </a:solidFill>
               </a:rPr>
               <a:t>Unsigned</a:t>
-            </a:r>
-            <a:r>
-              <a:rPr lang="en-US" dirty="0">
-                <a:solidFill>
-                  <a:schemeClr val="tx1"/>
-                </a:solidFill>
-              </a:rPr>
-              <a:t>:</a:t>
             </a:r>
             <a:r>
               <a:rPr lang="en-US" dirty="0"/>
@@ -43114,26 +43578,116 @@
             <a:r>
               <a:rPr lang="en-US" dirty="0">
                 <a:solidFill>
-                  <a:srgbClr val="0070C0"/>
-                </a:solidFill>
-              </a:rPr>
-              <a:t>Use </a:t>
-            </a:r>
+                  <a:schemeClr val="tx1"/>
+                </a:solidFill>
+              </a:rPr>
+              <a:t>Instruction Formats:</a:t>
+            </a:r>
+          </a:p>
+          <a:p>
+            <a:pPr lvl="1"/>
             <a:r>
               <a:rPr lang="en-US" b="1" dirty="0">
                 <a:solidFill>
-                  <a:srgbClr val="0070C0"/>
-                </a:solidFill>
-              </a:rPr>
-              <a:t>same</a:t>
+                  <a:srgbClr val="92D050"/>
+                </a:solidFill>
+              </a:rPr>
+              <a:t>U</a:t>
             </a:r>
             <a:r>
               <a:rPr lang="en-US" dirty="0">
                 <a:solidFill>
-                  <a:srgbClr val="0070C0"/>
-                </a:solidFill>
-              </a:rPr>
-              <a:t> instruction</a:t>
+                  <a:schemeClr val="tx1"/>
+                </a:solidFill>
+              </a:rPr>
+              <a:t>MULL	R0,R1,</a:t>
+            </a:r>
+            <a:r>
+              <a:rPr lang="en-US" b="1" dirty="0">
+                <a:solidFill>
+                  <a:srgbClr val="0000FF"/>
+                </a:solidFill>
+              </a:rPr>
+              <a:t>R2,R3</a:t>
+            </a:r>
+            <a:r>
+              <a:rPr lang="en-US" dirty="0">
+                <a:solidFill>
+                  <a:schemeClr val="tx1"/>
+                </a:solidFill>
+              </a:rPr>
+              <a:t>		// R0.R1 </a:t>
+            </a:r>
+            <a:r>
+              <a:rPr lang="en-US" dirty="0">
+                <a:solidFill>
+                  <a:schemeClr val="tx1"/>
+                </a:solidFill>
+                <a:sym typeface="Wingdings" panose="05000000000000000000" pitchFamily="2" charset="2"/>
+              </a:rPr>
+              <a:t>=               </a:t>
+            </a:r>
+            <a:r>
+              <a:rPr lang="en-US" b="1" dirty="0">
+                <a:solidFill>
+                  <a:srgbClr val="0000FF"/>
+                </a:solidFill>
+                <a:sym typeface="Wingdings" panose="05000000000000000000" pitchFamily="2" charset="2"/>
+              </a:rPr>
+              <a:t>R2 × R3</a:t>
+            </a:r>
+          </a:p>
+          <a:p>
+            <a:pPr lvl="1"/>
+            <a:r>
+              <a:rPr lang="en-US" b="1" dirty="0">
+                <a:solidFill>
+                  <a:srgbClr val="92D050"/>
+                </a:solidFill>
+              </a:rPr>
+              <a:t>U</a:t>
+            </a:r>
+            <a:r>
+              <a:rPr lang="en-US" dirty="0">
+                <a:solidFill>
+                  <a:schemeClr val="tx1"/>
+                </a:solidFill>
+              </a:rPr>
+              <a:t>MLAL	R0,R1,</a:t>
+            </a:r>
+            <a:r>
+              <a:rPr lang="en-US" b="1" dirty="0">
+                <a:solidFill>
+                  <a:srgbClr val="0000FF"/>
+                </a:solidFill>
+              </a:rPr>
+              <a:t>R2,R3</a:t>
+            </a:r>
+            <a:r>
+              <a:rPr lang="en-US" dirty="0">
+                <a:solidFill>
+                  <a:schemeClr val="tx1"/>
+                </a:solidFill>
+              </a:rPr>
+              <a:t>		// R0.R1 </a:t>
+            </a:r>
+            <a:r>
+              <a:rPr lang="en-US" dirty="0">
+                <a:solidFill>
+                  <a:schemeClr val="tx1"/>
+                </a:solidFill>
+                <a:sym typeface="Wingdings" panose="05000000000000000000" pitchFamily="2" charset="2"/>
+              </a:rPr>
+              <a:t>= R0.R1 + </a:t>
+            </a:r>
+            <a:r>
+              <a:rPr lang="en-US" b="1" dirty="0">
+                <a:solidFill>
+                  <a:srgbClr val="0000FF"/>
+                </a:solidFill>
+                <a:sym typeface="Wingdings" panose="05000000000000000000" pitchFamily="2" charset="2"/>
+              </a:rPr>
+              <a:t>R2 × R3</a:t>
             </a:r>
           </a:p>
           <a:p>
@@ -43146,188 +43700,37 @@
                   <a:schemeClr val="tx1"/>
                 </a:solidFill>
               </a:rPr>
-              <a:t>Format Examples:</a:t>
-            </a:r>
-          </a:p>
-          <a:p>
-            <a:pPr lvl="1"/>
+              <a:t>Flags:</a:t>
+            </a:r>
+            <a:r>
+              <a:rPr lang="en-US" dirty="0"/>
+              <a:t>      </a:t>
+            </a:r>
+            <a:r>
+              <a:rPr lang="en-US" b="1" dirty="0">
+                <a:solidFill>
+                  <a:srgbClr val="FF0000"/>
+                </a:solidFill>
+              </a:rPr>
+              <a:t>Unaffected!</a:t>
+            </a:r>
+          </a:p>
+          <a:p>
             <a:r>
               <a:rPr lang="en-US" dirty="0">
                 <a:solidFill>
                   <a:schemeClr val="tx1"/>
                 </a:solidFill>
               </a:rPr>
-              <a:t>MUL	R0,</a:t>
+              <a:t>Overflow: </a:t>
             </a:r>
             <a:r>
               <a:rPr lang="en-US" b="1" dirty="0">
                 <a:solidFill>
-                  <a:srgbClr val="0000FF"/>
-                </a:solidFill>
-              </a:rPr>
-              <a:t>R1,R2</a:t>
-            </a:r>
-            <a:r>
-              <a:rPr lang="en-US" dirty="0">
-                <a:solidFill>
-                  <a:schemeClr val="tx1"/>
-                </a:solidFill>
-              </a:rPr>
-              <a:t>		// R0 </a:t>
-            </a:r>
-            <a:r>
-              <a:rPr lang="en-US" dirty="0">
-                <a:solidFill>
-                  <a:schemeClr val="tx1"/>
-                </a:solidFill>
-                <a:sym typeface="Wingdings" panose="05000000000000000000" pitchFamily="2" charset="2"/>
-              </a:rPr>
-              <a:t>= </a:t>
-            </a:r>
-            <a:r>
-              <a:rPr lang="en-US" b="1" dirty="0">
-                <a:solidFill>
-                  <a:srgbClr val="0000FF"/>
-                </a:solidFill>
-                <a:sym typeface="Wingdings" panose="05000000000000000000" pitchFamily="2" charset="2"/>
-              </a:rPr>
-              <a:t>R1 × R2</a:t>
-            </a:r>
-          </a:p>
-          <a:p>
-            <a:pPr lvl="1"/>
-            <a:r>
-              <a:rPr lang="en-US" dirty="0">
-                <a:solidFill>
-                  <a:schemeClr val="tx1"/>
-                </a:solidFill>
-              </a:rPr>
-              <a:t>MLA	R0,</a:t>
-            </a:r>
-            <a:r>
-              <a:rPr lang="en-US" b="1" dirty="0">
-                <a:solidFill>
-                  <a:srgbClr val="0000FF"/>
-                </a:solidFill>
-              </a:rPr>
-              <a:t>R1,R2</a:t>
-            </a:r>
-            <a:r>
-              <a:rPr lang="en-US" dirty="0">
-                <a:solidFill>
-                  <a:schemeClr val="tx1"/>
-                </a:solidFill>
-              </a:rPr>
-              <a:t>,R3		// R0 </a:t>
-            </a:r>
-            <a:r>
-              <a:rPr lang="en-US" dirty="0">
-                <a:solidFill>
-                  <a:schemeClr val="tx1"/>
-                </a:solidFill>
-                <a:sym typeface="Wingdings" panose="05000000000000000000" pitchFamily="2" charset="2"/>
-              </a:rPr>
-              <a:t>= R3 + </a:t>
-            </a:r>
-            <a:r>
-              <a:rPr lang="en-US" b="1" dirty="0">
-                <a:solidFill>
-                  <a:srgbClr val="0000FF"/>
-                </a:solidFill>
-                <a:sym typeface="Wingdings" panose="05000000000000000000" pitchFamily="2" charset="2"/>
-              </a:rPr>
-              <a:t>R1 × R2</a:t>
-            </a:r>
-          </a:p>
-          <a:p>
-            <a:pPr lvl="1"/>
-            <a:r>
-              <a:rPr lang="en-US" dirty="0">
-                <a:solidFill>
-                  <a:schemeClr val="tx1"/>
-                </a:solidFill>
-              </a:rPr>
-              <a:t>MLS	R0,</a:t>
-            </a:r>
-            <a:r>
-              <a:rPr lang="en-US" b="1" dirty="0">
-                <a:solidFill>
-                  <a:srgbClr val="0000FF"/>
-                </a:solidFill>
-              </a:rPr>
-              <a:t>R1,R2</a:t>
-            </a:r>
-            <a:r>
-              <a:rPr lang="en-US" dirty="0">
-                <a:solidFill>
-                  <a:schemeClr val="tx1"/>
-                </a:solidFill>
-              </a:rPr>
-              <a:t>,R3		// R0 </a:t>
-            </a:r>
-            <a:r>
-              <a:rPr lang="en-US" dirty="0">
-                <a:solidFill>
-                  <a:schemeClr val="tx1"/>
-                </a:solidFill>
-                <a:sym typeface="Wingdings" panose="05000000000000000000" pitchFamily="2" charset="2"/>
-              </a:rPr>
-              <a:t>= R3 -  </a:t>
-            </a:r>
-            <a:r>
-              <a:rPr lang="en-US" b="1" dirty="0">
-                <a:solidFill>
-                  <a:srgbClr val="0000FF"/>
-                </a:solidFill>
-                <a:sym typeface="Wingdings" panose="05000000000000000000" pitchFamily="2" charset="2"/>
-              </a:rPr>
-              <a:t>R1 × R2</a:t>
-            </a:r>
-          </a:p>
-          <a:p>
-            <a:endParaRPr lang="en-US" dirty="0"/>
-          </a:p>
-          <a:p>
-            <a:r>
-              <a:rPr lang="en-US" dirty="0">
-                <a:solidFill>
-                  <a:schemeClr val="tx1"/>
-                </a:solidFill>
-              </a:rPr>
-              <a:t>Flags:</a:t>
-            </a:r>
-            <a:r>
-              <a:rPr lang="en-US" dirty="0"/>
-              <a:t> </a:t>
-            </a:r>
-            <a:r>
-              <a:rPr lang="en-US" dirty="0">
-                <a:solidFill>
-                  <a:srgbClr val="0070C0"/>
-                </a:solidFill>
-              </a:rPr>
-              <a:t>Append “S” (only MUL) to capture result characteristics in N and Z flags</a:t>
-            </a:r>
-          </a:p>
-          <a:p>
-            <a:endParaRPr lang="en-US" dirty="0"/>
-          </a:p>
-          <a:p>
-            <a:r>
-              <a:rPr lang="en-US" dirty="0">
-                <a:solidFill>
-                  <a:schemeClr val="tx1"/>
-                </a:solidFill>
-              </a:rPr>
-              <a:t>Overflow: </a:t>
-            </a:r>
-            <a:r>
-              <a:rPr lang="en-US" b="1" dirty="0">
-                <a:solidFill>
                   <a:srgbClr val="FF0000"/>
                 </a:solidFill>
               </a:rPr>
-              <a:t>May happen but impossible to detect!</a:t>
+              <a:t>Can’t happen</a:t>
             </a:r>
           </a:p>
         </p:txBody>
@@ -43335,7 +43738,7 @@
     </p:spTree>
     <p:extLst>
       <p:ext uri="{BB962C8B-B14F-4D97-AF65-F5344CB8AC3E}">
-        <p14:creationId xmlns:p14="http://schemas.microsoft.com/office/powerpoint/2010/main" val="3196419567"/>
+        <p14:creationId xmlns:p14="http://schemas.microsoft.com/office/powerpoint/2010/main" val="228742505"/>
       </p:ext>
     </p:extLst>
   </p:cSld>
@@ -43374,8 +43777,8 @@
         </p:nvSpPr>
         <p:spPr>
           <a:xfrm>
-            <a:off x="936516" y="741171"/>
-            <a:ext cx="9643252" cy="734703"/>
+            <a:off x="940526" y="745181"/>
+            <a:ext cx="8315769" cy="746735"/>
           </a:xfrm>
         </p:spPr>
         <p:txBody>
@@ -43386,7 +43789,7 @@
           <a:p>
             <a:r>
               <a:rPr lang="en-US" dirty="0"/>
-              <a:t>Double-Length 32x32 Integer Multiplication</a:t>
+              <a:t>Single-Length 32÷32 Integer Division</a:t>
             </a:r>
           </a:p>
         </p:txBody>
@@ -43403,8 +43806,8 @@
         </p:nvSpPr>
         <p:spPr>
           <a:xfrm>
-            <a:off x="936515" y="1795670"/>
-            <a:ext cx="10425305" cy="4833730"/>
+            <a:off x="940525" y="1806366"/>
+            <a:ext cx="10409263" cy="4835066"/>
           </a:xfrm>
         </p:spPr>
         <p:txBody>
@@ -43419,7 +43822,65 @@
                   <a:schemeClr val="tx1"/>
                 </a:solidFill>
               </a:rPr>
-              <a:t>Instructions:</a:t>
+              <a:t>Instructions: </a:t>
+            </a:r>
+            <a:r>
+              <a:rPr lang="en-US" b="1" dirty="0">
+                <a:solidFill>
+                  <a:srgbClr val="FF0000"/>
+                </a:solidFill>
+              </a:rPr>
+              <a:t>S</a:t>
+            </a:r>
+            <a:r>
+              <a:rPr lang="en-US" dirty="0">
+                <a:solidFill>
+                  <a:srgbClr val="0070C0"/>
+                </a:solidFill>
+              </a:rPr>
+              <a:t>DIV</a:t>
+            </a:r>
+            <a:r>
+              <a:rPr lang="en-US" dirty="0">
+                <a:solidFill>
+                  <a:schemeClr val="tx1"/>
+                </a:solidFill>
+              </a:rPr>
+              <a:t>,</a:t>
+            </a:r>
+            <a:r>
+              <a:rPr lang="en-US" dirty="0">
+                <a:solidFill>
+                  <a:srgbClr val="0070C0"/>
+                </a:solidFill>
+              </a:rPr>
+              <a:t> </a:t>
+            </a:r>
+            <a:r>
+              <a:rPr lang="en-US" b="1" dirty="0">
+                <a:solidFill>
+                  <a:srgbClr val="92D050"/>
+                </a:solidFill>
+              </a:rPr>
+              <a:t>U</a:t>
+            </a:r>
+            <a:r>
+              <a:rPr lang="en-US" dirty="0">
+                <a:solidFill>
+                  <a:srgbClr val="0070C0"/>
+                </a:solidFill>
+              </a:rPr>
+              <a:t>DIV</a:t>
+            </a:r>
+          </a:p>
+          <a:p>
+            <a:r>
+              <a:rPr lang="en-US" b="1" dirty="0">
+                <a:solidFill>
+                  <a:srgbClr val="FF0000"/>
+                </a:solidFill>
+              </a:rPr>
+              <a:t>Signed</a:t>
             </a:r>
             <a:r>
               <a:rPr lang="en-US" dirty="0"/>
@@ -43428,37 +43889,16 @@
             <a:r>
               <a:rPr lang="en-US" dirty="0">
                 <a:solidFill>
-                  <a:srgbClr val="0070C0"/>
-                </a:solidFill>
-              </a:rPr>
-              <a:t>UMULL, SMULL, UMLAL, SMLAL</a:t>
-            </a:r>
-          </a:p>
-          <a:p>
-            <a:endParaRPr lang="en-US" dirty="0"/>
-          </a:p>
-          <a:p>
-            <a:r>
-              <a:rPr lang="en-US" b="1" dirty="0">
-                <a:solidFill>
-                  <a:srgbClr val="FF0000"/>
-                </a:solidFill>
-              </a:rPr>
-              <a:t>Signed</a:t>
+                  <a:schemeClr val="tx1"/>
+                </a:solidFill>
+              </a:rPr>
+              <a:t>vs.</a:t>
             </a:r>
             <a:r>
               <a:rPr lang="en-US" dirty="0"/>
               <a:t> </a:t>
             </a:r>
             <a:r>
-              <a:rPr lang="en-US" dirty="0">
-                <a:solidFill>
-                  <a:schemeClr val="tx1"/>
-                </a:solidFill>
-              </a:rPr>
-              <a:t>vs. </a:t>
-            </a:r>
-            <a:r>
               <a:rPr lang="en-US" b="1" dirty="0">
                 <a:solidFill>
                   <a:srgbClr val="92D050"/>
@@ -43479,9 +43919,9 @@
               <a:t>Use </a:t>
             </a:r>
             <a:r>
-              <a:rPr lang="en-US" b="1" dirty="0">
-                <a:solidFill>
-                  <a:srgbClr val="0070C0"/>
+              <a:rPr lang="en-US" dirty="0">
+                <a:solidFill>
+                  <a:srgbClr val="FF0000"/>
                 </a:solidFill>
               </a:rPr>
               <a:t>different</a:t>
@@ -43517,7 +43957,7 @@
                   <a:schemeClr val="tx1"/>
                 </a:solidFill>
               </a:rPr>
-              <a:t>Instruction Formats:</a:t>
+              <a:t>Instruction Format:</a:t>
             </a:r>
           </a:p>
           <a:p>
@@ -43533,97 +43973,19 @@
             <a:r>
               <a:rPr lang="en-US" dirty="0">
                 <a:solidFill>
-                  <a:schemeClr val="tx1"/>
-                </a:solidFill>
-              </a:rPr>
-              <a:t>MULL	R0,R1,</a:t>
-            </a:r>
-            <a:r>
-              <a:rPr lang="en-US" b="1" dirty="0">
-                <a:solidFill>
-                  <a:srgbClr val="0000FF"/>
-                </a:solidFill>
-              </a:rPr>
-              <a:t>R2,R3</a:t>
+                  <a:srgbClr val="0070C0"/>
+                </a:solidFill>
+              </a:rPr>
+              <a:t>DIV	R0,R1,R2		// R0 </a:t>
             </a:r>
             <a:r>
               <a:rPr lang="en-US" dirty="0">
                 <a:solidFill>
-                  <a:schemeClr val="tx1"/>
-                </a:solidFill>
-              </a:rPr>
-              <a:t>		// R0.R1 </a:t>
-            </a:r>
-            <a:r>
-              <a:rPr lang="en-US" dirty="0">
-                <a:solidFill>
-                  <a:schemeClr val="tx1"/>
+                  <a:srgbClr val="0070C0"/>
                 </a:solidFill>
                 <a:sym typeface="Wingdings" panose="05000000000000000000" pitchFamily="2" charset="2"/>
               </a:rPr>
-              <a:t>=               </a:t>
-            </a:r>
-            <a:r>
-              <a:rPr lang="en-US" b="1" dirty="0">
-                <a:solidFill>
-                  <a:srgbClr val="0000FF"/>
-                </a:solidFill>
-                <a:sym typeface="Wingdings" panose="05000000000000000000" pitchFamily="2" charset="2"/>
-              </a:rPr>
-              <a:t>R2 × R3</a:t>
-            </a:r>
-          </a:p>
-          <a:p>
-            <a:pPr lvl="1"/>
-            <a:r>
-              <a:rPr lang="en-US" b="1" dirty="0">
-                <a:solidFill>
-                  <a:srgbClr val="FF0000"/>
-                </a:solidFill>
-              </a:rPr>
-              <a:t>S</a:t>
-            </a:r>
-            <a:r>
-              <a:rPr lang="en-US" dirty="0">
-                <a:solidFill>
-                  <a:schemeClr val="tx1"/>
-                </a:solidFill>
-              </a:rPr>
-              <a:t>MLAL	R0,R1,</a:t>
-            </a:r>
-            <a:r>
-              <a:rPr lang="en-US" b="1" dirty="0">
-                <a:solidFill>
-                  <a:srgbClr val="0000FF"/>
-                </a:solidFill>
-              </a:rPr>
-              <a:t>R2,R3</a:t>
-            </a:r>
-            <a:r>
-              <a:rPr lang="en-US" dirty="0">
-                <a:solidFill>
-                  <a:schemeClr val="tx1"/>
-                </a:solidFill>
-              </a:rPr>
-              <a:t>		// R0.R1 </a:t>
-            </a:r>
-            <a:r>
-              <a:rPr lang="en-US" dirty="0">
-                <a:solidFill>
-                  <a:schemeClr val="tx1"/>
-                </a:solidFill>
-                <a:sym typeface="Wingdings" panose="05000000000000000000" pitchFamily="2" charset="2"/>
-              </a:rPr>
-              <a:t>= R0.R1 + </a:t>
-            </a:r>
-            <a:r>
-              <a:rPr lang="en-US" b="1" dirty="0">
-                <a:solidFill>
-                  <a:srgbClr val="0000FF"/>
-                </a:solidFill>
-                <a:sym typeface="Wingdings" panose="05000000000000000000" pitchFamily="2" charset="2"/>
-              </a:rPr>
-              <a:t>R2 × R3</a:t>
+              <a:t>= R1 ÷ R2</a:t>
             </a:r>
           </a:p>
           <a:p>
@@ -43645,7 +44007,7 @@
                   <a:schemeClr val="tx1"/>
                 </a:solidFill>
               </a:rPr>
-              <a:t>Instruction Formats:</a:t>
+              <a:t>Instruction Format:</a:t>
             </a:r>
           </a:p>
           <a:p>
@@ -43661,140 +44023,79 @@
             <a:r>
               <a:rPr lang="en-US" dirty="0">
                 <a:solidFill>
+                  <a:srgbClr val="0070C0"/>
+                </a:solidFill>
+              </a:rPr>
+              <a:t>DIV	R0,R1,R2		// R0 </a:t>
+            </a:r>
+            <a:r>
+              <a:rPr lang="en-US" dirty="0">
+                <a:solidFill>
+                  <a:srgbClr val="0070C0"/>
+                </a:solidFill>
+                <a:sym typeface="Wingdings" panose="05000000000000000000" pitchFamily="2" charset="2"/>
+              </a:rPr>
+              <a:t>= R1 ÷ R2</a:t>
+            </a:r>
+          </a:p>
+          <a:p>
+            <a:endParaRPr lang="en-US" dirty="0"/>
+          </a:p>
+          <a:p>
+            <a:r>
+              <a:rPr lang="en-US" dirty="0">
+                <a:solidFill>
                   <a:schemeClr val="tx1"/>
                 </a:solidFill>
               </a:rPr>
-              <a:t>MULL	R0,R1,</a:t>
+              <a:t>Flags:</a:t>
+            </a:r>
+            <a:r>
+              <a:rPr lang="en-US" dirty="0"/>
+              <a:t> </a:t>
             </a:r>
             <a:r>
               <a:rPr lang="en-US" b="1" dirty="0">
                 <a:solidFill>
-                  <a:srgbClr val="0000FF"/>
-                </a:solidFill>
-              </a:rPr>
-              <a:t>R2,R3</a:t>
-            </a:r>
+                  <a:srgbClr val="FF0000"/>
+                </a:solidFill>
+              </a:rPr>
+              <a:t>Unaffected</a:t>
+            </a:r>
+          </a:p>
+          <a:p>
+            <a:endParaRPr lang="en-US" dirty="0"/>
+          </a:p>
+          <a:p>
             <a:r>
               <a:rPr lang="en-US" dirty="0">
                 <a:solidFill>
                   <a:schemeClr val="tx1"/>
                 </a:solidFill>
               </a:rPr>
-              <a:t>		// R0.R1 </a:t>
-            </a:r>
+              <a:t>Overflow:</a:t>
+            </a:r>
+          </a:p>
+          <a:p>
+            <a:pPr lvl="1"/>
             <a:r>
               <a:rPr lang="en-US" dirty="0">
                 <a:solidFill>
-                  <a:schemeClr val="tx1"/>
-                </a:solidFill>
-                <a:sym typeface="Wingdings" panose="05000000000000000000" pitchFamily="2" charset="2"/>
-              </a:rPr>
-              <a:t>=               </a:t>
-            </a:r>
-            <a:r>
-              <a:rPr lang="en-US" b="1" dirty="0">
-                <a:solidFill>
-                  <a:srgbClr val="0000FF"/>
-                </a:solidFill>
-                <a:sym typeface="Wingdings" panose="05000000000000000000" pitchFamily="2" charset="2"/>
-              </a:rPr>
-              <a:t>R2 × R3</a:t>
+                  <a:srgbClr val="0070C0"/>
+                </a:solidFill>
+              </a:rPr>
+              <a:t>Division by zero</a:t>
             </a:r>
           </a:p>
           <a:p>
             <a:pPr lvl="1"/>
             <a:r>
-              <a:rPr lang="en-US" b="1" dirty="0">
-                <a:solidFill>
-                  <a:srgbClr val="92D050"/>
-                </a:solidFill>
-              </a:rPr>
-              <a:t>U</a:t>
-            </a:r>
-            <a:r>
               <a:rPr lang="en-US" dirty="0">
                 <a:solidFill>
-                  <a:schemeClr val="tx1"/>
-                </a:solidFill>
-              </a:rPr>
-              <a:t>MLAL	R0,R1,</a:t>
-            </a:r>
-            <a:r>
-              <a:rPr lang="en-US" b="1" dirty="0">
-                <a:solidFill>
-                  <a:srgbClr val="0000FF"/>
-                </a:solidFill>
-              </a:rPr>
-              <a:t>R2,R3</a:t>
-            </a:r>
-            <a:r>
-              <a:rPr lang="en-US" dirty="0">
-                <a:solidFill>
-                  <a:schemeClr val="tx1"/>
-                </a:solidFill>
-              </a:rPr>
-              <a:t>		// R0.R1 </a:t>
-            </a:r>
-            <a:r>
-              <a:rPr lang="en-US" dirty="0">
-                <a:solidFill>
-                  <a:schemeClr val="tx1"/>
-                </a:solidFill>
-                <a:sym typeface="Wingdings" panose="05000000000000000000" pitchFamily="2" charset="2"/>
-              </a:rPr>
-              <a:t>= R0.R1 + </a:t>
-            </a:r>
-            <a:r>
-              <a:rPr lang="en-US" b="1" dirty="0">
-                <a:solidFill>
-                  <a:srgbClr val="0000FF"/>
-                </a:solidFill>
-                <a:sym typeface="Wingdings" panose="05000000000000000000" pitchFamily="2" charset="2"/>
-              </a:rPr>
-              <a:t>R2 × R3</a:t>
-            </a:r>
-          </a:p>
-          <a:p>
-            <a:endParaRPr lang="en-US" dirty="0"/>
-          </a:p>
-          <a:p>
-            <a:r>
-              <a:rPr lang="en-US" dirty="0">
-                <a:solidFill>
-                  <a:schemeClr val="tx1"/>
-                </a:solidFill>
-              </a:rPr>
-              <a:t>Flags:</a:t>
-            </a:r>
-            <a:r>
-              <a:rPr lang="en-US" dirty="0"/>
-              <a:t>      </a:t>
-            </a:r>
-            <a:r>
-              <a:rPr lang="en-US" b="1" dirty="0">
-                <a:solidFill>
-                  <a:srgbClr val="FF0000"/>
-                </a:solidFill>
-              </a:rPr>
-              <a:t>Unaffected!</a:t>
-            </a:r>
-          </a:p>
-          <a:p>
-            <a:r>
-              <a:rPr lang="en-US" dirty="0">
-                <a:solidFill>
-                  <a:schemeClr val="tx1"/>
-                </a:solidFill>
-              </a:rPr>
-              <a:t>Overflow: </a:t>
-            </a:r>
-            <a:r>
-              <a:rPr lang="en-US" b="1" dirty="0">
-                <a:solidFill>
-                  <a:srgbClr val="FF0000"/>
-                </a:solidFill>
-              </a:rPr>
-              <a:t>Can’t happen</a:t>
+                  <a:srgbClr val="0070C0"/>
+                </a:solidFill>
+              </a:rPr>
+              <a:t>Full-scale negative divided by -1</a:t>
             </a:r>
           </a:p>
         </p:txBody>
@@ -43802,7 +44103,7 @@
     </p:spTree>
     <p:extLst>
       <p:ext uri="{BB962C8B-B14F-4D97-AF65-F5344CB8AC3E}">
-        <p14:creationId xmlns:p14="http://schemas.microsoft.com/office/powerpoint/2010/main" val="228742505"/>
+        <p14:creationId xmlns:p14="http://schemas.microsoft.com/office/powerpoint/2010/main" val="3769027795"/>
       </p:ext>
     </p:extLst>
   </p:cSld>
@@ -43839,371 +44140,6 @@
             <p:ph type="title"/>
           </p:nvPr>
         </p:nvSpPr>
-        <p:spPr>
-          <a:xfrm>
-            <a:off x="940526" y="745181"/>
-            <a:ext cx="8315769" cy="746735"/>
-          </a:xfrm>
-        </p:spPr>
-        <p:txBody>
-          <a:bodyPr>
-            <a:normAutofit/>
-          </a:bodyPr>
-          <a:lstStyle/>
-          <a:p>
-            <a:r>
-              <a:rPr lang="en-US" dirty="0"/>
-              <a:t>Single-Length 32÷32 Integer Division</a:t>
-            </a:r>
-          </a:p>
-        </p:txBody>
-      </p:sp>
-      <p:sp>
-        <p:nvSpPr>
-          <p:cNvPr id="3" name="Content Placeholder 2"/>
-          <p:cNvSpPr>
-            <a:spLocks noGrp="1"/>
-          </p:cNvSpPr>
-          <p:nvPr>
-            <p:ph idx="1"/>
-          </p:nvPr>
-        </p:nvSpPr>
-        <p:spPr>
-          <a:xfrm>
-            <a:off x="940525" y="1806366"/>
-            <a:ext cx="10409263" cy="4835066"/>
-          </a:xfrm>
-        </p:spPr>
-        <p:txBody>
-          <a:bodyPr>
-            <a:normAutofit fontScale="92500" lnSpcReduction="10000"/>
-          </a:bodyPr>
-          <a:lstStyle/>
-          <a:p>
-            <a:r>
-              <a:rPr lang="en-US" dirty="0">
-                <a:solidFill>
-                  <a:schemeClr val="tx1"/>
-                </a:solidFill>
-              </a:rPr>
-              <a:t>Instructions: </a:t>
-            </a:r>
-            <a:r>
-              <a:rPr lang="en-US" b="1" dirty="0">
-                <a:solidFill>
-                  <a:srgbClr val="FF0000"/>
-                </a:solidFill>
-              </a:rPr>
-              <a:t>S</a:t>
-            </a:r>
-            <a:r>
-              <a:rPr lang="en-US" dirty="0">
-                <a:solidFill>
-                  <a:srgbClr val="0070C0"/>
-                </a:solidFill>
-              </a:rPr>
-              <a:t>DIV</a:t>
-            </a:r>
-            <a:r>
-              <a:rPr lang="en-US" dirty="0">
-                <a:solidFill>
-                  <a:schemeClr val="tx1"/>
-                </a:solidFill>
-              </a:rPr>
-              <a:t>,</a:t>
-            </a:r>
-            <a:r>
-              <a:rPr lang="en-US" dirty="0">
-                <a:solidFill>
-                  <a:srgbClr val="0070C0"/>
-                </a:solidFill>
-              </a:rPr>
-              <a:t> </a:t>
-            </a:r>
-            <a:r>
-              <a:rPr lang="en-US" b="1" dirty="0">
-                <a:solidFill>
-                  <a:srgbClr val="92D050"/>
-                </a:solidFill>
-              </a:rPr>
-              <a:t>U</a:t>
-            </a:r>
-            <a:r>
-              <a:rPr lang="en-US" dirty="0">
-                <a:solidFill>
-                  <a:srgbClr val="0070C0"/>
-                </a:solidFill>
-              </a:rPr>
-              <a:t>DIV</a:t>
-            </a:r>
-          </a:p>
-          <a:p>
-            <a:r>
-              <a:rPr lang="en-US" b="1" dirty="0">
-                <a:solidFill>
-                  <a:srgbClr val="FF0000"/>
-                </a:solidFill>
-              </a:rPr>
-              <a:t>Signed</a:t>
-            </a:r>
-            <a:r>
-              <a:rPr lang="en-US" dirty="0"/>
-              <a:t> </a:t>
-            </a:r>
-            <a:r>
-              <a:rPr lang="en-US" dirty="0">
-                <a:solidFill>
-                  <a:schemeClr val="tx1"/>
-                </a:solidFill>
-              </a:rPr>
-              <a:t>vs.</a:t>
-            </a:r>
-            <a:r>
-              <a:rPr lang="en-US" dirty="0"/>
-              <a:t> </a:t>
-            </a:r>
-            <a:r>
-              <a:rPr lang="en-US" b="1" dirty="0">
-                <a:solidFill>
-                  <a:srgbClr val="92D050"/>
-                </a:solidFill>
-              </a:rPr>
-              <a:t>Unsigned</a:t>
-            </a:r>
-            <a:r>
-              <a:rPr lang="en-US" dirty="0"/>
-              <a:t>: </a:t>
-            </a:r>
-            <a:r>
-              <a:rPr lang="en-US" dirty="0">
-                <a:solidFill>
-                  <a:srgbClr val="0070C0"/>
-                </a:solidFill>
-              </a:rPr>
-              <a:t>Use </a:t>
-            </a:r>
-            <a:r>
-              <a:rPr lang="en-US" dirty="0">
-                <a:solidFill>
-                  <a:srgbClr val="FF0000"/>
-                </a:solidFill>
-              </a:rPr>
-              <a:t>different</a:t>
-            </a:r>
-            <a:r>
-              <a:rPr lang="en-US" dirty="0">
-                <a:solidFill>
-                  <a:srgbClr val="0070C0"/>
-                </a:solidFill>
-              </a:rPr>
-              <a:t> instructions!</a:t>
-            </a:r>
-          </a:p>
-          <a:p>
-            <a:endParaRPr lang="en-US" dirty="0"/>
-          </a:p>
-          <a:p>
-            <a:r>
-              <a:rPr lang="en-US" b="1" dirty="0">
-                <a:solidFill>
-                  <a:srgbClr val="FF0000"/>
-                </a:solidFill>
-              </a:rPr>
-              <a:t>Signed</a:t>
-            </a:r>
-            <a:r>
-              <a:rPr lang="en-US" dirty="0"/>
-              <a:t> </a:t>
-            </a:r>
-            <a:r>
-              <a:rPr lang="en-US" dirty="0">
-                <a:solidFill>
-                  <a:schemeClr val="tx1"/>
-                </a:solidFill>
-              </a:rPr>
-              <a:t>Instruction Format:</a:t>
-            </a:r>
-          </a:p>
-          <a:p>
-            <a:pPr lvl="1"/>
-            <a:r>
-              <a:rPr lang="en-US" b="1" dirty="0">
-                <a:solidFill>
-                  <a:srgbClr val="FF0000"/>
-                </a:solidFill>
-              </a:rPr>
-              <a:t>S</a:t>
-            </a:r>
-            <a:r>
-              <a:rPr lang="en-US" dirty="0">
-                <a:solidFill>
-                  <a:srgbClr val="0070C0"/>
-                </a:solidFill>
-              </a:rPr>
-              <a:t>DIV	R0,R1,R2		// R0 </a:t>
-            </a:r>
-            <a:r>
-              <a:rPr lang="en-US" dirty="0">
-                <a:solidFill>
-                  <a:srgbClr val="0070C0"/>
-                </a:solidFill>
-                <a:sym typeface="Wingdings" panose="05000000000000000000" pitchFamily="2" charset="2"/>
-              </a:rPr>
-              <a:t>= R1 ÷ R2</a:t>
-            </a:r>
-          </a:p>
-          <a:p>
-            <a:r>
-              <a:rPr lang="en-US" b="1" dirty="0">
-                <a:solidFill>
-                  <a:srgbClr val="92D050"/>
-                </a:solidFill>
-              </a:rPr>
-              <a:t>Unsigned</a:t>
-            </a:r>
-            <a:r>
-              <a:rPr lang="en-US" dirty="0"/>
-              <a:t> </a:t>
-            </a:r>
-            <a:r>
-              <a:rPr lang="en-US" dirty="0">
-                <a:solidFill>
-                  <a:schemeClr val="tx1"/>
-                </a:solidFill>
-              </a:rPr>
-              <a:t>Instruction Format:</a:t>
-            </a:r>
-          </a:p>
-          <a:p>
-            <a:pPr lvl="1"/>
-            <a:r>
-              <a:rPr lang="en-US" b="1" dirty="0">
-                <a:solidFill>
-                  <a:srgbClr val="92D050"/>
-                </a:solidFill>
-              </a:rPr>
-              <a:t>U</a:t>
-            </a:r>
-            <a:r>
-              <a:rPr lang="en-US" dirty="0">
-                <a:solidFill>
-                  <a:srgbClr val="0070C0"/>
-                </a:solidFill>
-              </a:rPr>
-              <a:t>DIV	R0,R1,R2		// R0 </a:t>
-            </a:r>
-            <a:r>
-              <a:rPr lang="en-US" dirty="0">
-                <a:solidFill>
-                  <a:srgbClr val="0070C0"/>
-                </a:solidFill>
-                <a:sym typeface="Wingdings" panose="05000000000000000000" pitchFamily="2" charset="2"/>
-              </a:rPr>
-              <a:t>= R1 ÷ R2</a:t>
-            </a:r>
-          </a:p>
-          <a:p>
-            <a:endParaRPr lang="en-US" dirty="0"/>
-          </a:p>
-          <a:p>
-            <a:r>
-              <a:rPr lang="en-US" dirty="0">
-                <a:solidFill>
-                  <a:schemeClr val="tx1"/>
-                </a:solidFill>
-              </a:rPr>
-              <a:t>Flags:</a:t>
-            </a:r>
-            <a:r>
-              <a:rPr lang="en-US" dirty="0"/>
-              <a:t> </a:t>
-            </a:r>
-            <a:r>
-              <a:rPr lang="en-US" b="1" dirty="0">
-                <a:solidFill>
-                  <a:srgbClr val="FF0000"/>
-                </a:solidFill>
-              </a:rPr>
-              <a:t>Unaffected</a:t>
-            </a:r>
-          </a:p>
-          <a:p>
-            <a:endParaRPr lang="en-US" dirty="0"/>
-          </a:p>
-          <a:p>
-            <a:r>
-              <a:rPr lang="en-US" dirty="0">
-                <a:solidFill>
-                  <a:schemeClr val="tx1"/>
-                </a:solidFill>
-              </a:rPr>
-              <a:t>Overflow:</a:t>
-            </a:r>
-          </a:p>
-          <a:p>
-            <a:pPr lvl="1"/>
-            <a:r>
-              <a:rPr lang="en-US" dirty="0">
-                <a:solidFill>
-                  <a:srgbClr val="0070C0"/>
-                </a:solidFill>
-              </a:rPr>
-              <a:t>Division by zero</a:t>
-            </a:r>
-          </a:p>
-          <a:p>
-            <a:pPr lvl="1"/>
-            <a:r>
-              <a:rPr lang="en-US" dirty="0">
-                <a:solidFill>
-                  <a:srgbClr val="0070C0"/>
-                </a:solidFill>
-              </a:rPr>
-              <a:t>Full-scale negative divided by -1</a:t>
-            </a:r>
-          </a:p>
-        </p:txBody>
-      </p:sp>
-    </p:spTree>
-    <p:extLst>
-      <p:ext uri="{BB962C8B-B14F-4D97-AF65-F5344CB8AC3E}">
-        <p14:creationId xmlns:p14="http://schemas.microsoft.com/office/powerpoint/2010/main" val="3769027795"/>
-      </p:ext>
-    </p:extLst>
-  </p:cSld>
-  <p:clrMapOvr>
-    <a:masterClrMapping/>
-  </p:clrMapOvr>
-</p:sld>
-</file>
-
-<file path=ppt/slides/slide38.xml><?xml version="1.0" encoding="utf-8"?>
-<p:sld xmlns:a="http://schemas.openxmlformats.org/drawingml/2006/main" xmlns:r="http://schemas.openxmlformats.org/officeDocument/2006/relationships" xmlns:p="http://schemas.openxmlformats.org/presentationml/2006/main">
-  <p:cSld>
-    <p:spTree>
-      <p:nvGrpSpPr>
-        <p:cNvPr id="1" name=""/>
-        <p:cNvGrpSpPr/>
-        <p:nvPr/>
-      </p:nvGrpSpPr>
-      <p:grpSpPr>
-        <a:xfrm>
-          <a:off x="0" y="0"/>
-          <a:ext cx="0" cy="0"/>
-          <a:chOff x="0" y="0"/>
-          <a:chExt cx="0" cy="0"/>
-        </a:xfrm>
-      </p:grpSpPr>
-      <p:sp>
-        <p:nvSpPr>
-          <p:cNvPr id="2" name="Title 1"/>
-          <p:cNvSpPr>
-            <a:spLocks noGrp="1"/>
-          </p:cNvSpPr>
-          <p:nvPr>
-            <p:ph type="title"/>
-          </p:nvPr>
-        </p:nvSpPr>
         <p:spPr/>
         <p:txBody>
           <a:bodyPr rtlCol="0">
@@ -44428,6 +44364,70 @@
     <p:extLst>
       <p:ext uri="{BB962C8B-B14F-4D97-AF65-F5344CB8AC3E}">
         <p14:creationId xmlns:p14="http://schemas.microsoft.com/office/powerpoint/2010/main" val="2453586173"/>
+      </p:ext>
+    </p:extLst>
+  </p:cSld>
+  <p:clrMapOvr>
+    <a:masterClrMapping/>
+  </p:clrMapOvr>
+</p:sld>
+</file>
+
+<file path=ppt/slides/slide38.xml><?xml version="1.0" encoding="utf-8"?>
+<p:sld xmlns:a="http://schemas.openxmlformats.org/drawingml/2006/main" xmlns:r="http://schemas.openxmlformats.org/officeDocument/2006/relationships" xmlns:p="http://schemas.openxmlformats.org/presentationml/2006/main">
+  <p:cSld>
+    <p:spTree>
+      <p:nvGrpSpPr>
+        <p:cNvPr id="1" name="">
+          <a:extLst>
+            <a:ext uri="{FF2B5EF4-FFF2-40B4-BE49-F238E27FC236}">
+              <a16:creationId xmlns:a16="http://schemas.microsoft.com/office/drawing/2014/main" id="{84DA25F2-3AE0-BDCF-0880-EDD5EEF55E54}"/>
+            </a:ext>
+          </a:extLst>
+        </p:cNvPr>
+        <p:cNvGrpSpPr/>
+        <p:nvPr/>
+      </p:nvGrpSpPr>
+      <p:grpSpPr>
+        <a:xfrm>
+          <a:off x="0" y="0"/>
+          <a:ext cx="0" cy="0"/>
+          <a:chOff x="0" y="0"/>
+          <a:chExt cx="0" cy="0"/>
+        </a:xfrm>
+      </p:grpSpPr>
+      <p:sp>
+        <p:nvSpPr>
+          <p:cNvPr id="2" name="Title 1">
+            <a:extLst>
+              <a:ext uri="{FF2B5EF4-FFF2-40B4-BE49-F238E27FC236}">
+                <a16:creationId xmlns:a16="http://schemas.microsoft.com/office/drawing/2014/main" id="{6EAE57A2-3A61-C5F8-EEFD-EA2961784338}"/>
+              </a:ext>
+            </a:extLst>
+          </p:cNvPr>
+          <p:cNvSpPr>
+            <a:spLocks noGrp="1"/>
+          </p:cNvSpPr>
+          <p:nvPr>
+            <p:ph type="ctrTitle"/>
+          </p:nvPr>
+        </p:nvSpPr>
+        <p:spPr/>
+        <p:txBody>
+          <a:bodyPr/>
+          <a:lstStyle/>
+          <a:p>
+            <a:r>
+              <a:rPr lang="en-US" dirty="0"/>
+              <a:t>… to here …</a:t>
+            </a:r>
+          </a:p>
+        </p:txBody>
+      </p:sp>
+    </p:spTree>
+    <p:extLst>
+      <p:ext uri="{BB962C8B-B14F-4D97-AF65-F5344CB8AC3E}">
+        <p14:creationId xmlns:p14="http://schemas.microsoft.com/office/powerpoint/2010/main" val="2815624037"/>
       </p:ext>
     </p:extLst>
   </p:cSld>

</xml_diff>